<commit_message>
Lesson sd-10-010: match the deck and its PPTX to the rewritten lesson
Co-Authored-By: Claude Sonnet 5.5 <noreply@anthropic.com>
Claude-Session: https://claude.ai/code/session_01Y9NYFwg4CcDYEWi1zr53gi
</commit_message>
<xml_diff>
--- a/system-design-101/vi/lessons/sd-10-010/slides/sd-10-010.pptx
+++ b/system-design-101/vi/lessons/sd-10-010/slides/sd-10-010.pptx
@@ -1986,7 +1986,51 @@
                 <a:ea typeface="Be Vietnam Pro" pitchFamily="34" charset="-122"/>
                 <a:cs typeface="Be Vietnam Pro" pitchFamily="34" charset="-120"/>
               </a:rPr>
-              <a:t> A</a:t>
+              <a:t> B</a:t>
+            </a:r>
+            <a:r>
+              <a:rPr lang="en-US" sz="2850" dirty="0" spc="-10" kern="0">
+                <a:solidFill>
+                  <a:srgbClr val="C4C8D6"/>
+                </a:solidFill>
+                <a:latin typeface="Be Vietnam Pro" pitchFamily="34" charset="0"/>
+                <a:ea typeface="Be Vietnam Pro" pitchFamily="34" charset="-122"/>
+                <a:cs typeface="Be Vietnam Pro" pitchFamily="34" charset="-120"/>
+              </a:rPr>
+              <a:t> lấy</a:t>
+            </a:r>
+            <a:r>
+              <a:rPr lang="en-US" sz="2850" dirty="0" spc="-1" kern="0">
+                <a:solidFill>
+                  <a:srgbClr val="C4C8D6"/>
+                </a:solidFill>
+                <a:latin typeface="Be Vietnam Pro" pitchFamily="34" charset="0"/>
+                <a:ea typeface="Be Vietnam Pro" pitchFamily="34" charset="-122"/>
+                <a:cs typeface="Be Vietnam Pro" pitchFamily="34" charset="-120"/>
+              </a:rPr>
+              <a:t> từ hàng</a:t>
+            </a:r>
+            <a:r>
+              <a:rPr lang="en-US" sz="2850" dirty="0" spc="15" kern="0">
+                <a:solidFill>
+                  <a:srgbClr val="C4C8D6"/>
+                </a:solidFill>
+                <a:latin typeface="Be Vietnam Pro" pitchFamily="34" charset="0"/>
+                <a:ea typeface="Be Vietnam Pro" pitchFamily="34" charset="-122"/>
+                <a:cs typeface="Be Vietnam Pro" pitchFamily="34" charset="-120"/>
+              </a:rPr>
+              <a:t> đợi</a:t>
+            </a:r>
+            <a:r>
+              <a:rPr lang="en-US" sz="2850" dirty="0" spc="-17" kern="0">
+                <a:solidFill>
+                  <a:srgbClr val="C4C8D6"/>
+                </a:solidFill>
+                <a:latin typeface="Be Vietnam Pro" pitchFamily="34" charset="0"/>
+                <a:ea typeface="Be Vietnam Pro" pitchFamily="34" charset="-122"/>
+                <a:cs typeface="Be Vietnam Pro" pitchFamily="34" charset="-120"/>
+              </a:rPr>
+              <a:t> trống:</a:t>
             </a:r>
             <a:r>
               <a:rPr lang="en-US" sz="2850" dirty="0" spc="12" kern="0">
@@ -1997,10 +2041,10 @@
                 <a:ea typeface="Be Vietnam Pro" pitchFamily="34" charset="-122"/>
                 <a:cs typeface="Be Vietnam Pro" pitchFamily="34" charset="-120"/>
               </a:rPr>
-              <a:t> đang</a:t>
-            </a:r>
-            <a:r>
-              <a:rPr lang="en-US" sz="2850" dirty="0" spc="-1" kern="0">
+              <a:t> đợi,</a:t>
+            </a:r>
+            <a:r>
+              <a:rPr lang="en-US" sz="2850" dirty="0" spc="-9" kern="0">
                 <a:solidFill>
                   <a:srgbClr val="C4C8D6"/>
                 </a:solidFill>
@@ -2008,7 +2052,7 @@
                 <a:ea typeface="Be Vietnam Pro" pitchFamily="34" charset="-122"/>
                 <a:cs typeface="Be Vietnam Pro" pitchFamily="34" charset="-120"/>
               </a:rPr>
-              <a:t> giữ</a:t>
+              <a:t> hay</a:t>
             </a:r>
             <a:r>
               <a:rPr lang="en-US" sz="2850" dirty="0" spc="-2" kern="0">
@@ -2019,10 +2063,10 @@
                 <a:ea typeface="Be Vietnam Pro" pitchFamily="34" charset="-122"/>
                 <a:cs typeface="Be Vietnam Pro" pitchFamily="34" charset="-120"/>
               </a:rPr>
-              <a:t> khóa,</a:t>
-            </a:r>
-            <a:r>
-              <a:rPr lang="en-US" sz="2850" dirty="0" spc="-1" kern="0">
+              <a:t> không</a:t>
+            </a:r>
+            <a:r>
+              <a:rPr lang="en-US" sz="2850" dirty="0" spc="11" kern="0">
                 <a:solidFill>
                   <a:srgbClr val="C4C8D6"/>
                 </a:solidFill>
@@ -2030,117 +2074,7 @@
                 <a:ea typeface="Be Vietnam Pro" pitchFamily="34" charset="-122"/>
                 <a:cs typeface="Be Vietnam Pro" pitchFamily="34" charset="-120"/>
               </a:rPr>
-              <a:t> luồng</a:t>
-            </a:r>
-            <a:r>
-              <a:rPr lang="en-US" sz="2850" dirty="0" spc="1" kern="0">
-                <a:solidFill>
-                  <a:srgbClr val="C4C8D6"/>
-                </a:solidFill>
-                <a:latin typeface="Be Vietnam Pro" pitchFamily="34" charset="0"/>
-                <a:ea typeface="Be Vietnam Pro" pitchFamily="34" charset="-122"/>
-                <a:cs typeface="Be Vietnam Pro" pitchFamily="34" charset="-120"/>
-              </a:rPr>
-              <a:t> B</a:t>
-            </a:r>
-            <a:r>
-              <a:rPr lang="en-US" sz="2850" dirty="0" spc="2" kern="0">
-                <a:solidFill>
-                  <a:srgbClr val="C4C8D6"/>
-                </a:solidFill>
-                <a:latin typeface="Be Vietnam Pro" pitchFamily="34" charset="0"/>
-                <a:ea typeface="Be Vietnam Pro" pitchFamily="34" charset="-122"/>
-                <a:cs typeface="Be Vietnam Pro" pitchFamily="34" charset="-120"/>
-              </a:rPr>
-              <a:t> xin</a:t>
-            </a:r>
-            <a:r>
-              <a:rPr lang="en-US" sz="2850" dirty="0" spc="1" kern="0">
-                <a:solidFill>
-                  <a:srgbClr val="C4C8D6"/>
-                </a:solidFill>
-                <a:latin typeface="Be Vietnam Pro" pitchFamily="34" charset="0"/>
-                <a:ea typeface="Be Vietnam Pro" pitchFamily="34" charset="-122"/>
-                <a:cs typeface="Be Vietnam Pro" pitchFamily="34" charset="-120"/>
-              </a:rPr>
-              <a:t> truy</a:t>
-            </a:r>
-            <a:r>
-              <a:rPr lang="en-US" sz="2850" dirty="0" spc="0" kern="0">
-                <a:solidFill>
-                  <a:srgbClr val="C4C8D6"/>
-                </a:solidFill>
-                <a:latin typeface="Be Vietnam Pro" pitchFamily="34" charset="0"/>
-                <a:ea typeface="Be Vietnam Pro" pitchFamily="34" charset="-122"/>
-                <a:cs typeface="Be Vietnam Pro" pitchFamily="34" charset="-120"/>
-              </a:rPr>
-              <a:t> cập: B phải</a:t>
-            </a:r>
-            <a:r>
-              <a:rPr lang="en-US" sz="2850" dirty="0" spc="15" kern="0">
-                <a:solidFill>
-                  <a:srgbClr val="C4C8D6"/>
-                </a:solidFill>
-                <a:latin typeface="Be Vietnam Pro" pitchFamily="34" charset="0"/>
-                <a:ea typeface="Be Vietnam Pro" pitchFamily="34" charset="-122"/>
-                <a:cs typeface="Be Vietnam Pro" pitchFamily="34" charset="-120"/>
-              </a:rPr>
-              <a:t> đợi</a:t>
-            </a:r>
-            <a:r>
-              <a:rPr lang="en-US" sz="2850" dirty="0" spc="-8" kern="0">
-                <a:solidFill>
-                  <a:srgbClr val="C4C8D6"/>
-                </a:solidFill>
-                <a:latin typeface="Be Vietnam Pro" pitchFamily="34" charset="0"/>
-                <a:ea typeface="Be Vietnam Pro" pitchFamily="34" charset="-122"/>
-                <a:cs typeface="Be Vietnam Pro" pitchFamily="34" charset="-120"/>
-              </a:rPr>
-              <a:t> hay</a:t>
-            </a:r>
-            <a:r>
-              <a:rPr lang="en-US" sz="2850" dirty="0" spc="0" kern="0">
-                <a:solidFill>
-                  <a:srgbClr val="C4C8D6"/>
-                </a:solidFill>
-                <a:latin typeface="Be Vietnam Pro" pitchFamily="34" charset="0"/>
-                <a:ea typeface="Be Vietnam Pro" pitchFamily="34" charset="-122"/>
-                <a:cs typeface="Be Vietnam Pro" pitchFamily="34" charset="-120"/>
-              </a:rPr>
-              <a:t> bị</a:t>
-            </a:r>
-            <a:r>
-              <a:rPr lang="en-US" sz="2850" dirty="0" spc="-1" kern="0">
-                <a:solidFill>
-                  <a:srgbClr val="C4C8D6"/>
-                </a:solidFill>
-                <a:latin typeface="Be Vietnam Pro" pitchFamily="34" charset="0"/>
-                <a:ea typeface="Be Vietnam Pro" pitchFamily="34" charset="-122"/>
-                <a:cs typeface="Be Vietnam Pro" pitchFamily="34" charset="-120"/>
-              </a:rPr>
-              <a:t> từ</a:t>
-            </a:r>
-            <a:r>
-              <a:rPr lang="en-US" sz="2850" dirty="0" spc="0" kern="0">
-                <a:solidFill>
-                  <a:srgbClr val="C4C8D6"/>
-                </a:solidFill>
-                <a:latin typeface="Be Vietnam Pro" pitchFamily="34" charset="0"/>
-                <a:ea typeface="Be Vietnam Pro" pitchFamily="34" charset="-122"/>
-                <a:cs typeface="Be Vietnam Pro" pitchFamily="34" charset="-120"/>
-              </a:rPr>
-              <a:t> chối</a:t>
-            </a:r>
-            <a:r>
-              <a:rPr lang="en-US" sz="2850" dirty="0" spc="-17" kern="0">
-                <a:solidFill>
-                  <a:srgbClr val="C4C8D6"/>
-                </a:solidFill>
-                <a:latin typeface="Be Vietnam Pro" pitchFamily="34" charset="0"/>
-                <a:ea typeface="Be Vietnam Pro" pitchFamily="34" charset="-122"/>
-                <a:cs typeface="Be Vietnam Pro" pitchFamily="34" charset="-120"/>
-              </a:rPr>
-              <a:t> ngay?</a:t>
+              <a:t> đợi?</a:t>
             </a:r>
             <a:endParaRPr lang="en-US" sz="2850" dirty="0"/>
           </a:p>
@@ -2704,6 +2638,28 @@
               <a:t>B</a:t>
             </a:r>
             <a:r>
+              <a:rPr lang="en-US" sz="2550" dirty="0" spc="12" kern="0">
+                <a:solidFill>
+                  <a:srgbClr val="C4C8D6"/>
+                </a:solidFill>
+                <a:latin typeface="Be Vietnam Pro" pitchFamily="34" charset="0"/>
+                <a:ea typeface="Be Vietnam Pro" pitchFamily="34" charset="-122"/>
+                <a:cs typeface="Be Vietnam Pro" pitchFamily="34" charset="-120"/>
+              </a:rPr>
+              <a:t> đợi</a:t>
+            </a:r>
+            <a:r>
+              <a:rPr lang="en-US" sz="2550" dirty="0" spc="-12" kern="0">
+                <a:solidFill>
+                  <a:srgbClr val="C4C8D6"/>
+                </a:solidFill>
+                <a:latin typeface="Be Vietnam Pro" pitchFamily="34" charset="0"/>
+                <a:ea typeface="Be Vietnam Pro" pitchFamily="34" charset="-122"/>
+                <a:cs typeface="Be Vietnam Pro" pitchFamily="34" charset="-120"/>
+              </a:rPr>
+              <a:t> tới</a:t>
+            </a:r>
+            <a:r>
               <a:rPr lang="en-US" sz="2550" dirty="0" spc="0" kern="0">
                 <a:solidFill>
                   <a:srgbClr val="C4C8D6"/>
@@ -2712,10 +2668,10 @@
                 <a:ea typeface="Be Vietnam Pro" pitchFamily="34" charset="-122"/>
                 <a:cs typeface="Be Vietnam Pro" pitchFamily="34" charset="-120"/>
               </a:rPr>
-              <a:t> phải</a:t>
-            </a:r>
-            <a:r>
-              <a:rPr lang="en-US" sz="2550" dirty="0" spc="12" kern="0">
+              <a:t> khi</a:t>
+            </a:r>
+            <a:r>
+              <a:rPr lang="en-US" sz="2550" dirty="0" spc="1" kern="0">
                 <a:solidFill>
                   <a:srgbClr val="C4C8D6"/>
                 </a:solidFill>
@@ -2723,10 +2679,10 @@
                 <a:ea typeface="Be Vietnam Pro" pitchFamily="34" charset="-122"/>
                 <a:cs typeface="Be Vietnam Pro" pitchFamily="34" charset="-120"/>
               </a:rPr>
-              <a:t> đợi</a:t>
-            </a:r>
-            <a:r>
-              <a:rPr lang="en-US" sz="2550" dirty="0" spc="-12" kern="0">
+              <a:t> làm</a:t>
+            </a:r>
+            <a:r>
+              <a:rPr lang="en-US" sz="2550" dirty="0" spc="6" kern="0">
                 <a:solidFill>
                   <a:srgbClr val="C4C8D6"/>
                 </a:solidFill>
@@ -2734,51 +2690,7 @@
                 <a:ea typeface="Be Vietnam Pro" pitchFamily="34" charset="-122"/>
                 <a:cs typeface="Be Vietnam Pro" pitchFamily="34" charset="-120"/>
               </a:rPr>
-              <a:t> tới</a:t>
-            </a:r>
-            <a:r>
-              <a:rPr lang="en-US" sz="2550" dirty="0" spc="-1" kern="0">
-                <a:solidFill>
-                  <a:srgbClr val="C4C8D6"/>
-                </a:solidFill>
-                <a:latin typeface="Be Vietnam Pro" pitchFamily="34" charset="0"/>
-                <a:ea typeface="Be Vietnam Pro" pitchFamily="34" charset="-122"/>
-                <a:cs typeface="Be Vietnam Pro" pitchFamily="34" charset="-120"/>
-              </a:rPr>
-              <a:t> khi</a:t>
-            </a:r>
-            <a:r>
-              <a:rPr lang="en-US" sz="2550" dirty="0" spc="-2" kern="0">
-                <a:solidFill>
-                  <a:srgbClr val="C4C8D6"/>
-                </a:solidFill>
-                <a:latin typeface="Be Vietnam Pro" pitchFamily="34" charset="0"/>
-                <a:ea typeface="Be Vietnam Pro" pitchFamily="34" charset="-122"/>
-                <a:cs typeface="Be Vietnam Pro" pitchFamily="34" charset="-120"/>
-              </a:rPr>
-              <a:t> khóa</a:t>
-            </a:r>
-            <a:r>
-              <a:rPr lang="en-US" sz="2550" dirty="0" spc="6" kern="0">
-                <a:solidFill>
-                  <a:srgbClr val="C4C8D6"/>
-                </a:solidFill>
-                <a:latin typeface="Be Vietnam Pro" pitchFamily="34" charset="0"/>
-                <a:ea typeface="Be Vietnam Pro" pitchFamily="34" charset="-122"/>
-                <a:cs typeface="Be Vietnam Pro" pitchFamily="34" charset="-120"/>
-              </a:rPr>
               <a:t> được</a:t>
-            </a:r>
-            <a:r>
-              <a:rPr lang="en-US" sz="2550" dirty="0" spc="0" kern="0">
-                <a:solidFill>
-                  <a:srgbClr val="C4C8D6"/>
-                </a:solidFill>
-                <a:latin typeface="Be Vietnam Pro" pitchFamily="34" charset="0"/>
-                <a:ea typeface="Be Vietnam Pro" pitchFamily="34" charset="-122"/>
-                <a:cs typeface="Be Vietnam Pro" pitchFamily="34" charset="-120"/>
-              </a:rPr>
-              <a:t> nhả</a:t>
             </a:r>
             <a:endParaRPr lang="en-US" sz="2550" dirty="0"/>
           </a:p>
@@ -2874,7 +2786,7 @@
               <a:buNone/>
             </a:pPr>
             <a:r>
-              <a:rPr lang="en-US" sz="4200" dirty="0" spc="-29" kern="0">
+              <a:rPr lang="en-US" sz="4200" dirty="0" spc="3" kern="0">
                 <a:solidFill>
                   <a:srgbClr val="F3EEE3"/>
                 </a:solidFill>
@@ -2882,10 +2794,10 @@
                 <a:ea typeface="Bricolage Grotesque ExtraBold" pitchFamily="34" charset="-122"/>
                 <a:cs typeface="Bricolage Grotesque ExtraBold" pitchFamily="34" charset="-120"/>
               </a:rPr>
-              <a:t>Từ</a:t>
-            </a:r>
-            <a:r>
-              <a:rPr lang="en-US" sz="4200" dirty="0" spc="-2" kern="0">
+              <a:t>Thua</a:t>
+            </a:r>
+            <a:r>
+              <a:rPr lang="en-US" sz="4200" dirty="0" spc="-14" kern="0">
                 <a:solidFill>
                   <a:srgbClr val="F3EEE3"/>
                 </a:solidFill>
@@ -2893,10 +2805,10 @@
                 <a:ea typeface="Bricolage Grotesque ExtraBold" pitchFamily="34" charset="-122"/>
                 <a:cs typeface="Bricolage Grotesque ExtraBold" pitchFamily="34" charset="-120"/>
               </a:rPr>
-              <a:t> chối</a:t>
-            </a:r>
-            <a:r>
-              <a:rPr lang="en-US" sz="4200" dirty="0" spc="-5" kern="0">
+              <a:t> thì</a:t>
+            </a:r>
+            <a:r>
+              <a:rPr lang="en-US" sz="4200" dirty="0" spc="0" kern="0">
                 <a:solidFill>
                   <a:srgbClr val="F3EEE3"/>
                 </a:solidFill>
@@ -2904,7 +2816,7 @@
                 <a:ea typeface="Bricolage Grotesque ExtraBold" pitchFamily="34" charset="-122"/>
                 <a:cs typeface="Bricolage Grotesque ExtraBold" pitchFamily="34" charset="-120"/>
               </a:rPr>
-              <a:t> ngay</a:t>
+              <a:t> thử lại</a:t>
             </a:r>
             <a:endParaRPr lang="en-US" sz="4200" dirty="0"/>
           </a:p>
@@ -3317,7 +3229,7 @@
               <a:buNone/>
             </a:pPr>
             <a:r>
-              <a:rPr lang="en-US" sz="2550" dirty="0" spc="6" kern="0">
+              <a:rPr lang="en-US" sz="2550" dirty="0" spc="-13" kern="0">
                 <a:solidFill>
                   <a:srgbClr val="C4C8D6"/>
                 </a:solidFill>
@@ -3325,10 +3237,10 @@
                 <a:ea typeface="Be Vietnam Pro" pitchFamily="34" charset="-122"/>
                 <a:cs typeface="Be Vietnam Pro" pitchFamily="34" charset="-120"/>
               </a:rPr>
-              <a:t>B</a:t>
-            </a:r>
-            <a:r>
-              <a:rPr lang="en-US" sz="2550" dirty="0" spc="7" kern="0">
+              <a:t>Luồng</a:t>
+            </a:r>
+            <a:r>
+              <a:rPr lang="en-US" sz="2550" dirty="0" spc="1" kern="0">
                 <a:solidFill>
                   <a:srgbClr val="C4C8D6"/>
                 </a:solidFill>
@@ -3336,10 +3248,10 @@
                 <a:ea typeface="Be Vietnam Pro" pitchFamily="34" charset="-122"/>
                 <a:cs typeface="Be Vietnam Pro" pitchFamily="34" charset="-120"/>
               </a:rPr>
-              <a:t> được</a:t>
-            </a:r>
-            <a:r>
-              <a:rPr lang="en-US" sz="2550" dirty="0" spc="-3" kern="0">
+              <a:t> thua</a:t>
+            </a:r>
+            <a:r>
+              <a:rPr lang="en-US" sz="2550" dirty="0" spc="-39" kern="0">
                 <a:solidFill>
                   <a:srgbClr val="C4C8D6"/>
                 </a:solidFill>
@@ -3347,10 +3259,10 @@
                 <a:ea typeface="Be Vietnam Pro" pitchFamily="34" charset="-122"/>
                 <a:cs typeface="Be Vietnam Pro" pitchFamily="34" charset="-120"/>
               </a:rPr>
-              <a:t> báo</a:t>
-            </a:r>
-            <a:r>
-              <a:rPr lang="en-US" sz="2550" dirty="0" spc="-16" kern="0">
+              <a:t> CAS</a:t>
+            </a:r>
+            <a:r>
+              <a:rPr lang="en-US" sz="2550" dirty="0" spc="10" kern="0">
                 <a:solidFill>
                   <a:srgbClr val="C4C8D6"/>
                 </a:solidFill>
@@ -3358,7 +3270,18 @@
                 <a:ea typeface="Be Vietnam Pro" pitchFamily="34" charset="-122"/>
                 <a:cs typeface="Be Vietnam Pro" pitchFamily="34" charset="-120"/>
               </a:rPr>
-              <a:t> ngay,</a:t>
+              <a:t> đọc</a:t>
+            </a:r>
+            <a:r>
+              <a:rPr lang="en-US" sz="2550" dirty="0" spc="-1" kern="0">
+                <a:solidFill>
+                  <a:srgbClr val="C4C8D6"/>
+                </a:solidFill>
+                <a:latin typeface="Be Vietnam Pro" pitchFamily="34" charset="0"/>
+                <a:ea typeface="Be Vietnam Pro" pitchFamily="34" charset="-122"/>
+                <a:cs typeface="Be Vietnam Pro" pitchFamily="34" charset="-120"/>
+              </a:rPr>
+              <a:t> lại,</a:t>
             </a:r>
             <a:r>
               <a:rPr lang="en-US" sz="2550" dirty="0" spc="0" kern="0">
@@ -3369,10 +3292,10 @@
                 <a:ea typeface="Be Vietnam Pro" pitchFamily="34" charset="-122"/>
                 <a:cs typeface="Be Vietnam Pro" pitchFamily="34" charset="-120"/>
               </a:rPr>
-              <a:t> tự</a:t>
-            </a:r>
-            <a:r>
-              <a:rPr lang="en-US" sz="2550" dirty="0" spc="-18" kern="0">
+              <a:t> thử</a:t>
+            </a:r>
+            <a:r>
+              <a:rPr lang="en-US" sz="2550" dirty="0" spc="1" kern="0">
                 <a:solidFill>
                   <a:srgbClr val="C4C8D6"/>
                 </a:solidFill>
@@ -3380,29 +3303,7 @@
                 <a:ea typeface="Be Vietnam Pro" pitchFamily="34" charset="-122"/>
                 <a:cs typeface="Be Vietnam Pro" pitchFamily="34" charset="-120"/>
               </a:rPr>
-              <a:t> quyết</a:t>
-            </a:r>
-            <a:r>
-              <a:rPr lang="en-US" sz="2550" dirty="0" spc="2" kern="0">
-                <a:solidFill>
-                  <a:srgbClr val="C4C8D6"/>
-                </a:solidFill>
-                <a:latin typeface="Be Vietnam Pro" pitchFamily="34" charset="0"/>
-                <a:ea typeface="Be Vietnam Pro" pitchFamily="34" charset="-122"/>
-                <a:cs typeface="Be Vietnam Pro" pitchFamily="34" charset="-120"/>
-              </a:rPr>
-              <a:t> làm</a:t>
-            </a:r>
-            <a:r>
-              <a:rPr lang="en-US" sz="2550" dirty="0" spc="1" kern="0">
-                <a:solidFill>
-                  <a:srgbClr val="C4C8D6"/>
-                </a:solidFill>
-                <a:latin typeface="Be Vietnam Pro" pitchFamily="34" charset="0"/>
-                <a:ea typeface="Be Vietnam Pro" pitchFamily="34" charset="-122"/>
-                <a:cs typeface="Be Vietnam Pro" pitchFamily="34" charset="-120"/>
-              </a:rPr>
-              <a:t> gì tiếp</a:t>
+              <a:t> tiếp</a:t>
             </a:r>
             <a:endParaRPr lang="en-US" sz="2550" dirty="0"/>
           </a:p>
@@ -4554,7 +4455,18 @@
                 <a:ea typeface="Be Vietnam Pro" pitchFamily="34" charset="-122"/>
                 <a:cs typeface="Be Vietnam Pro" pitchFamily="34" charset="-120"/>
               </a:rPr>
-              <a:t> 2026-10-18.</a:t>
+              <a:t> 2026-10-19.</a:t>
+            </a:r>
+            <a:r>
+              <a:rPr lang="en-US" sz="2250" dirty="0" spc="0" kern="0">
+                <a:solidFill>
+                  <a:srgbClr val="F3EEE3"/>
+                </a:solidFill>
+                <a:latin typeface="Be Vietnam Pro" pitchFamily="34" charset="0"/>
+                <a:ea typeface="Be Vietnam Pro" pitchFamily="34" charset="-122"/>
+                <a:cs typeface="Be Vietnam Pro" pitchFamily="34" charset="-120"/>
+              </a:rPr>
+              <a:t> Hình</a:t>
             </a:r>
             <a:r>
               <a:rPr lang="en-US" sz="2250" dirty="0" spc="-1" kern="0">
@@ -4565,7 +4477,7 @@
                 <a:ea typeface="Be Vietnam Pro" pitchFamily="34" charset="-122"/>
                 <a:cs typeface="Be Vietnam Pro" pitchFamily="34" charset="-120"/>
               </a:rPr>
-              <a:t> Hình minh</a:t>
+              <a:t> minh</a:t>
             </a:r>
             <a:r>
               <a:rPr lang="en-US" sz="2250" dirty="0" spc="-2" kern="0">
@@ -4579,7 +4491,7 @@
               <a:t> họa</a:t>
             </a:r>
             <a:r>
-              <a:rPr lang="en-US" sz="2250" dirty="0" spc="0" kern="0">
+              <a:rPr lang="en-US" sz="2250" dirty="0" spc="-1" kern="0">
                 <a:solidFill>
                   <a:srgbClr val="F3EEE3"/>
                 </a:solidFill>
@@ -4590,7 +4502,7 @@
               <a:t> là</a:t>
             </a:r>
             <a:r>
-              <a:rPr lang="en-US" sz="2250" dirty="0" spc="-5" kern="0">
+              <a:rPr lang="en-US" sz="2250" dirty="0" spc="-4" kern="0">
                 <a:solidFill>
                   <a:srgbClr val="F3EEE3"/>
                 </a:solidFill>
@@ -4601,7 +4513,7 @@
               <a:t> thiết</a:t>
             </a:r>
             <a:r>
-              <a:rPr lang="en-US" sz="2250" dirty="0" spc="-34" kern="0">
+              <a:rPr lang="en-US" sz="2250" dirty="0" spc="-35" kern="0">
                 <a:solidFill>
                   <a:srgbClr val="F3EEE3"/>
                 </a:solidFill>
@@ -4612,7 +4524,7 @@
               <a:t> kế</a:t>
             </a:r>
             <a:r>
-              <a:rPr lang="en-US" sz="2250" dirty="0" spc="2" kern="0">
+              <a:rPr lang="en-US" sz="2250" dirty="0" spc="1" kern="0">
                 <a:solidFill>
                   <a:srgbClr val="F3EEE3"/>
                 </a:solidFill>
@@ -5117,6 +5029,28 @@
               <a:buNone/>
             </a:pPr>
             <a:r>
+              <a:rPr lang="en-US" sz="2100" dirty="0" spc="-60" kern="0">
+                <a:solidFill>
+                  <a:srgbClr val="C4C8D6"/>
+                </a:solidFill>
+                <a:latin typeface="Be Vietnam Pro" pitchFamily="34" charset="0"/>
+                <a:ea typeface="Be Vietnam Pro" pitchFamily="34" charset="-122"/>
+                <a:cs typeface="Be Vietnam Pro" pitchFamily="34" charset="-120"/>
+              </a:rPr>
+              <a:t>Tên</a:t>
+            </a:r>
+            <a:r>
+              <a:rPr lang="en-US" sz="2100" dirty="0" spc="-2" kern="0">
+                <a:solidFill>
+                  <a:srgbClr val="C4C8D6"/>
+                </a:solidFill>
+                <a:latin typeface="Be Vietnam Pro" pitchFamily="34" charset="0"/>
+                <a:ea typeface="Be Vietnam Pro" pitchFamily="34" charset="-122"/>
+                <a:cs typeface="Be Vietnam Pro" pitchFamily="34" charset="-120"/>
+              </a:rPr>
+              <a:t> các</a:t>
+            </a:r>
+            <a:r>
               <a:rPr lang="en-US" sz="2100" dirty="0" spc="0" kern="0">
                 <a:solidFill>
                   <a:srgbClr val="C4C8D6"/>
@@ -5125,10 +5059,10 @@
                 <a:ea typeface="Be Vietnam Pro" pitchFamily="34" charset="-122"/>
                 <a:cs typeface="Be Vietnam Pro" pitchFamily="34" charset="-120"/>
               </a:rPr>
-              <a:t>Chặn</a:t>
-            </a:r>
-            <a:r>
-              <a:rPr lang="en-US" sz="2100" dirty="0" spc="-17" kern="0">
+              <a:t> khái</a:t>
+            </a:r>
+            <a:r>
+              <a:rPr lang="en-US" sz="2100" dirty="0" spc="1" kern="0">
                 <a:solidFill>
                   <a:srgbClr val="C4C8D6"/>
                 </a:solidFill>
@@ -5136,51 +5070,7 @@
                 <a:ea typeface="Be Vietnam Pro" pitchFamily="34" charset="-122"/>
                 <a:cs typeface="Be Vietnam Pro" pitchFamily="34" charset="-120"/>
               </a:rPr>
-              <a:t> và</a:t>
-            </a:r>
-            <a:r>
-              <a:rPr lang="en-US" sz="2100" dirty="0" spc="-1" kern="0">
-                <a:solidFill>
-                  <a:srgbClr val="C4C8D6"/>
-                </a:solidFill>
-                <a:latin typeface="Be Vietnam Pro" pitchFamily="34" charset="0"/>
-                <a:ea typeface="Be Vietnam Pro" pitchFamily="34" charset="-122"/>
-                <a:cs typeface="Be Vietnam Pro" pitchFamily="34" charset="-120"/>
-              </a:rPr>
-              <a:t> không chặn,</a:t>
-            </a:r>
-            <a:r>
-              <a:rPr lang="en-US" sz="2100" dirty="0" spc="-9" kern="0">
-                <a:solidFill>
-                  <a:srgbClr val="C4C8D6"/>
-                </a:solidFill>
-                <a:latin typeface="Be Vietnam Pro" pitchFamily="34" charset="0"/>
-                <a:ea typeface="Be Vietnam Pro" pitchFamily="34" charset="-122"/>
-                <a:cs typeface="Be Vietnam Pro" pitchFamily="34" charset="-120"/>
-              </a:rPr>
-              <a:t> bỏ</a:t>
-            </a:r>
-            <a:r>
-              <a:rPr lang="en-US" sz="2100" dirty="0" spc="8" kern="0">
-                <a:solidFill>
-                  <a:srgbClr val="C4C8D6"/>
-                </a:solidFill>
-                <a:latin typeface="Be Vietnam Pro" pitchFamily="34" charset="0"/>
-                <a:ea typeface="Be Vietnam Pro" pitchFamily="34" charset="-122"/>
-                <a:cs typeface="Be Vietnam Pro" pitchFamily="34" charset="-120"/>
-              </a:rPr>
-              <a:t> đói,</a:t>
-            </a:r>
-            <a:r>
-              <a:rPr lang="en-US" sz="2100" dirty="0" spc="-14" kern="0">
-                <a:solidFill>
-                  <a:srgbClr val="C4C8D6"/>
-                </a:solidFill>
-                <a:latin typeface="Be Vietnam Pro" pitchFamily="34" charset="0"/>
-                <a:ea typeface="Be Vietnam Pro" pitchFamily="34" charset="-122"/>
-                <a:cs typeface="Be Vietnam Pro" pitchFamily="34" charset="-120"/>
-              </a:rPr>
-              <a:t> wait-free,</a:t>
+              <a:t> niệm:</a:t>
             </a:r>
             <a:endParaRPr lang="en-US" sz="2100" dirty="0"/>
           </a:p>
@@ -5192,7 +5082,7 @@
               <a:buNone/>
             </a:pPr>
             <a:r>
-              <a:rPr lang="en-US" sz="2100" dirty="0" spc="-33" kern="0">
+              <a:rPr lang="en-US" sz="2100" dirty="0" spc="0" kern="0">
                 <a:solidFill>
                   <a:srgbClr val="C4C8D6"/>
                 </a:solidFill>
@@ -5200,7 +5090,7 @@
                 <a:ea typeface="Be Vietnam Pro" pitchFamily="34" charset="-122"/>
                 <a:cs typeface="Be Vietnam Pro" pitchFamily="34" charset="-120"/>
               </a:rPr>
-              <a:t>CAS,</a:t>
+              <a:t>chặn,</a:t>
             </a:r>
             <a:r>
               <a:rPr lang="en-US" sz="2100" dirty="0" spc="-1" kern="0">
@@ -5211,10 +5101,10 @@
                 <a:ea typeface="Be Vietnam Pro" pitchFamily="34" charset="-122"/>
                 <a:cs typeface="Be Vietnam Pro" pitchFamily="34" charset="-120"/>
               </a:rPr>
-              <a:t> hai</a:t>
-            </a:r>
-            <a:r>
-              <a:rPr lang="en-US" sz="2100" dirty="0" spc="-2" kern="0">
+              <a:t> không chặn,</a:t>
+            </a:r>
+            <a:r>
+              <a:rPr lang="en-US" sz="2100" dirty="0" spc="-14" kern="0">
                 <a:solidFill>
                   <a:srgbClr val="C4C8D6"/>
                 </a:solidFill>
@@ -5222,10 +5112,10 @@
                 <a:ea typeface="Be Vietnam Pro" pitchFamily="34" charset="-122"/>
                 <a:cs typeface="Be Vietnam Pro" pitchFamily="34" charset="-120"/>
               </a:rPr>
-              <a:t> lợi</a:t>
-            </a:r>
-            <a:r>
-              <a:rPr lang="en-US" sz="2100" dirty="0" spc="0" kern="0">
+              <a:t> wait-free,</a:t>
+            </a:r>
+            <a:r>
+              <a:rPr lang="en-US" sz="2100" dirty="0" spc="-27" kern="0">
                 <a:solidFill>
                   <a:srgbClr val="C4C8D6"/>
                 </a:solidFill>
@@ -5233,7 +5123,7 @@
                 <a:ea typeface="Be Vietnam Pro" pitchFamily="34" charset="-122"/>
                 <a:cs typeface="Be Vietnam Pro" pitchFamily="34" charset="-120"/>
               </a:rPr>
-              <a:t> ích.</a:t>
+              <a:t> CAS.</a:t>
             </a:r>
             <a:endParaRPr lang="en-US" sz="2100" dirty="0"/>
           </a:p>
@@ -6360,26 +6250,15 @@
               <a:buNone/>
             </a:pPr>
             <a:r>
-              <a:rPr lang="en-US" sz="3600" b="1" dirty="0" spc="-15" kern="0">
-                <a:solidFill>
-                  <a:srgbClr val="F3EEE3"/>
-                </a:solidFill>
-                <a:latin typeface="Be Vietnam Pro" pitchFamily="34" charset="0"/>
-                <a:ea typeface="Be Vietnam Pro" pitchFamily="34" charset="-122"/>
-                <a:cs typeface="Be Vietnam Pro" pitchFamily="34" charset="-120"/>
-              </a:rPr>
-              <a:t>không</a:t>
-            </a:r>
-            <a:r>
-              <a:rPr lang="en-US" sz="3600" b="1" dirty="0" spc="-6" kern="0">
-                <a:solidFill>
-                  <a:srgbClr val="F3EEE3"/>
-                </a:solidFill>
-                <a:latin typeface="Be Vietnam Pro" pitchFamily="34" charset="0"/>
-                <a:ea typeface="Be Vietnam Pro" pitchFamily="34" charset="-122"/>
-                <a:cs typeface="Be Vietnam Pro" pitchFamily="34" charset="-120"/>
-              </a:rPr>
-              <a:t> chờ</a:t>
+              <a:rPr lang="en-US" sz="3600" b="1" dirty="0" spc="-22" kern="0">
+                <a:solidFill>
+                  <a:srgbClr val="F3EEE3"/>
+                </a:solidFill>
+                <a:latin typeface="Be Vietnam Pro" pitchFamily="34" charset="0"/>
+                <a:ea typeface="Be Vietnam Pro" pitchFamily="34" charset="-122"/>
+                <a:cs typeface="Be Vietnam Pro" pitchFamily="34" charset="-120"/>
+              </a:rPr>
+              <a:t>wait-free</a:t>
             </a:r>
             <a:endParaRPr lang="en-US" sz="3600" dirty="0"/>
           </a:p>
@@ -7363,7 +7242,7 @@
               <a:buNone/>
             </a:pPr>
             <a:r>
-              <a:rPr lang="en-US" sz="2550" dirty="0" spc="2" kern="0">
+              <a:rPr lang="en-US" sz="2550" dirty="0" spc="-6" kern="0">
                 <a:solidFill>
                   <a:srgbClr val="C4C8D6"/>
                 </a:solidFill>
@@ -7371,10 +7250,10 @@
                 <a:ea typeface="Be Vietnam Pro" pitchFamily="34" charset="-122"/>
                 <a:cs typeface="Be Vietnam Pro" pitchFamily="34" charset="-120"/>
               </a:rPr>
-              <a:t>A</a:t>
-            </a:r>
-            <a:r>
-              <a:rPr lang="en-US" sz="2550" dirty="0" spc="-9" kern="0">
+              <a:t>LinkedBlockingQueue</a:t>
+            </a:r>
+            <a:r>
+              <a:rPr lang="en-US" sz="2550" dirty="0" spc="0" kern="0">
                 <a:solidFill>
                   <a:srgbClr val="C4C8D6"/>
                 </a:solidFill>
@@ -7382,7 +7261,29 @@
                 <a:ea typeface="Be Vietnam Pro" pitchFamily="34" charset="-122"/>
                 <a:cs typeface="Be Vietnam Pro" pitchFamily="34" charset="-120"/>
               </a:rPr>
-              <a:t> lấy</a:t>
+              <a:t> có</a:t>
+            </a:r>
+            <a:r>
+              <a:rPr lang="en-US" sz="2550" dirty="0" spc="-1" kern="0">
+                <a:solidFill>
+                  <a:srgbClr val="C4C8D6"/>
+                </a:solidFill>
+                <a:latin typeface="Be Vietnam Pro" pitchFamily="34" charset="0"/>
+                <a:ea typeface="Be Vietnam Pro" pitchFamily="34" charset="-122"/>
+                <a:cs typeface="Be Vietnam Pro" pitchFamily="34" charset="-120"/>
+              </a:rPr>
+              <a:t> hai khóa:</a:t>
+            </a:r>
+            <a:r>
+              <a:rPr lang="en-US" sz="2550" dirty="0" spc="0" kern="0">
+                <a:solidFill>
+                  <a:srgbClr val="C4C8D6"/>
+                </a:solidFill>
+                <a:latin typeface="Be Vietnam Pro" pitchFamily="34" charset="0"/>
+                <a:ea typeface="Be Vietnam Pro" pitchFamily="34" charset="-122"/>
+                <a:cs typeface="Be Vietnam Pro" pitchFamily="34" charset="-120"/>
+              </a:rPr>
+              <a:t> cần</a:t>
             </a:r>
             <a:r>
               <a:rPr lang="en-US" sz="2550" dirty="0" spc="-3" kern="0">
@@ -7396,7 +7297,7 @@
               <a:t> khóa</a:t>
             </a:r>
             <a:r>
-              <a:rPr lang="en-US" sz="2550" dirty="0" spc="6" kern="0">
+              <a:rPr lang="en-US" sz="2550" dirty="0" spc="11" kern="0">
                 <a:solidFill>
                   <a:srgbClr val="C4C8D6"/>
                 </a:solidFill>
@@ -7404,10 +7305,10 @@
                 <a:ea typeface="Be Vietnam Pro" pitchFamily="34" charset="-122"/>
                 <a:cs typeface="Be Vietnam Pro" pitchFamily="34" charset="-120"/>
               </a:rPr>
-              <a:t> trước.</a:t>
-            </a:r>
-            <a:r>
-              <a:rPr lang="en-US" sz="2550" dirty="0" spc="3" kern="0">
+              <a:t> đang</a:t>
+            </a:r>
+            <a:r>
+              <a:rPr lang="en-US" sz="2550" dirty="0" spc="0" kern="0">
                 <a:solidFill>
                   <a:srgbClr val="C4C8D6"/>
                 </a:solidFill>
@@ -7415,7 +7316,29 @@
                 <a:ea typeface="Be Vietnam Pro" pitchFamily="34" charset="-122"/>
                 <a:cs typeface="Be Vietnam Pro" pitchFamily="34" charset="-120"/>
               </a:rPr>
-              <a:t> Nếu</a:t>
+              <a:t> bị</a:t>
+            </a:r>
+            <a:r>
+              <a:rPr lang="en-US" sz="2550" dirty="0" spc="-1" kern="0">
+                <a:solidFill>
+                  <a:srgbClr val="C4C8D6"/>
+                </a:solidFill>
+                <a:latin typeface="Be Vietnam Pro" pitchFamily="34" charset="0"/>
+                <a:ea typeface="Be Vietnam Pro" pitchFamily="34" charset="-122"/>
+                <a:cs typeface="Be Vietnam Pro" pitchFamily="34" charset="-120"/>
+              </a:rPr>
+              <a:t> giữ</a:t>
+            </a:r>
+            <a:r>
+              <a:rPr lang="en-US" sz="2550" dirty="0" spc="1" kern="0">
+                <a:solidFill>
+                  <a:srgbClr val="C4C8D6"/>
+                </a:solidFill>
+                <a:latin typeface="Be Vietnam Pro" pitchFamily="34" charset="0"/>
+                <a:ea typeface="Be Vietnam Pro" pitchFamily="34" charset="-122"/>
+                <a:cs typeface="Be Vietnam Pro" pitchFamily="34" charset="-120"/>
+              </a:rPr>
+              <a:t> thì</a:t>
             </a:r>
             <a:r>
               <a:rPr lang="en-US" sz="2550" dirty="0" spc="0" kern="0">
@@ -7426,10 +7349,10 @@
                 <a:ea typeface="Be Vietnam Pro" pitchFamily="34" charset="-122"/>
                 <a:cs typeface="Be Vietnam Pro" pitchFamily="34" charset="-120"/>
               </a:rPr>
-              <a:t> A</a:t>
-            </a:r>
-            <a:r>
-              <a:rPr lang="en-US" sz="2550" dirty="0" spc="1" kern="0">
+              <a:t> phải</a:t>
+            </a:r>
+            <a:r>
+              <a:rPr lang="en-US" sz="2550" dirty="0" spc="11" kern="0">
                 <a:solidFill>
                   <a:srgbClr val="C4C8D6"/>
                 </a:solidFill>
@@ -7437,95 +7360,7 @@
                 <a:ea typeface="Be Vietnam Pro" pitchFamily="34" charset="-122"/>
                 <a:cs typeface="Be Vietnam Pro" pitchFamily="34" charset="-120"/>
               </a:rPr>
-              <a:t> bị</a:t>
-            </a:r>
-            <a:r>
-              <a:rPr lang="en-US" sz="2550" dirty="0" spc="-11" kern="0">
-                <a:solidFill>
-                  <a:srgbClr val="C4C8D6"/>
-                </a:solidFill>
-                <a:latin typeface="Be Vietnam Pro" pitchFamily="34" charset="0"/>
-                <a:ea typeface="Be Vietnam Pro" pitchFamily="34" charset="-122"/>
-                <a:cs typeface="Be Vietnam Pro" pitchFamily="34" charset="-120"/>
-              </a:rPr>
-              <a:t> tạm</a:t>
-            </a:r>
-            <a:r>
-              <a:rPr lang="en-US" sz="2550" dirty="0" spc="19" kern="0">
-                <a:solidFill>
-                  <a:srgbClr val="C4C8D6"/>
-                </a:solidFill>
-                <a:latin typeface="Be Vietnam Pro" pitchFamily="34" charset="0"/>
-                <a:ea typeface="Be Vietnam Pro" pitchFamily="34" charset="-122"/>
-                <a:cs typeface="Be Vietnam Pro" pitchFamily="34" charset="-120"/>
-              </a:rPr>
-              <a:t> dừng</a:t>
-            </a:r>
-            <a:r>
-              <a:rPr lang="en-US" sz="2550" dirty="0" spc="-1" kern="0">
-                <a:solidFill>
-                  <a:srgbClr val="C4C8D6"/>
-                </a:solidFill>
-                <a:latin typeface="Be Vietnam Pro" pitchFamily="34" charset="0"/>
-                <a:ea typeface="Be Vietnam Pro" pitchFamily="34" charset="-122"/>
-                <a:cs typeface="Be Vietnam Pro" pitchFamily="34" charset="-120"/>
-              </a:rPr>
-              <a:t> lúc giữ</a:t>
-            </a:r>
-            <a:r>
-              <a:rPr lang="en-US" sz="2550" dirty="0" spc="-3" kern="0">
-                <a:solidFill>
-                  <a:srgbClr val="C4C8D6"/>
-                </a:solidFill>
-                <a:latin typeface="Be Vietnam Pro" pitchFamily="34" charset="0"/>
-                <a:ea typeface="Be Vietnam Pro" pitchFamily="34" charset="-122"/>
-                <a:cs typeface="Be Vietnam Pro" pitchFamily="34" charset="-120"/>
-              </a:rPr>
-              <a:t> khóa,</a:t>
-            </a:r>
-            <a:r>
-              <a:rPr lang="en-US" sz="2550" dirty="0" spc="3" kern="0">
-                <a:solidFill>
-                  <a:srgbClr val="C4C8D6"/>
-                </a:solidFill>
-                <a:latin typeface="Be Vietnam Pro" pitchFamily="34" charset="0"/>
-                <a:ea typeface="Be Vietnam Pro" pitchFamily="34" charset="-122"/>
-                <a:cs typeface="Be Vietnam Pro" pitchFamily="34" charset="-120"/>
-              </a:rPr>
-              <a:t> B</a:t>
-            </a:r>
-            <a:r>
-              <a:rPr lang="en-US" sz="2550" dirty="0" spc="0" kern="0">
-                <a:solidFill>
-                  <a:srgbClr val="C4C8D6"/>
-                </a:solidFill>
-                <a:latin typeface="Be Vietnam Pro" pitchFamily="34" charset="0"/>
-                <a:ea typeface="Be Vietnam Pro" pitchFamily="34" charset="-122"/>
-                <a:cs typeface="Be Vietnam Pro" pitchFamily="34" charset="-120"/>
-              </a:rPr>
-              <a:t> chờ</a:t>
-            </a:r>
-            <a:r>
-              <a:rPr lang="en-US" sz="2550" dirty="0" spc="-37" kern="0">
-                <a:solidFill>
-                  <a:srgbClr val="C4C8D6"/>
-                </a:solidFill>
-                <a:latin typeface="Be Vietnam Pro" pitchFamily="34" charset="0"/>
-                <a:ea typeface="Be Vietnam Pro" pitchFamily="34" charset="-122"/>
-                <a:cs typeface="Be Vietnam Pro" pitchFamily="34" charset="-120"/>
-              </a:rPr>
-              <a:t> rất</a:t>
-            </a:r>
-            <a:r>
-              <a:rPr lang="en-US" sz="2550" dirty="0" spc="2" kern="0">
-                <a:solidFill>
-                  <a:srgbClr val="C4C8D6"/>
-                </a:solidFill>
-                <a:latin typeface="Be Vietnam Pro" pitchFamily="34" charset="0"/>
-                <a:ea typeface="Be Vietnam Pro" pitchFamily="34" charset="-122"/>
-                <a:cs typeface="Be Vietnam Pro" pitchFamily="34" charset="-120"/>
-              </a:rPr>
-              <a:t> lâu.</a:t>
+              <a:t> đợi.</a:t>
             </a:r>
             <a:endParaRPr lang="en-US" sz="2550" dirty="0"/>
           </a:p>
@@ -7614,7 +7449,7 @@
               <a:buNone/>
             </a:pPr>
             <a:r>
-              <a:rPr lang="en-US" sz="2100" b="1" dirty="0" spc="1" kern="0">
+              <a:rPr lang="en-US" sz="2100" b="1" dirty="0" spc="-2" kern="0">
                 <a:solidFill>
                   <a:srgbClr val="14161C"/>
                 </a:solidFill>
@@ -7622,10 +7457,10 @@
                 <a:ea typeface="Be Vietnam Pro" pitchFamily="34" charset="-122"/>
                 <a:cs typeface="Be Vietnam Pro" pitchFamily="34" charset="-120"/>
               </a:rPr>
-              <a:t>B</a:t>
-            </a:r>
-            <a:r>
-              <a:rPr lang="en-US" sz="2100" b="1" dirty="0" spc="-9" kern="0">
+              <a:t>put</a:t>
+            </a:r>
+            <a:r>
+              <a:rPr lang="en-US" sz="2100" b="1" dirty="0" spc="-19" kern="0">
                 <a:solidFill>
                   <a:srgbClr val="14161C"/>
                 </a:solidFill>
@@ -7633,10 +7468,10 @@
                 <a:ea typeface="Be Vietnam Pro" pitchFamily="34" charset="-122"/>
                 <a:cs typeface="Be Vietnam Pro" pitchFamily="34" charset="-120"/>
               </a:rPr>
-              <a:t> có</a:t>
-            </a:r>
-            <a:r>
-              <a:rPr lang="en-US" sz="2100" b="1" dirty="0" spc="-6" kern="0">
+              <a:t> và</a:t>
+            </a:r>
+            <a:r>
+              <a:rPr lang="en-US" sz="2100" b="1" dirty="0" spc="-23" kern="0">
                 <a:solidFill>
                   <a:srgbClr val="14161C"/>
                 </a:solidFill>
@@ -7644,10 +7479,10 @@
                 <a:ea typeface="Be Vietnam Pro" pitchFamily="34" charset="-122"/>
                 <a:cs typeface="Be Vietnam Pro" pitchFamily="34" charset="-120"/>
               </a:rPr>
-              <a:t> thể</a:t>
-            </a:r>
-            <a:r>
-              <a:rPr lang="en-US" sz="2100" b="1" dirty="0" spc="-1" kern="0">
+              <a:t> take</a:t>
+            </a:r>
+            <a:r>
+              <a:rPr lang="en-US" sz="2100" b="1" dirty="0" spc="0" kern="0">
                 <a:solidFill>
                   <a:srgbClr val="14161C"/>
                 </a:solidFill>
@@ -7655,10 +7490,10 @@
                 <a:ea typeface="Be Vietnam Pro" pitchFamily="34" charset="-122"/>
                 <a:cs typeface="Be Vietnam Pro" pitchFamily="34" charset="-120"/>
               </a:rPr>
-              <a:t> bị</a:t>
-            </a:r>
-            <a:r>
-              <a:rPr lang="en-US" sz="2100" b="1" dirty="0" spc="-6" kern="0">
+              <a:t> chặn</a:t>
+            </a:r>
+            <a:r>
+              <a:rPr lang="en-US" sz="2100" b="1" dirty="0" spc="-5" kern="0">
                 <a:solidFill>
                   <a:srgbClr val="14161C"/>
                 </a:solidFill>
@@ -7666,18 +7501,7 @@
                 <a:ea typeface="Be Vietnam Pro" pitchFamily="34" charset="-122"/>
                 <a:cs typeface="Be Vietnam Pro" pitchFamily="34" charset="-120"/>
               </a:rPr>
-              <a:t> bỏ</a:t>
-            </a:r>
-            <a:r>
-              <a:rPr lang="en-US" sz="2100" b="1" dirty="0" spc="1" kern="0">
-                <a:solidFill>
-                  <a:srgbClr val="14161C"/>
-                </a:solidFill>
-                <a:latin typeface="Be Vietnam Pro" pitchFamily="34" charset="0"/>
-                <a:ea typeface="Be Vietnam Pro" pitchFamily="34" charset="-122"/>
-                <a:cs typeface="Be Vietnam Pro" pitchFamily="34" charset="-120"/>
-              </a:rPr>
-              <a:t> đói</a:t>
+              <a:t> luồng</a:t>
             </a:r>
             <a:endParaRPr lang="en-US" sz="2100" dirty="0"/>
           </a:p>
@@ -8335,48 +8159,59 @@
               <a:buNone/>
             </a:pPr>
             <a:r>
-              <a:rPr lang="en-US" sz="1950" dirty="0" spc="-35" kern="0">
-                <a:solidFill>
-                  <a:srgbClr val="F3EEE3"/>
-                </a:solidFill>
-                <a:latin typeface="Be Vietnam Pro" pitchFamily="34" charset="0"/>
-                <a:ea typeface="Be Vietnam Pro" pitchFamily="34" charset="-122"/>
-                <a:cs typeface="Be Vietnam Pro" pitchFamily="34" charset="-120"/>
-              </a:rPr>
-              <a:t>Lấy</a:t>
-            </a:r>
-            <a:r>
-              <a:rPr lang="en-US" sz="1950" dirty="0" spc="-3" kern="0">
-                <a:solidFill>
-                  <a:srgbClr val="F3EEE3"/>
-                </a:solidFill>
-                <a:latin typeface="Be Vietnam Pro" pitchFamily="34" charset="0"/>
-                <a:ea typeface="Be Vietnam Pro" pitchFamily="34" charset="-122"/>
-                <a:cs typeface="Be Vietnam Pro" pitchFamily="34" charset="-120"/>
-              </a:rPr>
-              <a:t> khóa,</a:t>
-            </a:r>
-            <a:r>
-              <a:rPr lang="en-US" sz="1950" dirty="0" spc="1" kern="0">
-                <a:solidFill>
-                  <a:srgbClr val="F3EEE3"/>
-                </a:solidFill>
-                <a:latin typeface="Be Vietnam Pro" pitchFamily="34" charset="0"/>
-                <a:ea typeface="Be Vietnam Pro" pitchFamily="34" charset="-122"/>
-                <a:cs typeface="Be Vietnam Pro" pitchFamily="34" charset="-120"/>
-              </a:rPr>
-              <a:t> truy</a:t>
-            </a:r>
-            <a:r>
-              <a:rPr lang="en-US" sz="1950" dirty="0" spc="-3" kern="0">
-                <a:solidFill>
-                  <a:srgbClr val="F3EEE3"/>
-                </a:solidFill>
-                <a:latin typeface="Be Vietnam Pro" pitchFamily="34" charset="0"/>
-                <a:ea typeface="Be Vietnam Pro" pitchFamily="34" charset="-122"/>
-                <a:cs typeface="Be Vietnam Pro" pitchFamily="34" charset="-120"/>
-              </a:rPr>
-              <a:t> cập</a:t>
+              <a:rPr lang="en-US" sz="1950" dirty="0" spc="2" kern="0">
+                <a:solidFill>
+                  <a:srgbClr val="F3EEE3"/>
+                </a:solidFill>
+                <a:latin typeface="Be Vietnam Pro" pitchFamily="34" charset="0"/>
+                <a:ea typeface="Be Vietnam Pro" pitchFamily="34" charset="-122"/>
+                <a:cs typeface="Be Vietnam Pro" pitchFamily="34" charset="-120"/>
+              </a:rPr>
+              <a:t>Giữ</a:t>
+            </a:r>
+            <a:r>
+              <a:rPr lang="en-US" sz="1950" dirty="0" spc="-10" kern="0">
+                <a:solidFill>
+                  <a:srgbClr val="F3EEE3"/>
+                </a:solidFill>
+                <a:latin typeface="Be Vietnam Pro" pitchFamily="34" charset="0"/>
+                <a:ea typeface="Be Vietnam Pro" pitchFamily="34" charset="-122"/>
+                <a:cs typeface="Be Vietnam Pro" pitchFamily="34" charset="-120"/>
+              </a:rPr>
+              <a:t> putLock,</a:t>
+            </a:r>
+            <a:r>
+              <a:rPr lang="en-US" sz="1950" dirty="0" spc="-1" kern="0">
+                <a:solidFill>
+                  <a:srgbClr val="F3EEE3"/>
+                </a:solidFill>
+                <a:latin typeface="Be Vietnam Pro" pitchFamily="34" charset="0"/>
+                <a:ea typeface="Be Vietnam Pro" pitchFamily="34" charset="-122"/>
+                <a:cs typeface="Be Vietnam Pro" pitchFamily="34" charset="-120"/>
+              </a:rPr>
+              <a:t> thêm</a:t>
+            </a:r>
+            <a:r>
+              <a:rPr lang="en-US" sz="1950" dirty="0" spc="0" kern="0">
+                <a:solidFill>
+                  <a:srgbClr val="F3EEE3"/>
+                </a:solidFill>
+                <a:latin typeface="Be Vietnam Pro" pitchFamily="34" charset="0"/>
+                <a:ea typeface="Be Vietnam Pro" pitchFamily="34" charset="-122"/>
+                <a:cs typeface="Be Vietnam Pro" pitchFamily="34" charset="-120"/>
+              </a:rPr>
+              <a:t> phần</a:t>
+            </a:r>
+            <a:r>
+              <a:rPr lang="en-US" sz="1950" dirty="0" spc="-1" kern="0">
+                <a:solidFill>
+                  <a:srgbClr val="F3EEE3"/>
+                </a:solidFill>
+                <a:latin typeface="Be Vietnam Pro" pitchFamily="34" charset="0"/>
+                <a:ea typeface="Be Vietnam Pro" pitchFamily="34" charset="-122"/>
+                <a:cs typeface="Be Vietnam Pro" pitchFamily="34" charset="-120"/>
+              </a:rPr>
+              <a:t> tử</a:t>
             </a:r>
             <a:endParaRPr lang="en-US" sz="1950" dirty="0"/>
           </a:p>
@@ -8443,26 +8278,15 @@
               <a:t>Xin</a:t>
             </a:r>
             <a:r>
-              <a:rPr lang="en-US" sz="1950" dirty="0" spc="0" kern="0">
-                <a:solidFill>
-                  <a:srgbClr val="F3EEE3"/>
-                </a:solidFill>
-                <a:latin typeface="Be Vietnam Pro" pitchFamily="34" charset="0"/>
-                <a:ea typeface="Be Vietnam Pro" pitchFamily="34" charset="-122"/>
-                <a:cs typeface="Be Vietnam Pro" pitchFamily="34" charset="-120"/>
-              </a:rPr>
-              <a:t> truy</a:t>
-            </a:r>
-            <a:r>
-              <a:rPr lang="en-US" sz="1950" dirty="0" spc="-3" kern="0">
-                <a:solidFill>
-                  <a:srgbClr val="F3EEE3"/>
-                </a:solidFill>
-                <a:latin typeface="Be Vietnam Pro" pitchFamily="34" charset="0"/>
-                <a:ea typeface="Be Vietnam Pro" pitchFamily="34" charset="-122"/>
-                <a:cs typeface="Be Vietnam Pro" pitchFamily="34" charset="-120"/>
-              </a:rPr>
-              <a:t> cập</a:t>
+              <a:rPr lang="en-US" sz="1950" dirty="0" spc="-12" kern="0">
+                <a:solidFill>
+                  <a:srgbClr val="F3EEE3"/>
+                </a:solidFill>
+                <a:latin typeface="Be Vietnam Pro" pitchFamily="34" charset="0"/>
+                <a:ea typeface="Be Vietnam Pro" pitchFamily="34" charset="-122"/>
+                <a:cs typeface="Be Vietnam Pro" pitchFamily="34" charset="-120"/>
+              </a:rPr>
+              <a:t> putLock</a:t>
             </a:r>
             <a:endParaRPr lang="en-US" sz="1950" dirty="0"/>
           </a:p>
@@ -8540,7 +8364,7 @@
               <a:t> tới khi</a:t>
             </a:r>
             <a:r>
-              <a:rPr lang="en-US" sz="1950" b="1" dirty="0" spc="-6" kern="0">
+              <a:rPr lang="en-US" sz="1950" b="1" dirty="0" spc="-7" kern="0">
                 <a:solidFill>
                   <a:srgbClr val="FFB454"/>
                 </a:solidFill>
@@ -8548,10 +8372,10 @@
                 <a:ea typeface="Be Vietnam Pro" pitchFamily="34" charset="-122"/>
                 <a:cs typeface="Be Vietnam Pro" pitchFamily="34" charset="-120"/>
               </a:rPr>
-              <a:t> khóa</a:t>
-            </a:r>
-            <a:r>
-              <a:rPr lang="en-US" sz="1950" b="1" dirty="0" spc="8" kern="0">
+              <a:t> putLock</a:t>
+            </a:r>
+            <a:r>
+              <a:rPr lang="en-US" sz="1950" b="1" dirty="0" spc="7" kern="0">
                 <a:solidFill>
                   <a:srgbClr val="FFB454"/>
                 </a:solidFill>
@@ -8562,7 +8386,7 @@
               <a:t> được</a:t>
             </a:r>
             <a:r>
-              <a:rPr lang="en-US" sz="1950" b="1" dirty="0" spc="-2" kern="0">
+              <a:rPr lang="en-US" sz="1950" b="1" dirty="0" spc="-1" kern="0">
                 <a:solidFill>
                   <a:srgbClr val="FFB454"/>
                 </a:solidFill>
@@ -9254,7 +9078,7 @@
               <a:t>B</a:t>
             </a:r>
             <a:r>
-              <a:rPr lang="en-US" sz="6900" dirty="0" spc="-92" kern="0">
+              <a:rPr lang="en-US" sz="6900" dirty="0" spc="2" kern="0">
                 <a:solidFill>
                   <a:srgbClr val="14161C"/>
                 </a:solidFill>
@@ -9262,10 +9086,10 @@
                 <a:ea typeface="Bricolage Grotesque ExtraBold" pitchFamily="34" charset="-122"/>
                 <a:cs typeface="Bricolage Grotesque ExtraBold" pitchFamily="34" charset="-120"/>
               </a:rPr>
-              <a:t> được</a:t>
-            </a:r>
-            <a:r>
-              <a:rPr lang="en-US" sz="6900" dirty="0" spc="-4" kern="0">
+              <a:t> thua</a:t>
+            </a:r>
+            <a:r>
+              <a:rPr lang="en-US" sz="6900" dirty="0" spc="-83" kern="0">
                 <a:solidFill>
                   <a:srgbClr val="14161C"/>
                 </a:solidFill>
@@ -9273,7 +9097,7 @@
                 <a:ea typeface="Bricolage Grotesque ExtraBold" pitchFamily="34" charset="-122"/>
                 <a:cs typeface="Bricolage Grotesque ExtraBold" pitchFamily="34" charset="-120"/>
               </a:rPr>
-              <a:t> báo</a:t>
+              <a:t> CAS</a:t>
             </a:r>
             <a:endParaRPr lang="en-US" sz="6900" dirty="0"/>
           </a:p>
@@ -9285,7 +9109,7 @@
               <a:buNone/>
             </a:pPr>
             <a:r>
-              <a:rPr lang="en-US" sz="6900" dirty="0" spc="-2" kern="0">
+              <a:rPr lang="en-US" sz="6900" dirty="0" spc="-23" kern="0">
                 <a:solidFill>
                   <a:srgbClr val="14161C"/>
                 </a:solidFill>
@@ -9293,7 +9117,7 @@
                 <a:ea typeface="Bricolage Grotesque ExtraBold" pitchFamily="34" charset="-122"/>
                 <a:cs typeface="Bricolage Grotesque ExtraBold" pitchFamily="34" charset="-120"/>
               </a:rPr>
-              <a:t>từ</a:t>
+              <a:t>thì</a:t>
             </a:r>
             <a:r>
               <a:rPr lang="en-US" sz="6900" dirty="0" spc="0" kern="0">
@@ -9304,18 +9128,7 @@
                 <a:ea typeface="Bricolage Grotesque ExtraBold" pitchFamily="34" charset="-122"/>
                 <a:cs typeface="Bricolage Grotesque ExtraBold" pitchFamily="34" charset="-120"/>
               </a:rPr>
-              <a:t> chối</a:t>
-            </a:r>
-            <a:r>
-              <a:rPr lang="en-US" sz="6900" dirty="0" spc="-13" kern="0">
-                <a:solidFill>
-                  <a:srgbClr val="14161C"/>
-                </a:solidFill>
-                <a:latin typeface="Bricolage Grotesque ExtraBold" pitchFamily="34" charset="0"/>
-                <a:ea typeface="Bricolage Grotesque ExtraBold" pitchFamily="34" charset="-122"/>
-                <a:cs typeface="Bricolage Grotesque ExtraBold" pitchFamily="34" charset="-120"/>
-              </a:rPr>
-              <a:t> ngay</a:t>
+              <a:t> thử lại</a:t>
             </a:r>
             <a:endParaRPr lang="en-US" sz="6900" dirty="0"/>
           </a:p>
@@ -9429,7 +9242,29 @@
                 <a:ea typeface="Be Vietnam Pro" pitchFamily="34" charset="-122"/>
                 <a:cs typeface="Be Vietnam Pro" pitchFamily="34" charset="-120"/>
               </a:rPr>
-              <a:t>A truy</a:t>
+              <a:t>A</a:t>
+            </a:r>
+            <a:r>
+              <a:rPr lang="en-US" sz="2700" dirty="0" spc="-15" kern="0">
+                <a:solidFill>
+                  <a:srgbClr val="14161C"/>
+                </a:solidFill>
+                <a:latin typeface="Be Vietnam Pro" pitchFamily="34" charset="0"/>
+                <a:ea typeface="Be Vietnam Pro" pitchFamily="34" charset="-122"/>
+                <a:cs typeface="Be Vietnam Pro" pitchFamily="34" charset="-120"/>
+              </a:rPr>
+              <a:t> gắn</a:t>
+            </a:r>
+            <a:r>
+              <a:rPr lang="en-US" sz="2700" dirty="0" spc="-2" kern="0">
+                <a:solidFill>
+                  <a:srgbClr val="14161C"/>
+                </a:solidFill>
+                <a:latin typeface="Be Vietnam Pro" pitchFamily="34" charset="0"/>
+                <a:ea typeface="Be Vietnam Pro" pitchFamily="34" charset="-122"/>
+                <a:cs typeface="Be Vietnam Pro" pitchFamily="34" charset="-120"/>
+              </a:rPr>
+              <a:t> nút</a:t>
             </a:r>
             <a:r>
               <a:rPr lang="en-US" sz="2700" dirty="0" spc="1" kern="0">
@@ -9440,10 +9275,10 @@
                 <a:ea typeface="Be Vietnam Pro" pitchFamily="34" charset="-122"/>
                 <a:cs typeface="Be Vietnam Pro" pitchFamily="34" charset="-120"/>
               </a:rPr>
-              <a:t> cập,</a:t>
-            </a:r>
-            <a:r>
-              <a:rPr lang="en-US" sz="2700" dirty="0" spc="17" kern="0">
+              <a:t> cuối</a:t>
+            </a:r>
+            <a:r>
+              <a:rPr lang="en-US" sz="2700" dirty="0" spc="-5" kern="0">
                 <a:solidFill>
                   <a:srgbClr val="14161C"/>
                 </a:solidFill>
@@ -9451,10 +9286,10 @@
                 <a:ea typeface="Be Vietnam Pro" pitchFamily="34" charset="-122"/>
                 <a:cs typeface="Be Vietnam Pro" pitchFamily="34" charset="-120"/>
               </a:rPr>
-              <a:t> nhưng</a:t>
-            </a:r>
-            <a:r>
-              <a:rPr lang="en-US" sz="2700" dirty="0" spc="-1" kern="0">
+              <a:t> bằng</a:t>
+            </a:r>
+            <a:r>
+              <a:rPr lang="en-US" sz="2700" dirty="0" spc="-31" kern="0">
                 <a:solidFill>
                   <a:srgbClr val="14161C"/>
                 </a:solidFill>
@@ -9462,7 +9297,7 @@
                 <a:ea typeface="Be Vietnam Pro" pitchFamily="34" charset="-122"/>
                 <a:cs typeface="Be Vietnam Pro" pitchFamily="34" charset="-120"/>
               </a:rPr>
-              <a:t> phải</a:t>
+              <a:t> CAS;</a:t>
             </a:r>
             <a:r>
               <a:rPr lang="en-US" sz="2700" dirty="0" spc="-2" kern="0">
@@ -9473,10 +9308,10 @@
                 <a:ea typeface="Be Vietnam Pro" pitchFamily="34" charset="-122"/>
                 <a:cs typeface="Be Vietnam Pro" pitchFamily="34" charset="-120"/>
               </a:rPr>
-              <a:t> làm</a:t>
-            </a:r>
-            <a:r>
-              <a:rPr lang="en-US" sz="2700" dirty="0" spc="-19" kern="0">
+              <a:t> không</a:t>
+            </a:r>
+            <a:r>
+              <a:rPr lang="en-US" sz="2700" dirty="0" spc="-3" kern="0">
                 <a:solidFill>
                   <a:srgbClr val="14161C"/>
                 </a:solidFill>
@@ -9484,10 +9319,10 @@
                 <a:ea typeface="Be Vietnam Pro" pitchFamily="34" charset="-122"/>
                 <a:cs typeface="Be Vietnam Pro" pitchFamily="34" charset="-120"/>
               </a:rPr>
-              <a:t> xong</a:t>
-            </a:r>
-            <a:r>
-              <a:rPr lang="en-US" sz="2700" dirty="0" spc="-20" kern="0">
+              <a:t> ai</a:t>
+            </a:r>
+            <a:r>
+              <a:rPr lang="en-US" sz="2700" dirty="0" spc="12" kern="0">
                 <a:solidFill>
                   <a:srgbClr val="14161C"/>
                 </a:solidFill>
@@ -9495,10 +9330,10 @@
                 <a:ea typeface="Be Vietnam Pro" pitchFamily="34" charset="-122"/>
                 <a:cs typeface="Be Vietnam Pro" pitchFamily="34" charset="-120"/>
               </a:rPr>
-              <a:t> trong</a:t>
-            </a:r>
-            <a:r>
-              <a:rPr lang="en-US" sz="2700" dirty="0" spc="-7" kern="0">
+              <a:t> đợi</a:t>
+            </a:r>
+            <a:r>
+              <a:rPr lang="en-US" sz="2700" dirty="0" spc="-5" kern="0">
                 <a:solidFill>
                   <a:srgbClr val="14161C"/>
                 </a:solidFill>
@@ -9506,51 +9341,7 @@
                 <a:ea typeface="Be Vietnam Pro" pitchFamily="34" charset="-122"/>
                 <a:cs typeface="Be Vietnam Pro" pitchFamily="34" charset="-120"/>
               </a:rPr>
-              <a:t> một</a:t>
-            </a:r>
-            <a:r>
-              <a:rPr lang="en-US" sz="2700" dirty="0" spc="-12" kern="0">
-                <a:solidFill>
-                  <a:srgbClr val="14161C"/>
-                </a:solidFill>
-                <a:latin typeface="Be Vietnam Pro" pitchFamily="34" charset="0"/>
-                <a:ea typeface="Be Vietnam Pro" pitchFamily="34" charset="-122"/>
-                <a:cs typeface="Be Vietnam Pro" pitchFamily="34" charset="-120"/>
-              </a:rPr>
-              <a:t> số</a:t>
-            </a:r>
-            <a:r>
-              <a:rPr lang="en-US" sz="2700" dirty="0" spc="9" kern="0">
-                <a:solidFill>
-                  <a:srgbClr val="14161C"/>
-                </a:solidFill>
-                <a:latin typeface="Be Vietnam Pro" pitchFamily="34" charset="0"/>
-                <a:ea typeface="Be Vietnam Pro" pitchFamily="34" charset="-122"/>
-                <a:cs typeface="Be Vietnam Pro" pitchFamily="34" charset="-120"/>
-              </a:rPr>
-              <a:t> bước</a:t>
-            </a:r>
-            <a:r>
-              <a:rPr lang="en-US" sz="2700" dirty="0" spc="-12" kern="0">
-                <a:solidFill>
-                  <a:srgbClr val="14161C"/>
-                </a:solidFill>
-                <a:latin typeface="Be Vietnam Pro" pitchFamily="34" charset="0"/>
-                <a:ea typeface="Be Vietnam Pro" pitchFamily="34" charset="-122"/>
-                <a:cs typeface="Be Vietnam Pro" pitchFamily="34" charset="-120"/>
-              </a:rPr>
-              <a:t> nhất</a:t>
-            </a:r>
-            <a:r>
-              <a:rPr lang="en-US" sz="2700" dirty="0" spc="16" kern="0">
-                <a:solidFill>
-                  <a:srgbClr val="14161C"/>
-                </a:solidFill>
-                <a:latin typeface="Be Vietnam Pro" pitchFamily="34" charset="0"/>
-                <a:ea typeface="Be Vietnam Pro" pitchFamily="34" charset="-122"/>
-                <a:cs typeface="Be Vietnam Pro" pitchFamily="34" charset="-120"/>
-              </a:rPr>
-              <a:t> định.</a:t>
+              <a:t> khóa.</a:t>
             </a:r>
             <a:endParaRPr lang="en-US" sz="2700" dirty="0"/>
           </a:p>
@@ -9585,37 +9376,26 @@
               <a:buNone/>
             </a:pPr>
             <a:r>
-              <a:rPr lang="en-US" sz="2100" b="1" dirty="0" spc="-72" kern="0">
-                <a:solidFill>
-                  <a:srgbClr val="F3EEE3"/>
-                </a:solidFill>
-                <a:latin typeface="Be Vietnam Pro" pitchFamily="34" charset="0"/>
-                <a:ea typeface="Be Vietnam Pro" pitchFamily="34" charset="-122"/>
-                <a:cs typeface="Be Vietnam Pro" pitchFamily="34" charset="-120"/>
-              </a:rPr>
-              <a:t>Từ</a:t>
-            </a:r>
-            <a:r>
-              <a:rPr lang="en-US" sz="2100" b="1" dirty="0" spc="-6" kern="0">
-                <a:solidFill>
-                  <a:srgbClr val="F3EEE3"/>
-                </a:solidFill>
-                <a:latin typeface="Be Vietnam Pro" pitchFamily="34" charset="0"/>
-                <a:ea typeface="Be Vietnam Pro" pitchFamily="34" charset="-122"/>
-                <a:cs typeface="Be Vietnam Pro" pitchFamily="34" charset="-120"/>
-              </a:rPr>
-              <a:t> chối</a:t>
-            </a:r>
-            <a:r>
-              <a:rPr lang="en-US" sz="2100" b="1" dirty="0" spc="-12" kern="0">
-                <a:solidFill>
-                  <a:srgbClr val="F3EEE3"/>
-                </a:solidFill>
-                <a:latin typeface="Be Vietnam Pro" pitchFamily="34" charset="0"/>
-                <a:ea typeface="Be Vietnam Pro" pitchFamily="34" charset="-122"/>
-                <a:cs typeface="Be Vietnam Pro" pitchFamily="34" charset="-120"/>
-              </a:rPr>
-              <a:t> ngay</a:t>
+              <a:rPr lang="en-US" sz="2100" b="1" dirty="0" spc="2" kern="0">
+                <a:solidFill>
+                  <a:srgbClr val="F3EEE3"/>
+                </a:solidFill>
+                <a:latin typeface="Be Vietnam Pro" pitchFamily="34" charset="0"/>
+                <a:ea typeface="Be Vietnam Pro" pitchFamily="34" charset="-122"/>
+                <a:cs typeface="Be Vietnam Pro" pitchFamily="34" charset="-120"/>
+              </a:rPr>
+              <a:t>Thử</a:t>
+            </a:r>
+            <a:r>
+              <a:rPr lang="en-US" sz="2100" b="1" dirty="0" spc="-2" kern="0">
+                <a:solidFill>
+                  <a:srgbClr val="F3EEE3"/>
+                </a:solidFill>
+                <a:latin typeface="Be Vietnam Pro" pitchFamily="34" charset="0"/>
+                <a:ea typeface="Be Vietnam Pro" pitchFamily="34" charset="-122"/>
+                <a:cs typeface="Be Vietnam Pro" pitchFamily="34" charset="-120"/>
+              </a:rPr>
+              <a:t> lại</a:t>
             </a:r>
             <a:endParaRPr lang="en-US" sz="2100" dirty="0"/>
           </a:p>
@@ -9661,17 +9441,6 @@
               <a:t>B</a:t>
             </a:r>
             <a:r>
-              <a:rPr lang="en-US" sz="2100" b="1" dirty="0" spc="-11" kern="0">
-                <a:solidFill>
-                  <a:srgbClr val="F3EEE3"/>
-                </a:solidFill>
-                <a:latin typeface="Be Vietnam Pro" pitchFamily="34" charset="0"/>
-                <a:ea typeface="Be Vietnam Pro" pitchFamily="34" charset="-122"/>
-                <a:cs typeface="Be Vietnam Pro" pitchFamily="34" charset="-120"/>
-              </a:rPr>
-              <a:t> vẫn</a:t>
-            </a:r>
-            <a:r>
               <a:rPr lang="en-US" sz="2100" b="1" dirty="0" spc="-9" kern="0">
                 <a:solidFill>
                   <a:srgbClr val="F3EEE3"/>
@@ -9694,6 +9463,17 @@
               <a:t> thể</a:t>
             </a:r>
             <a:r>
+              <a:rPr lang="en-US" sz="2100" b="1" dirty="0" spc="-3" kern="0">
+                <a:solidFill>
+                  <a:srgbClr val="F3EEE3"/>
+                </a:solidFill>
+                <a:latin typeface="Be Vietnam Pro" pitchFamily="34" charset="0"/>
+                <a:ea typeface="Be Vietnam Pro" pitchFamily="34" charset="-122"/>
+                <a:cs typeface="Be Vietnam Pro" pitchFamily="34" charset="-120"/>
+              </a:rPr>
+              <a:t> thua</a:t>
+            </a:r>
+            <a:r>
               <a:rPr lang="en-US" sz="2100" b="1" dirty="0" spc="-1" kern="0">
                 <a:solidFill>
                   <a:srgbClr val="F3EEE3"/>
@@ -9702,29 +9482,18 @@
                 <a:ea typeface="Be Vietnam Pro" pitchFamily="34" charset="-122"/>
                 <a:cs typeface="Be Vietnam Pro" pitchFamily="34" charset="-120"/>
               </a:rPr>
-              <a:t> bị</a:t>
-            </a:r>
-            <a:r>
-              <a:rPr lang="en-US" sz="2100" b="1" dirty="0" spc="-6" kern="0">
-                <a:solidFill>
-                  <a:srgbClr val="F3EEE3"/>
-                </a:solidFill>
-                <a:latin typeface="Be Vietnam Pro" pitchFamily="34" charset="0"/>
-                <a:ea typeface="Be Vietnam Pro" pitchFamily="34" charset="-122"/>
-                <a:cs typeface="Be Vietnam Pro" pitchFamily="34" charset="-120"/>
-              </a:rPr>
-              <a:t> bỏ</a:t>
-            </a:r>
-            <a:r>
-              <a:rPr lang="en-US" sz="2100" b="1" dirty="0" spc="0" kern="0">
-                <a:solidFill>
-                  <a:srgbClr val="F3EEE3"/>
-                </a:solidFill>
-                <a:latin typeface="Be Vietnam Pro" pitchFamily="34" charset="0"/>
-                <a:ea typeface="Be Vietnam Pro" pitchFamily="34" charset="-122"/>
-                <a:cs typeface="Be Vietnam Pro" pitchFamily="34" charset="-120"/>
-              </a:rPr>
-              <a:t> đói</a:t>
+              <a:t> nhiều</a:t>
+            </a:r>
+            <a:r>
+              <a:rPr lang="en-US" sz="2100" b="1" dirty="0" spc="1" kern="0">
+                <a:solidFill>
+                  <a:srgbClr val="F3EEE3"/>
+                </a:solidFill>
+                <a:latin typeface="Be Vietnam Pro" pitchFamily="34" charset="0"/>
+                <a:ea typeface="Be Vietnam Pro" pitchFamily="34" charset="-122"/>
+                <a:cs typeface="Be Vietnam Pro" pitchFamily="34" charset="-120"/>
+              </a:rPr>
+              <a:t> lần</a:t>
             </a:r>
             <a:endParaRPr lang="en-US" sz="2100" dirty="0"/>
           </a:p>
@@ -9841,6 +9610,39 @@
               <a:t>B</a:t>
             </a:r>
             <a:r>
+              <a:rPr lang="en-US" sz="2550" dirty="0" spc="2" kern="0">
+                <a:solidFill>
+                  <a:srgbClr val="14161C"/>
+                </a:solidFill>
+                <a:latin typeface="Be Vietnam Pro" pitchFamily="34" charset="0"/>
+                <a:ea typeface="Be Vietnam Pro" pitchFamily="34" charset="-122"/>
+                <a:cs typeface="Be Vietnam Pro" pitchFamily="34" charset="-120"/>
+              </a:rPr>
+              <a:t> thua</a:t>
+            </a:r>
+            <a:r>
+              <a:rPr lang="en-US" sz="2550" dirty="0" spc="1" kern="0">
+                <a:solidFill>
+                  <a:srgbClr val="14161C"/>
+                </a:solidFill>
+                <a:latin typeface="Be Vietnam Pro" pitchFamily="34" charset="0"/>
+                <a:ea typeface="Be Vietnam Pro" pitchFamily="34" charset="-122"/>
+                <a:cs typeface="Be Vietnam Pro" pitchFamily="34" charset="-120"/>
+              </a:rPr>
+              <a:t> thì</a:t>
+            </a:r>
+            <a:r>
+              <a:rPr lang="en-US" sz="2550" dirty="0" spc="10" kern="0">
+                <a:solidFill>
+                  <a:srgbClr val="14161C"/>
+                </a:solidFill>
+                <a:latin typeface="Be Vietnam Pro" pitchFamily="34" charset="0"/>
+                <a:ea typeface="Be Vietnam Pro" pitchFamily="34" charset="-122"/>
+                <a:cs typeface="Be Vietnam Pro" pitchFamily="34" charset="-120"/>
+              </a:rPr>
+              <a:t> đọc</a:t>
+            </a:r>
+            <a:r>
               <a:rPr lang="en-US" sz="2550" dirty="0" spc="0" kern="0">
                 <a:solidFill>
                   <a:srgbClr val="14161C"/>
@@ -9849,7 +9651,18 @@
                 <a:ea typeface="Be Vietnam Pro" pitchFamily="34" charset="-122"/>
                 <a:cs typeface="Be Vietnam Pro" pitchFamily="34" charset="-120"/>
               </a:rPr>
-              <a:t> nhận phản</a:t>
+              <a:t> lại</a:t>
+            </a:r>
+            <a:r>
+              <a:rPr lang="en-US" sz="2550" dirty="0" spc="-19" kern="0">
+                <a:solidFill>
+                  <a:srgbClr val="14161C"/>
+                </a:solidFill>
+                <a:latin typeface="Be Vietnam Pro" pitchFamily="34" charset="0"/>
+                <a:ea typeface="Be Vietnam Pro" pitchFamily="34" charset="-122"/>
+                <a:cs typeface="Be Vietnam Pro" pitchFamily="34" charset="-120"/>
+              </a:rPr>
+              <a:t> và</a:t>
             </a:r>
             <a:r>
               <a:rPr lang="en-US" sz="2550" dirty="0" spc="-1" kern="0">
@@ -9860,10 +9673,10 @@
                 <a:ea typeface="Be Vietnam Pro" pitchFamily="34" charset="-122"/>
                 <a:cs typeface="Be Vietnam Pro" pitchFamily="34" charset="-120"/>
               </a:rPr>
-              <a:t> hồi</a:t>
-            </a:r>
-            <a:r>
-              <a:rPr lang="en-US" sz="2550" dirty="0" spc="-16" kern="0">
+              <a:t> thử</a:t>
+            </a:r>
+            <a:r>
+              <a:rPr lang="en-US" sz="2550" dirty="0" spc="-12" kern="0">
                 <a:solidFill>
                   <a:srgbClr val="14161C"/>
                 </a:solidFill>
@@ -9871,54 +9684,10 @@
                 <a:ea typeface="Be Vietnam Pro" pitchFamily="34" charset="-122"/>
                 <a:cs typeface="Be Vietnam Pro" pitchFamily="34" charset="-120"/>
               </a:rPr>
-              <a:t> ngay,</a:t>
-            </a:r>
-            <a:r>
-              <a:rPr lang="en-US" sz="2550" dirty="0" spc="-26" kern="0">
-                <a:solidFill>
-                  <a:srgbClr val="14161C"/>
-                </a:solidFill>
-                <a:latin typeface="Be Vietnam Pro" pitchFamily="34" charset="0"/>
-                <a:ea typeface="Be Vietnam Pro" pitchFamily="34" charset="-122"/>
-                <a:cs typeface="Be Vietnam Pro" pitchFamily="34" charset="-120"/>
-              </a:rPr>
-              <a:t> rồi</a:t>
-            </a:r>
-            <a:r>
-              <a:rPr lang="en-US" sz="2550" dirty="0" spc="-1" kern="0">
-                <a:solidFill>
-                  <a:srgbClr val="14161C"/>
-                </a:solidFill>
-                <a:latin typeface="Be Vietnam Pro" pitchFamily="34" charset="0"/>
-                <a:ea typeface="Be Vietnam Pro" pitchFamily="34" charset="-122"/>
-                <a:cs typeface="Be Vietnam Pro" pitchFamily="34" charset="-120"/>
-              </a:rPr>
-              <a:t> tự</a:t>
-            </a:r>
-            <a:r>
-              <a:rPr lang="en-US" sz="2550" dirty="0" spc="-17" kern="0">
-                <a:solidFill>
-                  <a:srgbClr val="14161C"/>
-                </a:solidFill>
-                <a:latin typeface="Be Vietnam Pro" pitchFamily="34" charset="0"/>
-                <a:ea typeface="Be Vietnam Pro" pitchFamily="34" charset="-122"/>
-                <a:cs typeface="Be Vietnam Pro" pitchFamily="34" charset="-120"/>
-              </a:rPr>
-              <a:t> quyết</a:t>
+              <a:t> gắn</a:t>
             </a:r>
             <a:r>
               <a:rPr lang="en-US" sz="2550" dirty="0" spc="1" kern="0">
-                <a:solidFill>
-                  <a:srgbClr val="14161C"/>
-                </a:solidFill>
-                <a:latin typeface="Be Vietnam Pro" pitchFamily="34" charset="0"/>
-                <a:ea typeface="Be Vietnam Pro" pitchFamily="34" charset="-122"/>
-                <a:cs typeface="Be Vietnam Pro" pitchFamily="34" charset="-120"/>
-              </a:rPr>
-              <a:t> làm gì</a:t>
-            </a:r>
-            <a:r>
-              <a:rPr lang="en-US" sz="2550" dirty="0" spc="2" kern="0">
                 <a:solidFill>
                   <a:srgbClr val="14161C"/>
                 </a:solidFill>
@@ -10326,7 +10095,7 @@
               <a:buNone/>
             </a:pPr>
             <a:r>
-              <a:rPr lang="en-US" sz="1950" dirty="0" spc="4" kern="0">
+              <a:rPr lang="en-US" sz="1950" dirty="0" spc="2" kern="0">
                 <a:solidFill>
                   <a:srgbClr val="14161C"/>
                 </a:solidFill>
@@ -10334,7 +10103,7 @@
                 <a:ea typeface="Be Vietnam Pro" pitchFamily="34" charset="-122"/>
                 <a:cs typeface="Be Vietnam Pro" pitchFamily="34" charset="-120"/>
               </a:rPr>
-              <a:t>Xin</a:t>
+              <a:t>Gắn</a:t>
             </a:r>
             <a:r>
               <a:rPr lang="en-US" sz="1950" dirty="0" spc="0" kern="0">
@@ -10345,10 +10114,10 @@
                 <a:ea typeface="Be Vietnam Pro" pitchFamily="34" charset="-122"/>
                 <a:cs typeface="Be Vietnam Pro" pitchFamily="34" charset="-120"/>
               </a:rPr>
-              <a:t> truy</a:t>
-            </a:r>
-            <a:r>
-              <a:rPr lang="en-US" sz="1950" dirty="0" spc="-3" kern="0">
+              <a:t> nút</a:t>
+            </a:r>
+            <a:r>
+              <a:rPr lang="en-US" sz="1950" dirty="0" spc="-1" kern="0">
                 <a:solidFill>
                   <a:srgbClr val="14161C"/>
                 </a:solidFill>
@@ -10356,7 +10125,18 @@
                 <a:ea typeface="Be Vietnam Pro" pitchFamily="34" charset="-122"/>
                 <a:cs typeface="Be Vietnam Pro" pitchFamily="34" charset="-120"/>
               </a:rPr>
-              <a:t> cập</a:t>
+              <a:t> bằng</a:t>
+            </a:r>
+            <a:r>
+              <a:rPr lang="en-US" sz="1950" dirty="0" spc="-31" kern="0">
+                <a:solidFill>
+                  <a:srgbClr val="14161C"/>
+                </a:solidFill>
+                <a:latin typeface="Be Vietnam Pro" pitchFamily="34" charset="0"/>
+                <a:ea typeface="Be Vietnam Pro" pitchFamily="34" charset="-122"/>
+                <a:cs typeface="Be Vietnam Pro" pitchFamily="34" charset="-120"/>
+              </a:rPr>
+              <a:t> CAS</a:t>
             </a:r>
             <a:endParaRPr lang="en-US" sz="1950" dirty="0"/>
           </a:p>
@@ -10412,7 +10192,7 @@
               <a:buNone/>
             </a:pPr>
             <a:r>
-              <a:rPr lang="en-US" sz="1950" b="1" dirty="0" spc="-70" kern="0">
+              <a:rPr lang="en-US" sz="1950" b="1" dirty="0" spc="-2" kern="0">
                 <a:solidFill>
                   <a:srgbClr val="0F766E"/>
                 </a:solidFill>
@@ -10420,10 +10200,10 @@
                 <a:ea typeface="Be Vietnam Pro" pitchFamily="34" charset="-122"/>
                 <a:cs typeface="Be Vietnam Pro" pitchFamily="34" charset="-120"/>
               </a:rPr>
-              <a:t>Từ</a:t>
-            </a:r>
-            <a:r>
-              <a:rPr lang="en-US" sz="1950" b="1" dirty="0" spc="-3" kern="0">
+              <a:t>Thua</a:t>
+            </a:r>
+            <a:r>
+              <a:rPr lang="en-US" sz="1950" b="1" dirty="0" spc="-26" kern="0">
                 <a:solidFill>
                   <a:srgbClr val="0F766E"/>
                 </a:solidFill>
@@ -10431,10 +10211,10 @@
                 <a:ea typeface="Be Vietnam Pro" pitchFamily="34" charset="-122"/>
                 <a:cs typeface="Be Vietnam Pro" pitchFamily="34" charset="-120"/>
               </a:rPr>
-              <a:t> chối</a:t>
-            </a:r>
-            <a:r>
-              <a:rPr lang="en-US" sz="1950" b="1" dirty="0" spc="-11" kern="0">
+              <a:t> CAS:</a:t>
+            </a:r>
+            <a:r>
+              <a:rPr lang="en-US" sz="1950" b="1" dirty="0" spc="0" kern="0">
                 <a:solidFill>
                   <a:srgbClr val="0F766E"/>
                 </a:solidFill>
@@ -10442,7 +10222,29 @@
                 <a:ea typeface="Be Vietnam Pro" pitchFamily="34" charset="-122"/>
                 <a:cs typeface="Be Vietnam Pro" pitchFamily="34" charset="-120"/>
               </a:rPr>
-              <a:t> ngay</a:t>
+              <a:t> đọc lại,</a:t>
+            </a:r>
+            <a:r>
+              <a:rPr lang="en-US" sz="1950" b="1" dirty="0" spc="-1" kern="0">
+                <a:solidFill>
+                  <a:srgbClr val="0F766E"/>
+                </a:solidFill>
+                <a:latin typeface="Be Vietnam Pro" pitchFamily="34" charset="0"/>
+                <a:ea typeface="Be Vietnam Pro" pitchFamily="34" charset="-122"/>
+                <a:cs typeface="Be Vietnam Pro" pitchFamily="34" charset="-120"/>
+              </a:rPr>
+              <a:t> thử</a:t>
+            </a:r>
+            <a:r>
+              <a:rPr lang="en-US" sz="1950" b="1" dirty="0" spc="0" kern="0">
+                <a:solidFill>
+                  <a:srgbClr val="0F766E"/>
+                </a:solidFill>
+                <a:latin typeface="Be Vietnam Pro" pitchFamily="34" charset="0"/>
+                <a:ea typeface="Be Vietnam Pro" pitchFamily="34" charset="-122"/>
+                <a:cs typeface="Be Vietnam Pro" pitchFamily="34" charset="-120"/>
+              </a:rPr>
+              <a:t> tiếp</a:t>
             </a:r>
             <a:endParaRPr lang="en-US" sz="1950" dirty="0"/>
           </a:p>
@@ -10535,7 +10337,7 @@
                 <a:ea typeface="Be Vietnam Pro" pitchFamily="34" charset="-122"/>
                 <a:cs typeface="Be Vietnam Pro" pitchFamily="34" charset="-120"/>
               </a:rPr>
-              <a:t>làm</a:t>
+              <a:t>gắn</a:t>
             </a:r>
             <a:r>
               <a:rPr lang="en-US" sz="2100" b="1" dirty="0" spc="-21" kern="0">
@@ -10581,26 +10383,15 @@
               <a:buNone/>
             </a:pPr>
             <a:r>
-              <a:rPr lang="en-US" sz="2100" b="1" dirty="0" spc="-3" kern="0">
-                <a:solidFill>
-                  <a:srgbClr val="F3EEE3"/>
-                </a:solidFill>
-                <a:latin typeface="Be Vietnam Pro" pitchFamily="34" charset="0"/>
-                <a:ea typeface="Be Vietnam Pro" pitchFamily="34" charset="-122"/>
-                <a:cs typeface="Be Vietnam Pro" pitchFamily="34" charset="-120"/>
-              </a:rPr>
-              <a:t>tự</a:t>
-            </a:r>
-            <a:r>
-              <a:rPr lang="en-US" sz="2100" b="1" dirty="0" spc="-16" kern="0">
-                <a:solidFill>
-                  <a:srgbClr val="F3EEE3"/>
-                </a:solidFill>
-                <a:latin typeface="Be Vietnam Pro" pitchFamily="34" charset="0"/>
-                <a:ea typeface="Be Vietnam Pro" pitchFamily="34" charset="-122"/>
-                <a:cs typeface="Be Vietnam Pro" pitchFamily="34" charset="-120"/>
-              </a:rPr>
-              <a:t> quyết</a:t>
+              <a:rPr lang="en-US" sz="2100" b="1" dirty="0" spc="-1" kern="0">
+                <a:solidFill>
+                  <a:srgbClr val="F3EEE3"/>
+                </a:solidFill>
+                <a:latin typeface="Be Vietnam Pro" pitchFamily="34" charset="0"/>
+                <a:ea typeface="Be Vietnam Pro" pitchFamily="34" charset="-122"/>
+                <a:cs typeface="Be Vietnam Pro" pitchFamily="34" charset="-120"/>
+              </a:rPr>
+              <a:t>thử lại</a:t>
             </a:r>
             <a:endParaRPr lang="en-US" sz="2100" dirty="0"/>
           </a:p>
@@ -10997,7 +10788,7 @@
               <a:buNone/>
             </a:pPr>
             <a:r>
-              <a:rPr lang="en-US" sz="1950" dirty="0" spc="-32" kern="0">
+              <a:rPr lang="en-US" sz="1950" dirty="0" spc="-2" kern="0">
                 <a:solidFill>
                   <a:srgbClr val="14161C"/>
                 </a:solidFill>
@@ -11005,10 +10796,10 @@
                 <a:ea typeface="Be Vietnam Pro" pitchFamily="34" charset="-122"/>
                 <a:cs typeface="Be Vietnam Pro" pitchFamily="34" charset="-120"/>
               </a:rPr>
-              <a:t>Truy</a:t>
-            </a:r>
-            <a:r>
-              <a:rPr lang="en-US" sz="1950" dirty="0" spc="-1" kern="0">
+              <a:t>A</a:t>
+            </a:r>
+            <a:r>
+              <a:rPr lang="en-US" sz="1950" dirty="0" spc="-8" kern="0">
                 <a:solidFill>
                   <a:srgbClr val="14161C"/>
                 </a:solidFill>
@@ -11016,10 +10807,10 @@
                 <a:ea typeface="Be Vietnam Pro" pitchFamily="34" charset="-122"/>
                 <a:cs typeface="Be Vietnam Pro" pitchFamily="34" charset="-120"/>
               </a:rPr>
-              <a:t> cập, làm</a:t>
-            </a:r>
-            <a:r>
-              <a:rPr lang="en-US" sz="1950" dirty="0" spc="-9" kern="0">
+              <a:t> gắn</a:t>
+            </a:r>
+            <a:r>
+              <a:rPr lang="en-US" sz="1950" dirty="0" spc="0" kern="0">
                 <a:solidFill>
                   <a:srgbClr val="14161C"/>
                 </a:solidFill>
@@ -11027,7 +10818,7 @@
                 <a:ea typeface="Be Vietnam Pro" pitchFamily="34" charset="-122"/>
                 <a:cs typeface="Be Vietnam Pro" pitchFamily="34" charset="-120"/>
               </a:rPr>
-              <a:t> xong</a:t>
+              <a:t> nút</a:t>
             </a:r>
             <a:endParaRPr lang="en-US" sz="1950" dirty="0"/>
           </a:p>
@@ -11036,7 +10827,7 @@
               <a:buNone/>
             </a:pPr>
             <a:r>
-              <a:rPr lang="en-US" sz="1950" dirty="0" spc="-14" kern="0">
+              <a:rPr lang="en-US" sz="1950" dirty="0" spc="-1" kern="0">
                 <a:solidFill>
                   <a:srgbClr val="14161C"/>
                 </a:solidFill>
@@ -11044,29 +10835,7 @@
                 <a:ea typeface="Be Vietnam Pro" pitchFamily="34" charset="-122"/>
                 <a:cs typeface="Be Vietnam Pro" pitchFamily="34" charset="-120"/>
               </a:rPr>
-              <a:t>trong</a:t>
-            </a:r>
-            <a:r>
-              <a:rPr lang="en-US" sz="1950" dirty="0" spc="-7" kern="0">
-                <a:solidFill>
-                  <a:srgbClr val="14161C"/>
-                </a:solidFill>
-                <a:latin typeface="Be Vietnam Pro" pitchFamily="34" charset="0"/>
-                <a:ea typeface="Be Vietnam Pro" pitchFamily="34" charset="-122"/>
-                <a:cs typeface="Be Vietnam Pro" pitchFamily="34" charset="-120"/>
-              </a:rPr>
-              <a:t> số</a:t>
-            </a:r>
-            <a:r>
-              <a:rPr lang="en-US" sz="1950" dirty="0" spc="3" kern="0">
-                <a:solidFill>
-                  <a:srgbClr val="14161C"/>
-                </a:solidFill>
-                <a:latin typeface="Be Vietnam Pro" pitchFamily="34" charset="0"/>
-                <a:ea typeface="Be Vietnam Pro" pitchFamily="34" charset="-122"/>
-                <a:cs typeface="Be Vietnam Pro" pitchFamily="34" charset="-120"/>
-              </a:rPr>
-              <a:t> bước</a:t>
+              <a:t>cuối bằng</a:t>
             </a:r>
             <a:endParaRPr lang="en-US" sz="1950" dirty="0"/>
           </a:p>
@@ -11075,7 +10844,7 @@
               <a:buNone/>
             </a:pPr>
             <a:r>
-              <a:rPr lang="en-US" sz="1950" dirty="0" spc="-10" kern="0">
+              <a:rPr lang="en-US" sz="1950" dirty="0" spc="-40" kern="0">
                 <a:solidFill>
                   <a:srgbClr val="14161C"/>
                 </a:solidFill>
@@ -11083,18 +10852,7 @@
                 <a:ea typeface="Be Vietnam Pro" pitchFamily="34" charset="-122"/>
                 <a:cs typeface="Be Vietnam Pro" pitchFamily="34" charset="-120"/>
               </a:rPr>
-              <a:t>nhất</a:t>
-            </a:r>
-            <a:r>
-              <a:rPr lang="en-US" sz="1950" dirty="0" spc="17" kern="0">
-                <a:solidFill>
-                  <a:srgbClr val="14161C"/>
-                </a:solidFill>
-                <a:latin typeface="Be Vietnam Pro" pitchFamily="34" charset="0"/>
-                <a:ea typeface="Be Vietnam Pro" pitchFamily="34" charset="-122"/>
-                <a:cs typeface="Be Vietnam Pro" pitchFamily="34" charset="-120"/>
-              </a:rPr>
-              <a:t> định</a:t>
+              <a:t>CAS</a:t>
             </a:r>
             <a:endParaRPr lang="en-US" sz="1950" dirty="0"/>
           </a:p>
@@ -11268,7 +11026,7 @@
               <a:buNone/>
             </a:pPr>
             <a:r>
-              <a:rPr lang="en-US" sz="6900" dirty="0" spc="0" kern="0">
+              <a:rPr lang="en-US" sz="6900" dirty="0" spc="-43" kern="0">
                 <a:solidFill>
                   <a:srgbClr val="F3EEE3"/>
                 </a:solidFill>
@@ -11276,29 +11034,7 @@
                 <a:ea typeface="Bricolage Grotesque ExtraBold" pitchFamily="34" charset="-122"/>
                 <a:cs typeface="Bricolage Grotesque ExtraBold" pitchFamily="34" charset="-120"/>
               </a:rPr>
-              <a:t>Giữ</a:t>
-            </a:r>
-            <a:r>
-              <a:rPr lang="en-US" sz="6900" dirty="0" spc="-2" kern="0">
-                <a:solidFill>
-                  <a:srgbClr val="F3EEE3"/>
-                </a:solidFill>
-                <a:latin typeface="Bricolage Grotesque ExtraBold" pitchFamily="34" charset="0"/>
-                <a:ea typeface="Bricolage Grotesque ExtraBold" pitchFamily="34" charset="-122"/>
-                <a:cs typeface="Bricolage Grotesque ExtraBold" pitchFamily="34" charset="-120"/>
-              </a:rPr>
-              <a:t> B</a:t>
-            </a:r>
-            <a:r>
-              <a:rPr lang="en-US" sz="6900" dirty="0" spc="0" kern="0">
-                <a:solidFill>
-                  <a:srgbClr val="F3EEE3"/>
-                </a:solidFill>
-                <a:latin typeface="Bricolage Grotesque ExtraBold" pitchFamily="34" charset="0"/>
-                <a:ea typeface="Bricolage Grotesque ExtraBold" pitchFamily="34" charset="-122"/>
-                <a:cs typeface="Bricolage Grotesque ExtraBold" pitchFamily="34" charset="-120"/>
-              </a:rPr>
-              <a:t> lại</a:t>
+              <a:t>Đợi</a:t>
             </a:r>
             <a:endParaRPr lang="en-US" sz="6900" dirty="0"/>
           </a:p>
@@ -11318,10 +11054,10 @@
                 <a:ea typeface="Bricolage Grotesque ExtraBold" pitchFamily="34" charset="-122"/>
                 <a:cs typeface="Bricolage Grotesque ExtraBold" pitchFamily="34" charset="-120"/>
               </a:rPr>
-              <a:t>hay</a:t>
-            </a:r>
-            <a:r>
-              <a:rPr lang="en-US" sz="6900" dirty="0" spc="-4" kern="0">
+              <a:t>hay thử</a:t>
+            </a:r>
+            <a:r>
+              <a:rPr lang="en-US" sz="6900" dirty="0" spc="1" kern="0">
                 <a:solidFill>
                   <a:srgbClr val="F3EEE3"/>
                 </a:solidFill>
@@ -11329,29 +11065,7 @@
                 <a:ea typeface="Bricolage Grotesque ExtraBold" pitchFamily="34" charset="-122"/>
                 <a:cs typeface="Bricolage Grotesque ExtraBold" pitchFamily="34" charset="-120"/>
               </a:rPr>
-              <a:t> báo</a:t>
-            </a:r>
-            <a:r>
-              <a:rPr lang="en-US" sz="6900" dirty="0" spc="-1" kern="0">
-                <a:solidFill>
-                  <a:srgbClr val="F3EEE3"/>
-                </a:solidFill>
-                <a:latin typeface="Bricolage Grotesque ExtraBold" pitchFamily="34" charset="0"/>
-                <a:ea typeface="Bricolage Grotesque ExtraBold" pitchFamily="34" charset="-122"/>
-                <a:cs typeface="Bricolage Grotesque ExtraBold" pitchFamily="34" charset="-120"/>
-              </a:rPr>
-              <a:t> cho</a:t>
-            </a:r>
-            <a:r>
-              <a:rPr lang="en-US" sz="6900" dirty="0" spc="-2" kern="0">
-                <a:solidFill>
-                  <a:srgbClr val="F3EEE3"/>
-                </a:solidFill>
-                <a:latin typeface="Bricolage Grotesque ExtraBold" pitchFamily="34" charset="0"/>
-                <a:ea typeface="Bricolage Grotesque ExtraBold" pitchFamily="34" charset="-122"/>
-                <a:cs typeface="Bricolage Grotesque ExtraBold" pitchFamily="34" charset="-120"/>
-              </a:rPr>
-              <a:t> B</a:t>
+              <a:t> lại</a:t>
             </a:r>
             <a:endParaRPr lang="en-US" sz="6900" dirty="0"/>
           </a:p>
@@ -11393,17 +11107,6 @@
               <a:t>B</a:t>
             </a:r>
             <a:r>
-              <a:rPr lang="en-US" sz="3000" b="1" dirty="0" spc="-4" kern="0">
-                <a:solidFill>
-                  <a:srgbClr val="F3EEE3"/>
-                </a:solidFill>
-                <a:latin typeface="Be Vietnam Pro" pitchFamily="34" charset="0"/>
-                <a:ea typeface="Be Vietnam Pro" pitchFamily="34" charset="-122"/>
-                <a:cs typeface="Be Vietnam Pro" pitchFamily="34" charset="-120"/>
-              </a:rPr>
-              <a:t> phải</a:t>
-            </a:r>
-            <a:r>
               <a:rPr lang="en-US" sz="3000" b="1" dirty="0" spc="-1" kern="0">
                 <a:solidFill>
                   <a:srgbClr val="F3EEE3"/>
@@ -11437,37 +11140,48 @@
               <a:t> khi</a:t>
             </a:r>
             <a:r>
-              <a:rPr lang="en-US" sz="3000" b="1" dirty="0" spc="4" kern="0">
-                <a:solidFill>
-                  <a:srgbClr val="F3EEE3"/>
-                </a:solidFill>
-                <a:latin typeface="Be Vietnam Pro" pitchFamily="34" charset="0"/>
-                <a:ea typeface="Be Vietnam Pro" pitchFamily="34" charset="-122"/>
-                <a:cs typeface="Be Vietnam Pro" pitchFamily="34" charset="-120"/>
-              </a:rPr>
-              <a:t> bị</a:t>
-            </a:r>
-            <a:r>
-              <a:rPr lang="en-US" sz="3000" b="1" dirty="0" spc="2" kern="0">
-                <a:solidFill>
-                  <a:srgbClr val="F3EEE3"/>
-                </a:solidFill>
-                <a:latin typeface="Be Vietnam Pro" pitchFamily="34" charset="0"/>
-                <a:ea typeface="Be Vietnam Pro" pitchFamily="34" charset="-122"/>
-                <a:cs typeface="Be Vietnam Pro" pitchFamily="34" charset="-120"/>
-              </a:rPr>
-              <a:t> từ</a:t>
-            </a:r>
-            <a:r>
-              <a:rPr lang="en-US" sz="3000" b="1" dirty="0" spc="-3" kern="0">
-                <a:solidFill>
-                  <a:srgbClr val="F3EEE3"/>
-                </a:solidFill>
-                <a:latin typeface="Be Vietnam Pro" pitchFamily="34" charset="0"/>
-                <a:ea typeface="Be Vietnam Pro" pitchFamily="34" charset="-122"/>
-                <a:cs typeface="Be Vietnam Pro" pitchFamily="34" charset="-120"/>
-              </a:rPr>
-              <a:t> chối</a:t>
+              <a:rPr lang="en-US" sz="3000" b="1" dirty="0" spc="12" kern="0">
+                <a:solidFill>
+                  <a:srgbClr val="F3EEE3"/>
+                </a:solidFill>
+                <a:latin typeface="Be Vietnam Pro" pitchFamily="34" charset="0"/>
+                <a:ea typeface="Be Vietnam Pro" pitchFamily="34" charset="-122"/>
+                <a:cs typeface="Be Vietnam Pro" pitchFamily="34" charset="-120"/>
+              </a:rPr>
+              <a:t> chưa</a:t>
+            </a:r>
+            <a:r>
+              <a:rPr lang="en-US" sz="3000" b="1" dirty="0" spc="0" kern="0">
+                <a:solidFill>
+                  <a:srgbClr val="F3EEE3"/>
+                </a:solidFill>
+                <a:latin typeface="Be Vietnam Pro" pitchFamily="34" charset="0"/>
+                <a:ea typeface="Be Vietnam Pro" pitchFamily="34" charset="-122"/>
+                <a:cs typeface="Be Vietnam Pro" pitchFamily="34" charset="-120"/>
+              </a:rPr>
+              <a:t> làm</a:t>
+            </a:r>
+            <a:r>
+              <a:rPr lang="en-US" sz="3000" b="1" dirty="0" spc="13" kern="0">
+                <a:solidFill>
+                  <a:srgbClr val="F3EEE3"/>
+                </a:solidFill>
+                <a:latin typeface="Be Vietnam Pro" pitchFamily="34" charset="0"/>
+                <a:ea typeface="Be Vietnam Pro" pitchFamily="34" charset="-122"/>
+                <a:cs typeface="Be Vietnam Pro" pitchFamily="34" charset="-120"/>
+              </a:rPr>
+              <a:t> được</a:t>
+            </a:r>
+            <a:r>
+              <a:rPr lang="en-US" sz="3000" b="1" dirty="0" spc="-15" kern="0">
+                <a:solidFill>
+                  <a:srgbClr val="F3EEE3"/>
+                </a:solidFill>
+                <a:latin typeface="Be Vietnam Pro" pitchFamily="34" charset="0"/>
+                <a:ea typeface="Be Vietnam Pro" pitchFamily="34" charset="-122"/>
+                <a:cs typeface="Be Vietnam Pro" pitchFamily="34" charset="-120"/>
+              </a:rPr>
+              <a:t> ngay</a:t>
             </a:r>
             <a:endParaRPr lang="en-US" sz="3000" dirty="0"/>
           </a:p>
@@ -11567,7 +11281,7 @@
               <a:t> khi</a:t>
             </a:r>
             <a:r>
-              <a:rPr lang="en-US" sz="2550" dirty="0" spc="-3" kern="0">
+              <a:rPr lang="en-US" sz="2550" dirty="0" spc="1" kern="0">
                 <a:solidFill>
                   <a:srgbClr val="C4C8D6"/>
                 </a:solidFill>
@@ -11575,10 +11289,10 @@
                 <a:ea typeface="Be Vietnam Pro" pitchFamily="34" charset="-122"/>
                 <a:cs typeface="Be Vietnam Pro" pitchFamily="34" charset="-120"/>
               </a:rPr>
-              <a:t> khóa</a:t>
-            </a:r>
-            <a:r>
-              <a:rPr lang="en-US" sz="2550" dirty="0" spc="7" kern="0">
+              <a:t> làm</a:t>
+            </a:r>
+            <a:r>
+              <a:rPr lang="en-US" sz="2550" dirty="0" spc="6" kern="0">
                 <a:solidFill>
                   <a:srgbClr val="C4C8D6"/>
                 </a:solidFill>
@@ -11586,7 +11300,18 @@
                 <a:ea typeface="Be Vietnam Pro" pitchFamily="34" charset="-122"/>
                 <a:cs typeface="Be Vietnam Pro" pitchFamily="34" charset="-120"/>
               </a:rPr>
-              <a:t> được</a:t>
+              <a:t> được.</a:t>
+            </a:r>
+            <a:r>
+              <a:rPr lang="en-US" sz="2550" dirty="0" spc="-1" kern="0">
+                <a:solidFill>
+                  <a:srgbClr val="C4C8D6"/>
+                </a:solidFill>
+                <a:latin typeface="Be Vietnam Pro" pitchFamily="34" charset="0"/>
+                <a:ea typeface="Be Vietnam Pro" pitchFamily="34" charset="-122"/>
+                <a:cs typeface="Be Vietnam Pro" pitchFamily="34" charset="-120"/>
+              </a:rPr>
+              <a:t> Không</a:t>
             </a:r>
             <a:r>
               <a:rPr lang="en-US" sz="2550" dirty="0" spc="0" kern="0">
@@ -11597,7 +11322,62 @@
                 <a:ea typeface="Be Vietnam Pro" pitchFamily="34" charset="-122"/>
                 <a:cs typeface="Be Vietnam Pro" pitchFamily="34" charset="-120"/>
               </a:rPr>
-              <a:t> nhả.</a:t>
+              <a:t> chặn</a:t>
+            </a:r>
+            <a:r>
+              <a:rPr lang="en-US" sz="2550" dirty="0" spc="17" kern="0">
+                <a:solidFill>
+                  <a:srgbClr val="C4C8D6"/>
+                </a:solidFill>
+                <a:latin typeface="Be Vietnam Pro" pitchFamily="34" charset="0"/>
+                <a:ea typeface="Be Vietnam Pro" pitchFamily="34" charset="-122"/>
+                <a:cs typeface="Be Vietnam Pro" pitchFamily="34" charset="-120"/>
+              </a:rPr>
+              <a:t> để</a:t>
+            </a:r>
+            <a:r>
+              <a:rPr lang="en-US" sz="2550" dirty="0" spc="3" kern="0">
+                <a:solidFill>
+                  <a:srgbClr val="C4C8D6"/>
+                </a:solidFill>
+                <a:latin typeface="Be Vietnam Pro" pitchFamily="34" charset="0"/>
+                <a:ea typeface="Be Vietnam Pro" pitchFamily="34" charset="-122"/>
+                <a:cs typeface="Be Vietnam Pro" pitchFamily="34" charset="-120"/>
+              </a:rPr>
+              <a:t> B</a:t>
+            </a:r>
+            <a:r>
+              <a:rPr lang="en-US" sz="2550" dirty="0" spc="10" kern="0">
+                <a:solidFill>
+                  <a:srgbClr val="C4C8D6"/>
+                </a:solidFill>
+                <a:latin typeface="Be Vietnam Pro" pitchFamily="34" charset="0"/>
+                <a:ea typeface="Be Vietnam Pro" pitchFamily="34" charset="-122"/>
+                <a:cs typeface="Be Vietnam Pro" pitchFamily="34" charset="-120"/>
+              </a:rPr>
+              <a:t> đọc</a:t>
+            </a:r>
+            <a:r>
+              <a:rPr lang="en-US" sz="2550" dirty="0" spc="0" kern="0">
+                <a:solidFill>
+                  <a:srgbClr val="C4C8D6"/>
+                </a:solidFill>
+                <a:latin typeface="Be Vietnam Pro" pitchFamily="34" charset="0"/>
+                <a:ea typeface="Be Vietnam Pro" pitchFamily="34" charset="-122"/>
+                <a:cs typeface="Be Vietnam Pro" pitchFamily="34" charset="-120"/>
+              </a:rPr>
+              <a:t> lại</a:t>
+            </a:r>
+            <a:r>
+              <a:rPr lang="en-US" sz="2550" dirty="0" spc="-19" kern="0">
+                <a:solidFill>
+                  <a:srgbClr val="C4C8D6"/>
+                </a:solidFill>
+                <a:latin typeface="Be Vietnam Pro" pitchFamily="34" charset="0"/>
+                <a:ea typeface="Be Vietnam Pro" pitchFamily="34" charset="-122"/>
+                <a:cs typeface="Be Vietnam Pro" pitchFamily="34" charset="-120"/>
+              </a:rPr>
+              <a:t> và</a:t>
             </a:r>
             <a:r>
               <a:rPr lang="en-US" sz="2550" dirty="0" spc="-1" kern="0">
@@ -11608,10 +11388,10 @@
                 <a:ea typeface="Be Vietnam Pro" pitchFamily="34" charset="-122"/>
                 <a:cs typeface="Be Vietnam Pro" pitchFamily="34" charset="-120"/>
               </a:rPr>
-              <a:t> Không</a:t>
-            </a:r>
-            <a:r>
-              <a:rPr lang="en-US" sz="2550" dirty="0" spc="0" kern="0">
+              <a:t> thử</a:t>
+            </a:r>
+            <a:r>
+              <a:rPr lang="en-US" sz="2550" dirty="0" spc="1" kern="0">
                 <a:solidFill>
                   <a:srgbClr val="C4C8D6"/>
                 </a:solidFill>
@@ -11619,73 +11399,7 @@
                 <a:ea typeface="Be Vietnam Pro" pitchFamily="34" charset="-122"/>
                 <a:cs typeface="Be Vietnam Pro" pitchFamily="34" charset="-120"/>
               </a:rPr>
-              <a:t> chặn</a:t>
-            </a:r>
-            <a:r>
-              <a:rPr lang="en-US" sz="2550" dirty="0" spc="-3" kern="0">
-                <a:solidFill>
-                  <a:srgbClr val="C4C8D6"/>
-                </a:solidFill>
-                <a:latin typeface="Be Vietnam Pro" pitchFamily="34" charset="0"/>
-                <a:ea typeface="Be Vietnam Pro" pitchFamily="34" charset="-122"/>
-                <a:cs typeface="Be Vietnam Pro" pitchFamily="34" charset="-120"/>
-              </a:rPr>
-              <a:t> báo</a:t>
-            </a:r>
-            <a:r>
-              <a:rPr lang="en-US" sz="2550" dirty="0" spc="4" kern="0">
-                <a:solidFill>
-                  <a:srgbClr val="C4C8D6"/>
-                </a:solidFill>
-                <a:latin typeface="Be Vietnam Pro" pitchFamily="34" charset="0"/>
-                <a:ea typeface="Be Vietnam Pro" pitchFamily="34" charset="-122"/>
-                <a:cs typeface="Be Vietnam Pro" pitchFamily="34" charset="-120"/>
-              </a:rPr>
-              <a:t> B</a:t>
-            </a:r>
-            <a:r>
-              <a:rPr lang="en-US" sz="2550" dirty="0" spc="-4" kern="0">
-                <a:solidFill>
-                  <a:srgbClr val="C4C8D6"/>
-                </a:solidFill>
-                <a:latin typeface="Be Vietnam Pro" pitchFamily="34" charset="0"/>
-                <a:ea typeface="Be Vietnam Pro" pitchFamily="34" charset="-122"/>
-                <a:cs typeface="Be Vietnam Pro" pitchFamily="34" charset="-120"/>
-              </a:rPr>
-              <a:t> biết</a:t>
-            </a:r>
-            <a:r>
-              <a:rPr lang="en-US" sz="2550" dirty="0" spc="0" kern="0">
-                <a:solidFill>
-                  <a:srgbClr val="C4C8D6"/>
-                </a:solidFill>
-                <a:latin typeface="Be Vietnam Pro" pitchFamily="34" charset="0"/>
-                <a:ea typeface="Be Vietnam Pro" pitchFamily="34" charset="-122"/>
-                <a:cs typeface="Be Vietnam Pro" pitchFamily="34" charset="-120"/>
-              </a:rPr>
-              <a:t> bị</a:t>
-            </a:r>
-            <a:r>
-              <a:rPr lang="en-US" sz="2550" dirty="0" spc="-1" kern="0">
-                <a:solidFill>
-                  <a:srgbClr val="C4C8D6"/>
-                </a:solidFill>
-                <a:latin typeface="Be Vietnam Pro" pitchFamily="34" charset="0"/>
-                <a:ea typeface="Be Vietnam Pro" pitchFamily="34" charset="-122"/>
-                <a:cs typeface="Be Vietnam Pro" pitchFamily="34" charset="-120"/>
-              </a:rPr>
-              <a:t> từ</a:t>
-            </a:r>
-            <a:r>
-              <a:rPr lang="en-US" sz="2550" dirty="0" spc="0" kern="0">
-                <a:solidFill>
-                  <a:srgbClr val="C4C8D6"/>
-                </a:solidFill>
-                <a:latin typeface="Be Vietnam Pro" pitchFamily="34" charset="0"/>
-                <a:ea typeface="Be Vietnam Pro" pitchFamily="34" charset="-122"/>
-                <a:cs typeface="Be Vietnam Pro" pitchFamily="34" charset="-120"/>
-              </a:rPr>
-              <a:t> chối.</a:t>
+              <a:t> tiếp.</a:t>
             </a:r>
             <a:endParaRPr lang="en-US" sz="2550" dirty="0"/>
           </a:p>
@@ -11774,7 +11488,7 @@
               <a:buNone/>
             </a:pPr>
             <a:r>
-              <a:rPr lang="en-US" sz="2100" b="1" dirty="0" spc="4" kern="0">
+              <a:rPr lang="en-US" sz="2100" b="1" dirty="0" spc="1" kern="0">
                 <a:solidFill>
                   <a:srgbClr val="14161C"/>
                 </a:solidFill>
@@ -11782,10 +11496,10 @@
                 <a:ea typeface="Be Vietnam Pro" pitchFamily="34" charset="-122"/>
                 <a:cs typeface="Be Vietnam Pro" pitchFamily="34" charset="-120"/>
               </a:rPr>
-              <a:t>Báo</a:t>
-            </a:r>
-            <a:r>
-              <a:rPr lang="en-US" sz="2100" b="1" dirty="0" spc="-6" kern="0">
+              <a:t>B</a:t>
+            </a:r>
+            <a:r>
+              <a:rPr lang="en-US" sz="2100" b="1" dirty="0" spc="-2" kern="0">
                 <a:solidFill>
                   <a:srgbClr val="14161C"/>
                 </a:solidFill>
@@ -11793,10 +11507,10 @@
                 <a:ea typeface="Be Vietnam Pro" pitchFamily="34" charset="-122"/>
                 <a:cs typeface="Be Vietnam Pro" pitchFamily="34" charset="-120"/>
               </a:rPr>
-              <a:t> cho</a:t>
-            </a:r>
-            <a:r>
-              <a:rPr lang="en-US" sz="2100" b="1" dirty="0" spc="-2" kern="0">
+              <a:t> thử</a:t>
+            </a:r>
+            <a:r>
+              <a:rPr lang="en-US" sz="2100" b="1" dirty="0" spc="-1" kern="0">
                 <a:solidFill>
                   <a:srgbClr val="14161C"/>
                 </a:solidFill>
@@ -11804,7 +11518,7 @@
                 <a:ea typeface="Be Vietnam Pro" pitchFamily="34" charset="-122"/>
                 <a:cs typeface="Be Vietnam Pro" pitchFamily="34" charset="-120"/>
               </a:rPr>
-              <a:t> B</a:t>
+              <a:t> lại</a:t>
             </a:r>
             <a:endParaRPr lang="en-US" sz="2100" dirty="0"/>
           </a:p>
@@ -11929,10 +11643,10 @@
                 <a:ea typeface="Be Vietnam Pro" pitchFamily="34" charset="-122"/>
                 <a:cs typeface="Be Vietnam Pro" pitchFamily="34" charset="-120"/>
               </a:rPr>
-              <a:t> chặn chỉ</a:t>
-            </a:r>
-            <a:r>
-              <a:rPr lang="en-US" sz="2550" dirty="0" spc="13" kern="0">
+              <a:t> chặn</a:t>
+            </a:r>
+            <a:r>
+              <a:rPr lang="en-US" sz="2550" dirty="0" spc="12" kern="0">
                 <a:solidFill>
                   <a:srgbClr val="F3EEE3"/>
                 </a:solidFill>
@@ -11943,6 +11657,50 @@
               <a:t> đổi</a:t>
             </a:r>
             <a:r>
+              <a:rPr lang="en-US" sz="2550" dirty="0" spc="-12" kern="0">
+                <a:solidFill>
+                  <a:srgbClr val="F3EEE3"/>
+                </a:solidFill>
+                <a:latin typeface="Be Vietnam Pro" pitchFamily="34" charset="0"/>
+                <a:ea typeface="Be Vietnam Pro" pitchFamily="34" charset="-122"/>
+                <a:cs typeface="Be Vietnam Pro" pitchFamily="34" charset="-120"/>
+              </a:rPr>
+              <a:t> chuyện</a:t>
+            </a:r>
+            <a:r>
+              <a:rPr lang="en-US" sz="2550" dirty="0" spc="12" kern="0">
+                <a:solidFill>
+                  <a:srgbClr val="F3EEE3"/>
+                </a:solidFill>
+                <a:latin typeface="Be Vietnam Pro" pitchFamily="34" charset="0"/>
+                <a:ea typeface="Be Vietnam Pro" pitchFamily="34" charset="-122"/>
+                <a:cs typeface="Be Vietnam Pro" pitchFamily="34" charset="-120"/>
+              </a:rPr>
+              <a:t> đợi</a:t>
+            </a:r>
+            <a:r>
+              <a:rPr lang="en-US" sz="2550" dirty="0" spc="1" kern="0">
+                <a:solidFill>
+                  <a:srgbClr val="F3EEE3"/>
+                </a:solidFill>
+                <a:latin typeface="Be Vietnam Pro" pitchFamily="34" charset="0"/>
+                <a:ea typeface="Be Vietnam Pro" pitchFamily="34" charset="-122"/>
+                <a:cs typeface="Be Vietnam Pro" pitchFamily="34" charset="-120"/>
+              </a:rPr>
+              <a:t> thành</a:t>
+            </a:r>
+            <a:r>
+              <a:rPr lang="en-US" sz="2550" dirty="0" spc="-1" kern="0">
+                <a:solidFill>
+                  <a:srgbClr val="F3EEE3"/>
+                </a:solidFill>
+                <a:latin typeface="Be Vietnam Pro" pitchFamily="34" charset="0"/>
+                <a:ea typeface="Be Vietnam Pro" pitchFamily="34" charset="-122"/>
+                <a:cs typeface="Be Vietnam Pro" pitchFamily="34" charset="-120"/>
+              </a:rPr>
+              <a:t> thử</a:t>
+            </a:r>
+            <a:r>
               <a:rPr lang="en-US" sz="2550" dirty="0" spc="0" kern="0">
                 <a:solidFill>
                   <a:srgbClr val="F3EEE3"/>
@@ -11951,62 +11709,7 @@
                 <a:ea typeface="Be Vietnam Pro" pitchFamily="34" charset="-122"/>
                 <a:cs typeface="Be Vietnam Pro" pitchFamily="34" charset="-120"/>
               </a:rPr>
-              <a:t> cách</a:t>
-            </a:r>
-            <a:r>
-              <a:rPr lang="en-US" sz="2550" dirty="0" spc="3" kern="0">
-                <a:solidFill>
-                  <a:srgbClr val="F3EEE3"/>
-                </a:solidFill>
-                <a:latin typeface="Be Vietnam Pro" pitchFamily="34" charset="0"/>
-                <a:ea typeface="Be Vietnam Pro" pitchFamily="34" charset="-122"/>
-                <a:cs typeface="Be Vietnam Pro" pitchFamily="34" charset="-120"/>
-              </a:rPr>
-              <a:t> B</a:t>
-            </a:r>
-            <a:r>
-              <a:rPr lang="en-US" sz="2550" dirty="0" spc="-4" kern="0">
-                <a:solidFill>
-                  <a:srgbClr val="F3EEE3"/>
-                </a:solidFill>
-                <a:latin typeface="Be Vietnam Pro" pitchFamily="34" charset="0"/>
-                <a:ea typeface="Be Vietnam Pro" pitchFamily="34" charset="-122"/>
-                <a:cs typeface="Be Vietnam Pro" pitchFamily="34" charset="-120"/>
-              </a:rPr>
-              <a:t> biết</a:t>
-            </a:r>
-            <a:r>
-              <a:rPr lang="en-US" sz="2550" dirty="0" spc="0" kern="0">
-                <a:solidFill>
-                  <a:srgbClr val="F3EEE3"/>
-                </a:solidFill>
-                <a:latin typeface="Be Vietnam Pro" pitchFamily="34" charset="0"/>
-                <a:ea typeface="Be Vietnam Pro" pitchFamily="34" charset="-122"/>
-                <a:cs typeface="Be Vietnam Pro" pitchFamily="34" charset="-120"/>
-              </a:rPr>
-              <a:t> mình</a:t>
-            </a:r>
-            <a:r>
-              <a:rPr lang="en-US" sz="2550" dirty="0" spc="1" kern="0">
-                <a:solidFill>
-                  <a:srgbClr val="F3EEE3"/>
-                </a:solidFill>
-                <a:latin typeface="Be Vietnam Pro" pitchFamily="34" charset="0"/>
-                <a:ea typeface="Be Vietnam Pro" pitchFamily="34" charset="-122"/>
-                <a:cs typeface="Be Vietnam Pro" pitchFamily="34" charset="-120"/>
-              </a:rPr>
-              <a:t> bị</a:t>
-            </a:r>
-            <a:r>
-              <a:rPr lang="en-US" sz="2550" dirty="0" spc="0" kern="0">
-                <a:solidFill>
-                  <a:srgbClr val="F3EEE3"/>
-                </a:solidFill>
-                <a:latin typeface="Be Vietnam Pro" pitchFamily="34" charset="0"/>
-                <a:ea typeface="Be Vietnam Pro" pitchFamily="34" charset="-122"/>
-                <a:cs typeface="Be Vietnam Pro" pitchFamily="34" charset="-120"/>
-              </a:rPr>
-              <a:t> từ chối.</a:t>
+              <a:t> lại.</a:t>
             </a:r>
             <a:endParaRPr lang="en-US" sz="2550" dirty="0"/>
           </a:p>
@@ -12398,29 +12101,40 @@
                 <a:ea typeface="Be Vietnam Pro" pitchFamily="34" charset="-122"/>
                 <a:cs typeface="Be Vietnam Pro" pitchFamily="34" charset="-120"/>
               </a:rPr>
-              <a:t>B bị từ</a:t>
-            </a:r>
-            <a:r>
-              <a:rPr lang="en-US" sz="2400" b="1" dirty="0" spc="-3" kern="0">
-                <a:solidFill>
-                  <a:srgbClr val="F3EEE3"/>
-                </a:solidFill>
-                <a:latin typeface="Be Vietnam Pro" pitchFamily="34" charset="0"/>
-                <a:ea typeface="Be Vietnam Pro" pitchFamily="34" charset="-122"/>
-                <a:cs typeface="Be Vietnam Pro" pitchFamily="34" charset="-120"/>
-              </a:rPr>
-              <a:t> chối</a:t>
-            </a:r>
-            <a:r>
-              <a:rPr lang="en-US" sz="2400" b="1" dirty="0" spc="-14" kern="0">
-                <a:solidFill>
-                  <a:srgbClr val="F3EEE3"/>
-                </a:solidFill>
-                <a:latin typeface="Be Vietnam Pro" pitchFamily="34" charset="0"/>
-                <a:ea typeface="Be Vietnam Pro" pitchFamily="34" charset="-122"/>
-                <a:cs typeface="Be Vietnam Pro" pitchFamily="34" charset="-120"/>
-              </a:rPr>
-              <a:t> ngay</a:t>
+              <a:t>B</a:t>
+            </a:r>
+            <a:r>
+              <a:rPr lang="en-US" sz="2400" b="1" dirty="0" spc="0" kern="0">
+                <a:solidFill>
+                  <a:srgbClr val="F3EEE3"/>
+                </a:solidFill>
+                <a:latin typeface="Be Vietnam Pro" pitchFamily="34" charset="0"/>
+                <a:ea typeface="Be Vietnam Pro" pitchFamily="34" charset="-122"/>
+                <a:cs typeface="Be Vietnam Pro" pitchFamily="34" charset="-120"/>
+              </a:rPr>
+              <a:t> thua</a:t>
+            </a:r>
+            <a:r>
+              <a:rPr lang="en-US" sz="2400" b="1" dirty="0" spc="1" kern="0">
+                <a:solidFill>
+                  <a:srgbClr val="F3EEE3"/>
+                </a:solidFill>
+                <a:latin typeface="Be Vietnam Pro" pitchFamily="34" charset="0"/>
+                <a:ea typeface="Be Vietnam Pro" pitchFamily="34" charset="-122"/>
+                <a:cs typeface="Be Vietnam Pro" pitchFamily="34" charset="-120"/>
+              </a:rPr>
+              <a:t> thì thử</a:t>
+            </a:r>
+            <a:r>
+              <a:rPr lang="en-US" sz="2400" b="1" dirty="0" spc="0" kern="0">
+                <a:solidFill>
+                  <a:srgbClr val="F3EEE3"/>
+                </a:solidFill>
+                <a:latin typeface="Be Vietnam Pro" pitchFamily="34" charset="0"/>
+                <a:ea typeface="Be Vietnam Pro" pitchFamily="34" charset="-122"/>
+                <a:cs typeface="Be Vietnam Pro" pitchFamily="34" charset="-120"/>
+              </a:rPr>
+              <a:t> lại</a:t>
             </a:r>
             <a:endParaRPr lang="en-US" sz="2400" dirty="0"/>
           </a:p>
@@ -12462,7 +12176,7 @@
               <a:t>B</a:t>
             </a:r>
             <a:r>
-              <a:rPr lang="en-US" sz="1800" b="1" spc="225" kern="0" dirty="0">
+              <a:rPr lang="en-US" sz="1800" b="1" spc="224" kern="0" dirty="0">
                 <a:solidFill>
                   <a:srgbClr val="9AA0B5"/>
                 </a:solidFill>
@@ -12470,7 +12184,7 @@
                 <a:ea typeface="Be Vietnam Pro" pitchFamily="34" charset="-122"/>
                 <a:cs typeface="Be Vietnam Pro" pitchFamily="34" charset="-120"/>
               </a:rPr>
-              <a:t> NHẬN PHẢN</a:t>
+              <a:t> ĐI TIẾP</a:t>
             </a:r>
             <a:r>
               <a:rPr lang="en-US" sz="1800" b="1" spc="226" kern="0" dirty="0">
@@ -12481,7 +12195,18 @@
                 <a:ea typeface="Be Vietnam Pro" pitchFamily="34" charset="-122"/>
                 <a:cs typeface="Be Vietnam Pro" pitchFamily="34" charset="-120"/>
               </a:rPr>
-              <a:t> HỒI</a:t>
+              <a:t> KHI</a:t>
+            </a:r>
+            <a:r>
+              <a:rPr lang="en-US" sz="1800" b="1" spc="209" kern="0" dirty="0">
+                <a:solidFill>
+                  <a:srgbClr val="9AA0B5"/>
+                </a:solidFill>
+                <a:latin typeface="Be Vietnam Pro" pitchFamily="34" charset="0"/>
+                <a:ea typeface="Be Vietnam Pro" pitchFamily="34" charset="-122"/>
+                <a:cs typeface="Be Vietnam Pro" pitchFamily="34" charset="-120"/>
+              </a:rPr>
+              <a:t> NÀO</a:t>
             </a:r>
             <a:endParaRPr lang="en-US" sz="1800" dirty="0"/>
           </a:p>
@@ -12602,26 +12327,48 @@
               <a:buNone/>
             </a:pPr>
             <a:r>
-              <a:rPr lang="en-US" sz="2400" b="1" dirty="0" spc="8" kern="0">
-                <a:solidFill>
-                  <a:srgbClr val="F3EEE3"/>
-                </a:solidFill>
-                <a:latin typeface="Be Vietnam Pro" pitchFamily="34" charset="0"/>
-                <a:ea typeface="Be Vietnam Pro" pitchFamily="34" charset="-122"/>
-                <a:cs typeface="Be Vietnam Pro" pitchFamily="34" charset="-120"/>
-              </a:rPr>
-              <a:t>Báo</a:t>
-            </a:r>
-            <a:r>
-              <a:rPr lang="en-US" sz="2400" b="1" dirty="0" spc="-14" kern="0">
-                <a:solidFill>
-                  <a:srgbClr val="F3EEE3"/>
-                </a:solidFill>
-                <a:latin typeface="Be Vietnam Pro" pitchFamily="34" charset="0"/>
-                <a:ea typeface="Be Vietnam Pro" pitchFamily="34" charset="-122"/>
-                <a:cs typeface="Be Vietnam Pro" pitchFamily="34" charset="-120"/>
-              </a:rPr>
-              <a:t> ngay</a:t>
+              <a:rPr lang="en-US" sz="2400" b="1" dirty="0" spc="5" kern="0">
+                <a:solidFill>
+                  <a:srgbClr val="F3EEE3"/>
+                </a:solidFill>
+                <a:latin typeface="Be Vietnam Pro" pitchFamily="34" charset="0"/>
+                <a:ea typeface="Be Vietnam Pro" pitchFamily="34" charset="-122"/>
+                <a:cs typeface="Be Vietnam Pro" pitchFamily="34" charset="-120"/>
+              </a:rPr>
+              <a:t>Sau</a:t>
+            </a:r>
+            <a:r>
+              <a:rPr lang="en-US" sz="2400" b="1" dirty="0" spc="-2" kern="0">
+                <a:solidFill>
+                  <a:srgbClr val="F3EEE3"/>
+                </a:solidFill>
+                <a:latin typeface="Be Vietnam Pro" pitchFamily="34" charset="0"/>
+                <a:ea typeface="Be Vietnam Pro" pitchFamily="34" charset="-122"/>
+                <a:cs typeface="Be Vietnam Pro" pitchFamily="34" charset="-120"/>
+              </a:rPr>
+              <a:t> mỗi</a:t>
+            </a:r>
+            <a:r>
+              <a:rPr lang="en-US" sz="2400" b="1" dirty="0" spc="0" kern="0">
+                <a:solidFill>
+                  <a:srgbClr val="F3EEE3"/>
+                </a:solidFill>
+                <a:latin typeface="Be Vietnam Pro" pitchFamily="34" charset="0"/>
+                <a:ea typeface="Be Vietnam Pro" pitchFamily="34" charset="-122"/>
+                <a:cs typeface="Be Vietnam Pro" pitchFamily="34" charset="-120"/>
+              </a:rPr>
+              <a:t> lần</a:t>
+            </a:r>
+            <a:r>
+              <a:rPr lang="en-US" sz="2400" b="1" dirty="0" spc="1" kern="0">
+                <a:solidFill>
+                  <a:srgbClr val="F3EEE3"/>
+                </a:solidFill>
+                <a:latin typeface="Be Vietnam Pro" pitchFamily="34" charset="0"/>
+                <a:ea typeface="Be Vietnam Pro" pitchFamily="34" charset="-122"/>
+                <a:cs typeface="Be Vietnam Pro" pitchFamily="34" charset="-120"/>
+              </a:rPr>
+              <a:t> thử</a:t>
             </a:r>
             <a:endParaRPr lang="en-US" sz="2400" dirty="0"/>
           </a:p>
@@ -13861,7 +13608,7 @@
               <a:buNone/>
             </a:pPr>
             <a:r>
-              <a:rPr lang="en-US" sz="2550" dirty="0" spc="-25" kern="0">
+              <a:rPr lang="en-US" sz="2550" dirty="0" spc="-1" kern="0">
                 <a:solidFill>
                   <a:srgbClr val="14161C"/>
                 </a:solidFill>
@@ -13869,10 +13616,10 @@
                 <a:ea typeface="Be Vietnam Pro" pitchFamily="34" charset="-122"/>
                 <a:cs typeface="Be Vietnam Pro" pitchFamily="34" charset="-120"/>
               </a:rPr>
-              <a:t>Wait-free</a:t>
-            </a:r>
-            <a:r>
-              <a:rPr lang="en-US" sz="2550" dirty="0" spc="-2" kern="0">
+              <a:t>Không</a:t>
+            </a:r>
+            <a:r>
+              <a:rPr lang="en-US" sz="2550" dirty="0" spc="0" kern="0">
                 <a:solidFill>
                   <a:srgbClr val="14161C"/>
                 </a:solidFill>
@@ -13880,7 +13627,18 @@
                 <a:ea typeface="Be Vietnam Pro" pitchFamily="34" charset="-122"/>
                 <a:cs typeface="Be Vietnam Pro" pitchFamily="34" charset="-120"/>
               </a:rPr>
-              <a:t> bằng</a:t>
+              <a:t> chặn</a:t>
+            </a:r>
+            <a:r>
+              <a:rPr lang="en-US" sz="2550" dirty="0" spc="6" kern="0">
+                <a:solidFill>
+                  <a:srgbClr val="14161C"/>
+                </a:solidFill>
+                <a:latin typeface="Be Vietnam Pro" pitchFamily="34" charset="0"/>
+                <a:ea typeface="Be Vietnam Pro" pitchFamily="34" charset="-122"/>
+                <a:cs typeface="Be Vietnam Pro" pitchFamily="34" charset="-120"/>
+              </a:rPr>
+              <a:t> chưa</a:t>
             </a:r>
             <a:r>
               <a:rPr lang="en-US" sz="2550" dirty="0" spc="0" kern="0">
@@ -13891,7 +13649,7 @@
                 <a:ea typeface="Be Vietnam Pro" pitchFamily="34" charset="-122"/>
                 <a:cs typeface="Be Vietnam Pro" pitchFamily="34" charset="-120"/>
               </a:rPr>
-              <a:t> không chặn cộng</a:t>
+              <a:t> chắc</a:t>
             </a:r>
             <a:r>
               <a:rPr lang="en-US" sz="2550" dirty="0" spc="1" kern="0">
@@ -13902,7 +13660,7 @@
                 <a:ea typeface="Be Vietnam Pro" pitchFamily="34" charset="-122"/>
                 <a:cs typeface="Be Vietnam Pro" pitchFamily="34" charset="-120"/>
               </a:rPr>
-              <a:t> không</a:t>
+              <a:t> là luồng</a:t>
             </a:r>
             <a:r>
               <a:rPr lang="en-US" sz="2550" dirty="0" spc="0" kern="0">
@@ -13913,10 +13671,10 @@
                 <a:ea typeface="Be Vietnam Pro" pitchFamily="34" charset="-122"/>
                 <a:cs typeface="Be Vietnam Pro" pitchFamily="34" charset="-120"/>
               </a:rPr>
-              <a:t> bị</a:t>
-            </a:r>
-            <a:r>
-              <a:rPr lang="en-US" sz="2550" dirty="0" spc="-4" kern="0">
+              <a:t> nào</a:t>
+            </a:r>
+            <a:r>
+              <a:rPr lang="en-US" sz="2550" dirty="0" spc="-1" kern="0">
                 <a:solidFill>
                   <a:srgbClr val="14161C"/>
                 </a:solidFill>
@@ -13924,10 +13682,10 @@
                 <a:ea typeface="Be Vietnam Pro" pitchFamily="34" charset="-122"/>
                 <a:cs typeface="Be Vietnam Pro" pitchFamily="34" charset="-120"/>
               </a:rPr>
-              <a:t> bỏ</a:t>
-            </a:r>
-            <a:r>
-              <a:rPr lang="en-US" sz="2550" dirty="0" spc="10" kern="0">
+              <a:t> cũng</a:t>
+            </a:r>
+            <a:r>
+              <a:rPr lang="en-US" sz="2550" dirty="0" spc="-15" kern="0">
                 <a:solidFill>
                   <a:srgbClr val="14161C"/>
                 </a:solidFill>
@@ -13935,7 +13693,7 @@
                 <a:ea typeface="Be Vietnam Pro" pitchFamily="34" charset="-122"/>
                 <a:cs typeface="Be Vietnam Pro" pitchFamily="34" charset="-120"/>
               </a:rPr>
-              <a:t> đói.</a:t>
+              <a:t> xong ngay.</a:t>
             </a:r>
             <a:endParaRPr lang="en-US" sz="2550" dirty="0"/>
           </a:p>
@@ -13993,7 +13751,7 @@
               <a:buNone/>
             </a:pPr>
             <a:r>
-              <a:rPr lang="en-US" sz="1800" b="1" spc="209" kern="0" dirty="0">
+              <a:rPr lang="en-US" sz="1800" b="1" spc="216" kern="0" dirty="0">
                 <a:solidFill>
                   <a:srgbClr val="6B6A66"/>
                 </a:solidFill>
@@ -14001,10 +13759,10 @@
                 <a:ea typeface="Be Vietnam Pro" pitchFamily="34" charset="-122"/>
                 <a:cs typeface="Be Vietnam Pro" pitchFamily="34" charset="-120"/>
               </a:rPr>
-              <a:t>WAIT-FREE</a:t>
-            </a:r>
-            <a:r>
-              <a:rPr lang="en-US" sz="1800" b="1" spc="226" kern="0" dirty="0">
+              <a:t>BA</a:t>
+            </a:r>
+            <a:r>
+              <a:rPr lang="en-US" sz="1800" b="1" spc="225" kern="0" dirty="0">
                 <a:solidFill>
                   <a:srgbClr val="6B6A66"/>
                 </a:solidFill>
@@ -14012,10 +13770,10 @@
                 <a:ea typeface="Be Vietnam Pro" pitchFamily="34" charset="-122"/>
                 <a:cs typeface="Be Vietnam Pro" pitchFamily="34" charset="-120"/>
               </a:rPr>
-              <a:t> GỒM</a:t>
-            </a:r>
-            <a:r>
-              <a:rPr lang="en-US" sz="1800" b="1" spc="225" kern="0" dirty="0">
+              <a:t> KHÁI</a:t>
+            </a:r>
+            <a:r>
+              <a:rPr lang="en-US" sz="1800" b="1" spc="224" kern="0" dirty="0">
                 <a:solidFill>
                   <a:srgbClr val="6B6A66"/>
                 </a:solidFill>
@@ -14023,7 +13781,18 @@
                 <a:ea typeface="Be Vietnam Pro" pitchFamily="34" charset="-122"/>
                 <a:cs typeface="Be Vietnam Pro" pitchFamily="34" charset="-120"/>
               </a:rPr>
-              <a:t> HAI PHẦN</a:t>
+              <a:t> NIỆM</a:t>
+            </a:r>
+            <a:r>
+              <a:rPr lang="en-US" sz="1800" b="1" spc="223" kern="0" dirty="0">
+                <a:solidFill>
+                  <a:srgbClr val="6B6A66"/>
+                </a:solidFill>
+                <a:latin typeface="Be Vietnam Pro" pitchFamily="34" charset="0"/>
+                <a:ea typeface="Be Vietnam Pro" pitchFamily="34" charset="-122"/>
+                <a:cs typeface="Be Vietnam Pro" pitchFamily="34" charset="-120"/>
+              </a:rPr>
+              <a:t> RIÊNG</a:t>
             </a:r>
             <a:endParaRPr lang="en-US" sz="1800" dirty="0"/>
           </a:p>
@@ -14108,7 +13877,7 @@
               <a:buNone/>
             </a:pPr>
             <a:r>
-              <a:rPr lang="en-US" sz="4494" dirty="0" spc="-3" kern="0">
+              <a:rPr lang="en-US" sz="4494" dirty="0" spc="6" kern="0">
                 <a:solidFill>
                   <a:srgbClr val="14161C"/>
                 </a:solidFill>
@@ -14116,7 +13885,7 @@
                 <a:ea typeface="Bricolage Grotesque ExtraBold" pitchFamily="34" charset="-122"/>
                 <a:cs typeface="Bricolage Grotesque ExtraBold" pitchFamily="34" charset="-120"/>
               </a:rPr>
-              <a:t>+</a:t>
+              <a:t>·</a:t>
             </a:r>
             <a:endParaRPr lang="en-US" sz="4494" dirty="0"/>
           </a:p>
@@ -14223,7 +13992,7 @@
               <a:buNone/>
             </a:pPr>
             <a:r>
-              <a:rPr lang="en-US" sz="4494" dirty="0" spc="-3" kern="0">
+              <a:rPr lang="en-US" sz="4494" dirty="0" spc="6" kern="0">
                 <a:solidFill>
                   <a:srgbClr val="14161C"/>
                 </a:solidFill>
@@ -14231,7 +14000,7 @@
                 <a:ea typeface="Bricolage Grotesque ExtraBold" pitchFamily="34" charset="-122"/>
                 <a:cs typeface="Bricolage Grotesque ExtraBold" pitchFamily="34" charset="-120"/>
               </a:rPr>
-              <a:t>=</a:t>
+              <a:t>·</a:t>
             </a:r>
             <a:endParaRPr lang="en-US" sz="4494" dirty="0"/>
           </a:p>
@@ -16402,7 +16171,7 @@
               <a:buNone/>
             </a:pPr>
             <a:r>
-              <a:rPr lang="en-US" sz="2100" dirty="0" spc="3" kern="0">
+              <a:rPr lang="en-US" sz="2100" dirty="0" spc="0" kern="0">
                 <a:solidFill>
                   <a:srgbClr val="C4C8D6"/>
                 </a:solidFill>
@@ -16410,10 +16179,10 @@
                 <a:ea typeface="Be Vietnam Pro" pitchFamily="34" charset="-122"/>
                 <a:cs typeface="Be Vietnam Pro" pitchFamily="34" charset="-120"/>
               </a:rPr>
-              <a:t>B</a:t>
-            </a:r>
-            <a:r>
-              <a:rPr lang="en-US" sz="2100" dirty="0" spc="0" kern="0">
+              <a:t>Không</a:t>
+            </a:r>
+            <a:r>
+              <a:rPr lang="en-US" sz="2100" dirty="0" spc="-1" kern="0">
                 <a:solidFill>
                   <a:srgbClr val="C4C8D6"/>
                 </a:solidFill>
@@ -16421,7 +16190,29 @@
                 <a:ea typeface="Be Vietnam Pro" pitchFamily="34" charset="-122"/>
                 <a:cs typeface="Be Vietnam Pro" pitchFamily="34" charset="-120"/>
               </a:rPr>
-              <a:t> nhận</a:t>
+              <a:t> ai</a:t>
+            </a:r>
+            <a:r>
+              <a:rPr lang="en-US" sz="2100" dirty="0" spc="9" kern="0">
+                <a:solidFill>
+                  <a:srgbClr val="C4C8D6"/>
+                </a:solidFill>
+                <a:latin typeface="Be Vietnam Pro" pitchFamily="34" charset="0"/>
+                <a:ea typeface="Be Vietnam Pro" pitchFamily="34" charset="-122"/>
+                <a:cs typeface="Be Vietnam Pro" pitchFamily="34" charset="-120"/>
+              </a:rPr>
+              <a:t> đợi</a:t>
+            </a:r>
+            <a:r>
+              <a:rPr lang="en-US" sz="2100" dirty="0" spc="-8" kern="0">
+                <a:solidFill>
+                  <a:srgbClr val="C4C8D6"/>
+                </a:solidFill>
+                <a:latin typeface="Be Vietnam Pro" pitchFamily="34" charset="0"/>
+                <a:ea typeface="Be Vietnam Pro" pitchFamily="34" charset="-122"/>
+                <a:cs typeface="Be Vietnam Pro" pitchFamily="34" charset="-120"/>
+              </a:rPr>
+              <a:t> một</a:t>
             </a:r>
             <a:r>
               <a:rPr lang="en-US" sz="2100" dirty="0" spc="-3" kern="0">
@@ -16432,7 +16223,18 @@
                 <a:ea typeface="Be Vietnam Pro" pitchFamily="34" charset="-122"/>
                 <a:cs typeface="Be Vietnam Pro" pitchFamily="34" charset="-120"/>
               </a:rPr>
-              <a:t> phản</a:t>
+              <a:t> khóa,</a:t>
+            </a:r>
+            <a:r>
+              <a:rPr lang="en-US" sz="2100" dirty="0" spc="1" kern="0">
+                <a:solidFill>
+                  <a:srgbClr val="C4C8D6"/>
+                </a:solidFill>
+                <a:latin typeface="Be Vietnam Pro" pitchFamily="34" charset="0"/>
+                <a:ea typeface="Be Vietnam Pro" pitchFamily="34" charset="-122"/>
+                <a:cs typeface="Be Vietnam Pro" pitchFamily="34" charset="-120"/>
+              </a:rPr>
+              <a:t> nên</a:t>
             </a:r>
             <a:r>
               <a:rPr lang="en-US" sz="2100" dirty="0" spc="-1" kern="0">
@@ -16443,10 +16245,10 @@
                 <a:ea typeface="Be Vietnam Pro" pitchFamily="34" charset="-122"/>
                 <a:cs typeface="Be Vietnam Pro" pitchFamily="34" charset="-120"/>
               </a:rPr>
-              <a:t> hồi</a:t>
-            </a:r>
-            <a:r>
-              <a:rPr lang="en-US" sz="2100" dirty="0" spc="-13" kern="0">
+              <a:t> không bị</a:t>
+            </a:r>
+            <a:r>
+              <a:rPr lang="en-US" sz="2100" dirty="0" spc="-18" kern="0">
                 <a:solidFill>
                   <a:srgbClr val="C4C8D6"/>
                 </a:solidFill>
@@ -16454,51 +16256,7 @@
                 <a:ea typeface="Be Vietnam Pro" pitchFamily="34" charset="-122"/>
                 <a:cs typeface="Be Vietnam Pro" pitchFamily="34" charset="-120"/>
               </a:rPr>
-              <a:t> ngay,</a:t>
-            </a:r>
-            <a:r>
-              <a:rPr lang="en-US" sz="2100" dirty="0" spc="11" kern="0">
-                <a:solidFill>
-                  <a:srgbClr val="C4C8D6"/>
-                </a:solidFill>
-                <a:latin typeface="Be Vietnam Pro" pitchFamily="34" charset="0"/>
-                <a:ea typeface="Be Vietnam Pro" pitchFamily="34" charset="-122"/>
-                <a:cs typeface="Be Vietnam Pro" pitchFamily="34" charset="-120"/>
-              </a:rPr>
-              <a:t> độ</a:t>
-            </a:r>
-            <a:r>
-              <a:rPr lang="en-US" sz="2100" dirty="0" spc="-22" kern="0">
-                <a:solidFill>
-                  <a:srgbClr val="C4C8D6"/>
-                </a:solidFill>
-                <a:latin typeface="Be Vietnam Pro" pitchFamily="34" charset="0"/>
-                <a:ea typeface="Be Vietnam Pro" pitchFamily="34" charset="-122"/>
-                <a:cs typeface="Be Vietnam Pro" pitchFamily="34" charset="-120"/>
-              </a:rPr>
-              <a:t> trễ</a:t>
-            </a:r>
-            <a:r>
-              <a:rPr lang="en-US" sz="2100" dirty="0" spc="-1" kern="0">
-                <a:solidFill>
-                  <a:srgbClr val="C4C8D6"/>
-                </a:solidFill>
-                <a:latin typeface="Be Vietnam Pro" pitchFamily="34" charset="0"/>
-                <a:ea typeface="Be Vietnam Pro" pitchFamily="34" charset="-122"/>
-                <a:cs typeface="Be Vietnam Pro" pitchFamily="34" charset="-120"/>
-              </a:rPr>
-              <a:t> giảm</a:t>
-            </a:r>
-            <a:r>
-              <a:rPr lang="en-US" sz="2100" dirty="0" spc="1" kern="0">
-                <a:solidFill>
-                  <a:srgbClr val="C4C8D6"/>
-                </a:solidFill>
-                <a:latin typeface="Be Vietnam Pro" pitchFamily="34" charset="0"/>
-                <a:ea typeface="Be Vietnam Pro" pitchFamily="34" charset="-122"/>
-                <a:cs typeface="Be Vietnam Pro" pitchFamily="34" charset="-120"/>
-              </a:rPr>
-              <a:t> nhiều.</a:t>
+              <a:t> treo.</a:t>
             </a:r>
             <a:endParaRPr lang="en-US" sz="2100" dirty="0"/>
           </a:p>
@@ -17717,7 +17475,7 @@
               <a:t>Không</a:t>
             </a:r>
             <a:r>
-              <a:rPr lang="en-US" sz="2400" dirty="0" spc="1" kern="0">
+              <a:rPr lang="en-US" sz="2400" dirty="0" spc="12" kern="0">
                 <a:solidFill>
                   <a:srgbClr val="14161C"/>
                 </a:solidFill>
@@ -17725,10 +17483,10 @@
                 <a:ea typeface="Be Vietnam Pro" pitchFamily="34" charset="-122"/>
                 <a:cs typeface="Be Vietnam Pro" pitchFamily="34" charset="-120"/>
               </a:rPr>
-              <a:t> phải luồng</a:t>
-            </a:r>
-            <a:r>
-              <a:rPr lang="en-US" sz="2400" dirty="0" spc="3" kern="0">
+              <a:t> hứa</a:t>
+            </a:r>
+            <a:r>
+              <a:rPr lang="en-US" sz="2400" dirty="0" spc="2" kern="0">
                 <a:solidFill>
                   <a:srgbClr val="14161C"/>
                 </a:solidFill>
@@ -17736,10 +17494,10 @@
                 <a:ea typeface="Be Vietnam Pro" pitchFamily="34" charset="-122"/>
                 <a:cs typeface="Be Vietnam Pro" pitchFamily="34" charset="-120"/>
               </a:rPr>
-              <a:t> nào</a:t>
-            </a:r>
-            <a:r>
-              <a:rPr lang="en-US" sz="2400" dirty="0" spc="2" kern="0">
+              <a:t> thắng</a:t>
+            </a:r>
+            <a:r>
+              <a:rPr lang="en-US" sz="2400" dirty="0" spc="-14" kern="0">
                 <a:solidFill>
                   <a:srgbClr val="14161C"/>
                 </a:solidFill>
@@ -17747,18 +17505,7 @@
                 <a:ea typeface="Be Vietnam Pro" pitchFamily="34" charset="-122"/>
                 <a:cs typeface="Be Vietnam Pro" pitchFamily="34" charset="-120"/>
               </a:rPr>
-              <a:t> cũng</a:t>
-            </a:r>
-            <a:r>
-              <a:rPr lang="en-US" sz="2400" dirty="0" spc="1" kern="0">
-                <a:solidFill>
-                  <a:srgbClr val="14161C"/>
-                </a:solidFill>
-                <a:latin typeface="Be Vietnam Pro" pitchFamily="34" charset="0"/>
-                <a:ea typeface="Be Vietnam Pro" pitchFamily="34" charset="-122"/>
-                <a:cs typeface="Be Vietnam Pro" pitchFamily="34" charset="-120"/>
-              </a:rPr>
-              <a:t> thành công</a:t>
+              <a:t> ngay</a:t>
             </a:r>
             <a:endParaRPr lang="en-US" sz="2400" dirty="0"/>
           </a:p>
@@ -17772,7 +17519,7 @@
               <a:buChar char="•"/>
             </a:pPr>
             <a:r>
-              <a:rPr lang="en-US" sz="2400" dirty="0" spc="5" kern="0">
+              <a:rPr lang="en-US" sz="2400" dirty="0" spc="-1" kern="0">
                 <a:solidFill>
                   <a:srgbClr val="14161C"/>
                 </a:solidFill>
@@ -17780,10 +17527,10 @@
                 <a:ea typeface="Be Vietnam Pro" pitchFamily="34" charset="-122"/>
                 <a:cs typeface="Be Vietnam Pro" pitchFamily="34" charset="-120"/>
               </a:rPr>
-              <a:t>B</a:t>
-            </a:r>
-            <a:r>
-              <a:rPr lang="en-US" sz="2400" dirty="0" spc="-12" kern="0">
+              <a:t>Thua</a:t>
+            </a:r>
+            <a:r>
+              <a:rPr lang="en-US" sz="2400" dirty="0" spc="-35" kern="0">
                 <a:solidFill>
                   <a:srgbClr val="14161C"/>
                 </a:solidFill>
@@ -17791,10 +17538,10 @@
                 <a:ea typeface="Be Vietnam Pro" pitchFamily="34" charset="-122"/>
                 <a:cs typeface="Be Vietnam Pro" pitchFamily="34" charset="-120"/>
               </a:rPr>
-              <a:t> vẫn</a:t>
-            </a:r>
-            <a:r>
-              <a:rPr lang="en-US" sz="2400" dirty="0" spc="1" kern="0">
+              <a:t> CAS</a:t>
+            </a:r>
+            <a:r>
+              <a:rPr lang="en-US" sz="2400" dirty="0" spc="0" kern="0">
                 <a:solidFill>
                   <a:srgbClr val="14161C"/>
                 </a:solidFill>
@@ -17802,7 +17549,18 @@
                 <a:ea typeface="Be Vietnam Pro" pitchFamily="34" charset="-122"/>
                 <a:cs typeface="Be Vietnam Pro" pitchFamily="34" charset="-120"/>
               </a:rPr>
-              <a:t> có</a:t>
+              <a:t> thì</a:t>
+            </a:r>
+            <a:r>
+              <a:rPr lang="en-US" sz="2400" dirty="0" spc="3" kern="0">
+                <a:solidFill>
+                  <a:srgbClr val="14161C"/>
+                </a:solidFill>
+                <a:latin typeface="Be Vietnam Pro" pitchFamily="34" charset="0"/>
+                <a:ea typeface="Be Vietnam Pro" pitchFamily="34" charset="-122"/>
+                <a:cs typeface="Be Vietnam Pro" pitchFamily="34" charset="-120"/>
+              </a:rPr>
+              <a:t> thử</a:t>
             </a:r>
             <a:r>
               <a:rPr lang="en-US" sz="2400" dirty="0" spc="0" kern="0">
@@ -17813,40 +17571,7 @@
                 <a:ea typeface="Be Vietnam Pro" pitchFamily="34" charset="-122"/>
                 <a:cs typeface="Be Vietnam Pro" pitchFamily="34" charset="-120"/>
               </a:rPr>
-              <a:t> thể</a:t>
-            </a:r>
-            <a:r>
-              <a:rPr lang="en-US" sz="2400" dirty="0" spc="2" kern="0">
-                <a:solidFill>
-                  <a:srgbClr val="14161C"/>
-                </a:solidFill>
-                <a:latin typeface="Be Vietnam Pro" pitchFamily="34" charset="0"/>
-                <a:ea typeface="Be Vietnam Pro" pitchFamily="34" charset="-122"/>
-                <a:cs typeface="Be Vietnam Pro" pitchFamily="34" charset="-120"/>
-              </a:rPr>
-              <a:t> bị</a:t>
-            </a:r>
-            <a:r>
-              <a:rPr lang="en-US" sz="2400" dirty="0" spc="-2" kern="0">
-                <a:solidFill>
-                  <a:srgbClr val="14161C"/>
-                </a:solidFill>
-                <a:latin typeface="Be Vietnam Pro" pitchFamily="34" charset="0"/>
-                <a:ea typeface="Be Vietnam Pro" pitchFamily="34" charset="-122"/>
-                <a:cs typeface="Be Vietnam Pro" pitchFamily="34" charset="-120"/>
-              </a:rPr>
-              <a:t> bỏ</a:t>
-            </a:r>
-            <a:r>
-              <a:rPr lang="en-US" sz="2400" dirty="0" spc="13" kern="0">
-                <a:solidFill>
-                  <a:srgbClr val="14161C"/>
-                </a:solidFill>
-                <a:latin typeface="Be Vietnam Pro" pitchFamily="34" charset="0"/>
-                <a:ea typeface="Be Vietnam Pro" pitchFamily="34" charset="-122"/>
-                <a:cs typeface="Be Vietnam Pro" pitchFamily="34" charset="-120"/>
-              </a:rPr>
-              <a:t> đói</a:t>
+              <a:t> lại</a:t>
             </a:r>
             <a:endParaRPr lang="en-US" sz="2400" dirty="0"/>
           </a:p>
@@ -19397,7 +19122,7 @@
               <a:buNone/>
             </a:pPr>
             <a:r>
-              <a:rPr lang="en-US" sz="6900" dirty="0" spc="-3" kern="0">
+              <a:rPr lang="en-US" sz="6900" dirty="0" spc="-5" kern="0">
                 <a:solidFill>
                   <a:srgbClr val="F3EEE3"/>
                 </a:solidFill>
@@ -19405,10 +19130,10 @@
                 <a:ea typeface="Bricolage Grotesque ExtraBold" pitchFamily="34" charset="-122"/>
                 <a:cs typeface="Bricolage Grotesque ExtraBold" pitchFamily="34" charset="-120"/>
               </a:rPr>
-              <a:t>A</a:t>
-            </a:r>
-            <a:r>
-              <a:rPr lang="en-US" sz="6900" dirty="0" spc="1" kern="0">
+              <a:t>B</a:t>
+            </a:r>
+            <a:r>
+              <a:rPr lang="en-US" sz="6900" dirty="0" spc="-16" kern="0">
                 <a:solidFill>
                   <a:srgbClr val="F3EEE3"/>
                 </a:solidFill>
@@ -19416,18 +19141,7 @@
                 <a:ea typeface="Bricolage Grotesque ExtraBold" pitchFamily="34" charset="-122"/>
                 <a:cs typeface="Bricolage Grotesque ExtraBold" pitchFamily="34" charset="-120"/>
               </a:rPr>
-              <a:t> bị</a:t>
-            </a:r>
-            <a:r>
-              <a:rPr lang="en-US" sz="6900" dirty="0" spc="26" kern="0">
-                <a:solidFill>
-                  <a:srgbClr val="F3EEE3"/>
-                </a:solidFill>
-                <a:latin typeface="Bricolage Grotesque ExtraBold" pitchFamily="34" charset="0"/>
-                <a:ea typeface="Bricolage Grotesque ExtraBold" pitchFamily="34" charset="-122"/>
-                <a:cs typeface="Bricolage Grotesque ExtraBold" pitchFamily="34" charset="-120"/>
-              </a:rPr>
-              <a:t> dừng,</a:t>
+              <a:t> gặp</a:t>
             </a:r>
             <a:endParaRPr lang="en-US" sz="6900" dirty="0"/>
           </a:p>
@@ -19439,7 +19153,7 @@
               <a:buNone/>
             </a:pPr>
             <a:r>
-              <a:rPr lang="en-US" sz="6900" dirty="0" spc="-5" kern="0">
+              <a:rPr lang="en-US" sz="6900" dirty="0" spc="2" kern="0">
                 <a:solidFill>
                   <a:srgbClr val="F3EEE3"/>
                 </a:solidFill>
@@ -19447,10 +19161,10 @@
                 <a:ea typeface="Bricolage Grotesque ExtraBold" pitchFamily="34" charset="-122"/>
                 <a:cs typeface="Bricolage Grotesque ExtraBold" pitchFamily="34" charset="-120"/>
               </a:rPr>
-              <a:t>B</a:t>
-            </a:r>
-            <a:r>
-              <a:rPr lang="en-US" sz="6900" dirty="0" spc="-1" kern="0">
+              <a:t>hàng</a:t>
+            </a:r>
+            <a:r>
+              <a:rPr lang="en-US" sz="6900" dirty="0" spc="-13" kern="0">
                 <a:solidFill>
                   <a:srgbClr val="F3EEE3"/>
                 </a:solidFill>
@@ -19458,18 +19172,7 @@
                 <a:ea typeface="Bricolage Grotesque ExtraBold" pitchFamily="34" charset="-122"/>
                 <a:cs typeface="Bricolage Grotesque ExtraBold" pitchFamily="34" charset="-120"/>
               </a:rPr>
-              <a:t> làm</a:t>
-            </a:r>
-            <a:r>
-              <a:rPr lang="en-US" sz="6900" dirty="0" spc="-21" kern="0">
-                <a:solidFill>
-                  <a:srgbClr val="F3EEE3"/>
-                </a:solidFill>
-                <a:latin typeface="Bricolage Grotesque ExtraBold" pitchFamily="34" charset="0"/>
-                <a:ea typeface="Bricolage Grotesque ExtraBold" pitchFamily="34" charset="-122"/>
-                <a:cs typeface="Bricolage Grotesque ExtraBold" pitchFamily="34" charset="-120"/>
-              </a:rPr>
-              <a:t> gì?</a:t>
+              <a:t> trống</a:t>
             </a:r>
             <a:endParaRPr lang="en-US" sz="6900" dirty="0"/>
           </a:p>
@@ -19586,6 +19289,28 @@
               <a:t>Luồng</a:t>
             </a:r>
             <a:r>
+              <a:rPr lang="en-US" sz="2550" dirty="0" spc="2" kern="0">
+                <a:solidFill>
+                  <a:srgbClr val="F3EEE3"/>
+                </a:solidFill>
+                <a:latin typeface="Be Vietnam Pro" pitchFamily="34" charset="0"/>
+                <a:ea typeface="Be Vietnam Pro" pitchFamily="34" charset="-122"/>
+                <a:cs typeface="Be Vietnam Pro" pitchFamily="34" charset="-120"/>
+              </a:rPr>
+              <a:t> B</a:t>
+            </a:r>
+            <a:r>
+              <a:rPr lang="en-US" sz="2550" dirty="0" spc="-9" kern="0">
+                <a:solidFill>
+                  <a:srgbClr val="F3EEE3"/>
+                </a:solidFill>
+                <a:latin typeface="Be Vietnam Pro" pitchFamily="34" charset="0"/>
+                <a:ea typeface="Be Vietnam Pro" pitchFamily="34" charset="-122"/>
+                <a:cs typeface="Be Vietnam Pro" pitchFamily="34" charset="-120"/>
+              </a:rPr>
+              <a:t> lấy</a:t>
+            </a:r>
+            <a:r>
               <a:rPr lang="en-US" sz="2550" dirty="0" spc="0" kern="0">
                 <a:solidFill>
                   <a:srgbClr val="F3EEE3"/>
@@ -19594,10 +19319,65 @@
                 <a:ea typeface="Be Vietnam Pro" pitchFamily="34" charset="-122"/>
                 <a:cs typeface="Be Vietnam Pro" pitchFamily="34" charset="-120"/>
               </a:rPr>
-              <a:t> A</a:t>
-            </a:r>
-            <a:r>
-              <a:rPr lang="en-US" sz="2550" dirty="0" spc="10" kern="0">
+              <a:t> phần</a:t>
+            </a:r>
+            <a:r>
+              <a:rPr lang="en-US" sz="2550" dirty="0" spc="-1" kern="0">
+                <a:solidFill>
+                  <a:srgbClr val="F3EEE3"/>
+                </a:solidFill>
+                <a:latin typeface="Be Vietnam Pro" pitchFamily="34" charset="0"/>
+                <a:ea typeface="Be Vietnam Pro" pitchFamily="34" charset="-122"/>
+                <a:cs typeface="Be Vietnam Pro" pitchFamily="34" charset="-120"/>
+              </a:rPr>
+              <a:t> tử từ</a:t>
+            </a:r>
+            <a:r>
+              <a:rPr lang="en-US" sz="2550" dirty="0" spc="-5" kern="0">
+                <a:solidFill>
+                  <a:srgbClr val="F3EEE3"/>
+                </a:solidFill>
+                <a:latin typeface="Be Vietnam Pro" pitchFamily="34" charset="0"/>
+                <a:ea typeface="Be Vietnam Pro" pitchFamily="34" charset="-122"/>
+                <a:cs typeface="Be Vietnam Pro" pitchFamily="34" charset="-120"/>
+              </a:rPr>
+              <a:t> một</a:t>
+            </a:r>
+            <a:r>
+              <a:rPr lang="en-US" sz="2550" dirty="0" spc="0" kern="0">
+                <a:solidFill>
+                  <a:srgbClr val="F3EEE3"/>
+                </a:solidFill>
+                <a:latin typeface="Be Vietnam Pro" pitchFamily="34" charset="0"/>
+                <a:ea typeface="Be Vietnam Pro" pitchFamily="34" charset="-122"/>
+                <a:cs typeface="Be Vietnam Pro" pitchFamily="34" charset="-120"/>
+              </a:rPr>
+              <a:t> hàng</a:t>
+            </a:r>
+            <a:r>
+              <a:rPr lang="en-US" sz="2550" dirty="0" spc="12" kern="0">
+                <a:solidFill>
+                  <a:srgbClr val="F3EEE3"/>
+                </a:solidFill>
+                <a:latin typeface="Be Vietnam Pro" pitchFamily="34" charset="0"/>
+                <a:ea typeface="Be Vietnam Pro" pitchFamily="34" charset="-122"/>
+                <a:cs typeface="Be Vietnam Pro" pitchFamily="34" charset="-120"/>
+              </a:rPr>
+              <a:t> đợi</a:t>
+            </a:r>
+            <a:r>
+              <a:rPr lang="en-US" sz="2550" dirty="0" spc="0" kern="0">
+                <a:solidFill>
+                  <a:srgbClr val="F3EEE3"/>
+                </a:solidFill>
+                <a:latin typeface="Be Vietnam Pro" pitchFamily="34" charset="0"/>
+                <a:ea typeface="Be Vietnam Pro" pitchFamily="34" charset="-122"/>
+                <a:cs typeface="Be Vietnam Pro" pitchFamily="34" charset="-120"/>
+              </a:rPr>
+              <a:t> chặn</a:t>
+            </a:r>
+            <a:r>
+              <a:rPr lang="en-US" sz="2550" dirty="0" spc="11" kern="0">
                 <a:solidFill>
                   <a:srgbClr val="F3EEE3"/>
                 </a:solidFill>
@@ -19608,70 +19388,26 @@
               <a:t> đang</a:t>
             </a:r>
             <a:r>
-              <a:rPr lang="en-US" sz="2550" dirty="0" spc="-1" kern="0">
-                <a:solidFill>
-                  <a:srgbClr val="F3EEE3"/>
-                </a:solidFill>
-                <a:latin typeface="Be Vietnam Pro" pitchFamily="34" charset="0"/>
-                <a:ea typeface="Be Vietnam Pro" pitchFamily="34" charset="-122"/>
-                <a:cs typeface="Be Vietnam Pro" pitchFamily="34" charset="-120"/>
-              </a:rPr>
-              <a:t> giữ</a:t>
-            </a:r>
-            <a:r>
-              <a:rPr lang="en-US" sz="2550" dirty="0" spc="-3" kern="0">
-                <a:solidFill>
-                  <a:srgbClr val="F3EEE3"/>
-                </a:solidFill>
-                <a:latin typeface="Be Vietnam Pro" pitchFamily="34" charset="0"/>
-                <a:ea typeface="Be Vietnam Pro" pitchFamily="34" charset="-122"/>
-                <a:cs typeface="Be Vietnam Pro" pitchFamily="34" charset="-120"/>
-              </a:rPr>
-              <a:t> khóa</a:t>
-            </a:r>
-            <a:r>
-              <a:rPr lang="en-US" sz="2550" dirty="0" spc="-1" kern="0">
-                <a:solidFill>
-                  <a:srgbClr val="F3EEE3"/>
-                </a:solidFill>
-                <a:latin typeface="Be Vietnam Pro" pitchFamily="34" charset="0"/>
-                <a:ea typeface="Be Vietnam Pro" pitchFamily="34" charset="-122"/>
-                <a:cs typeface="Be Vietnam Pro" pitchFamily="34" charset="-120"/>
-              </a:rPr>
-              <a:t> của</a:t>
-            </a:r>
-            <a:r>
-              <a:rPr lang="en-US" sz="2550" dirty="0" spc="0" kern="0">
-                <a:solidFill>
-                  <a:srgbClr val="F3EEE3"/>
-                </a:solidFill>
-                <a:latin typeface="Be Vietnam Pro" pitchFamily="34" charset="0"/>
-                <a:ea typeface="Be Vietnam Pro" pitchFamily="34" charset="-122"/>
-                <a:cs typeface="Be Vietnam Pro" pitchFamily="34" charset="-120"/>
-              </a:rPr>
-              <a:t> hàng</a:t>
-            </a:r>
-            <a:r>
-              <a:rPr lang="en-US" sz="2550" dirty="0" spc="12" kern="0">
-                <a:solidFill>
-                  <a:srgbClr val="F3EEE3"/>
-                </a:solidFill>
-                <a:latin typeface="Be Vietnam Pro" pitchFamily="34" charset="0"/>
-                <a:ea typeface="Be Vietnam Pro" pitchFamily="34" charset="-122"/>
-                <a:cs typeface="Be Vietnam Pro" pitchFamily="34" charset="-120"/>
-              </a:rPr>
-              <a:t> đợi</a:t>
-            </a:r>
-            <a:r>
-              <a:rPr lang="en-US" sz="2550" dirty="0" spc="0" kern="0">
-                <a:solidFill>
-                  <a:srgbClr val="F3EEE3"/>
-                </a:solidFill>
-                <a:latin typeface="Be Vietnam Pro" pitchFamily="34" charset="0"/>
-                <a:ea typeface="Be Vietnam Pro" pitchFamily="34" charset="-122"/>
-                <a:cs typeface="Be Vietnam Pro" pitchFamily="34" charset="-120"/>
-              </a:rPr>
-              <a:t> chặn</a:t>
+              <a:rPr lang="en-US" sz="2550" dirty="0" spc="-14" kern="0">
+                <a:solidFill>
+                  <a:srgbClr val="F3EEE3"/>
+                </a:solidFill>
+                <a:latin typeface="Be Vietnam Pro" pitchFamily="34" charset="0"/>
+                <a:ea typeface="Be Vietnam Pro" pitchFamily="34" charset="-122"/>
+                <a:cs typeface="Be Vietnam Pro" pitchFamily="34" charset="-120"/>
+              </a:rPr>
+              <a:t> trống.</a:t>
+            </a:r>
+            <a:r>
+              <a:rPr lang="en-US" sz="2550" dirty="0" spc="-12" kern="0">
+                <a:solidFill>
+                  <a:srgbClr val="F3EEE3"/>
+                </a:solidFill>
+                <a:latin typeface="Be Vietnam Pro" pitchFamily="34" charset="0"/>
+                <a:ea typeface="Be Vietnam Pro" pitchFamily="34" charset="-122"/>
+                <a:cs typeface="Be Vietnam Pro" pitchFamily="34" charset="-120"/>
+              </a:rPr>
+              <a:t> Chuyện</a:t>
             </a:r>
             <a:r>
               <a:rPr lang="en-US" sz="2550" dirty="0" spc="2" kern="0">
@@ -19682,117 +19418,40 @@
                 <a:ea typeface="Be Vietnam Pro" pitchFamily="34" charset="-122"/>
                 <a:cs typeface="Be Vietnam Pro" pitchFamily="34" charset="-120"/>
               </a:rPr>
-              <a:t> thì</a:t>
-            </a:r>
-            <a:r>
-              <a:rPr lang="en-US" sz="2550" dirty="0" spc="1" kern="0">
-                <a:solidFill>
-                  <a:srgbClr val="F3EEE3"/>
-                </a:solidFill>
-                <a:latin typeface="Be Vietnam Pro" pitchFamily="34" charset="0"/>
-                <a:ea typeface="Be Vietnam Pro" pitchFamily="34" charset="-122"/>
-                <a:cs typeface="Be Vietnam Pro" pitchFamily="34" charset="-120"/>
-              </a:rPr>
-              <a:t> bị</a:t>
-            </a:r>
-            <a:r>
-              <a:rPr lang="en-US" sz="2550" dirty="0" spc="0" kern="0">
-                <a:solidFill>
-                  <a:srgbClr val="F3EEE3"/>
-                </a:solidFill>
-                <a:latin typeface="Be Vietnam Pro" pitchFamily="34" charset="0"/>
-                <a:ea typeface="Be Vietnam Pro" pitchFamily="34" charset="-122"/>
-                <a:cs typeface="Be Vietnam Pro" pitchFamily="34" charset="-120"/>
-              </a:rPr>
-              <a:t> hệ</a:t>
-            </a:r>
-            <a:r>
-              <a:rPr lang="en-US" sz="2550" dirty="0" spc="22" kern="0">
-                <a:solidFill>
-                  <a:srgbClr val="F3EEE3"/>
-                </a:solidFill>
-                <a:latin typeface="Be Vietnam Pro" pitchFamily="34" charset="0"/>
-                <a:ea typeface="Be Vietnam Pro" pitchFamily="34" charset="-122"/>
-                <a:cs typeface="Be Vietnam Pro" pitchFamily="34" charset="-120"/>
-              </a:rPr>
-              <a:t> điều</a:t>
-            </a:r>
-            <a:r>
-              <a:rPr lang="en-US" sz="2550" dirty="0" spc="0" kern="0">
-                <a:solidFill>
-                  <a:srgbClr val="F3EEE3"/>
-                </a:solidFill>
-                <a:latin typeface="Be Vietnam Pro" pitchFamily="34" charset="0"/>
-                <a:ea typeface="Be Vietnam Pro" pitchFamily="34" charset="-122"/>
-                <a:cs typeface="Be Vietnam Pro" pitchFamily="34" charset="-120"/>
-              </a:rPr>
-              <a:t> hành</a:t>
-            </a:r>
-            <a:r>
-              <a:rPr lang="en-US" sz="2550" dirty="0" spc="-11" kern="0">
-                <a:solidFill>
-                  <a:srgbClr val="F3EEE3"/>
-                </a:solidFill>
-                <a:latin typeface="Be Vietnam Pro" pitchFamily="34" charset="0"/>
-                <a:ea typeface="Be Vietnam Pro" pitchFamily="34" charset="-122"/>
-                <a:cs typeface="Be Vietnam Pro" pitchFamily="34" charset="-120"/>
-              </a:rPr>
-              <a:t> tạm</a:t>
-            </a:r>
-            <a:r>
-              <a:rPr lang="en-US" sz="2550" dirty="0" spc="17" kern="0">
-                <a:solidFill>
-                  <a:srgbClr val="F3EEE3"/>
-                </a:solidFill>
-                <a:latin typeface="Be Vietnam Pro" pitchFamily="34" charset="0"/>
-                <a:ea typeface="Be Vietnam Pro" pitchFamily="34" charset="-122"/>
-                <a:cs typeface="Be Vietnam Pro" pitchFamily="34" charset="-120"/>
-              </a:rPr>
-              <a:t> dừng.</a:t>
-            </a:r>
-            <a:r>
-              <a:rPr lang="en-US" sz="2550" dirty="0" spc="-12" kern="0">
-                <a:solidFill>
-                  <a:srgbClr val="F3EEE3"/>
-                </a:solidFill>
-                <a:latin typeface="Be Vietnam Pro" pitchFamily="34" charset="0"/>
-                <a:ea typeface="Be Vietnam Pro" pitchFamily="34" charset="-122"/>
-                <a:cs typeface="Be Vietnam Pro" pitchFamily="34" charset="-120"/>
-              </a:rPr>
-              <a:t> Luồng</a:t>
-            </a:r>
-            <a:r>
-              <a:rPr lang="en-US" sz="2550" dirty="0" spc="4" kern="0">
-                <a:solidFill>
-                  <a:srgbClr val="F3EEE3"/>
-                </a:solidFill>
-                <a:latin typeface="Be Vietnam Pro" pitchFamily="34" charset="0"/>
-                <a:ea typeface="Be Vietnam Pro" pitchFamily="34" charset="-122"/>
-                <a:cs typeface="Be Vietnam Pro" pitchFamily="34" charset="-120"/>
-              </a:rPr>
-              <a:t> B</a:t>
-            </a:r>
-            <a:r>
-              <a:rPr lang="en-US" sz="2550" dirty="0" spc="-1" kern="0">
-                <a:solidFill>
-                  <a:srgbClr val="F3EEE3"/>
-                </a:solidFill>
-                <a:latin typeface="Be Vietnam Pro" pitchFamily="34" charset="0"/>
-                <a:ea typeface="Be Vietnam Pro" pitchFamily="34" charset="-122"/>
-                <a:cs typeface="Be Vietnam Pro" pitchFamily="34" charset="-120"/>
-              </a:rPr>
-              <a:t> xin</a:t>
-            </a:r>
-            <a:r>
-              <a:rPr lang="en-US" sz="2550" dirty="0" spc="1" kern="0">
-                <a:solidFill>
-                  <a:srgbClr val="F3EEE3"/>
-                </a:solidFill>
-                <a:latin typeface="Be Vietnam Pro" pitchFamily="34" charset="0"/>
-                <a:ea typeface="Be Vietnam Pro" pitchFamily="34" charset="-122"/>
-                <a:cs typeface="Be Vietnam Pro" pitchFamily="34" charset="-120"/>
-              </a:rPr>
-              <a:t> truy cập</a:t>
+              <a:t> gì</a:t>
+            </a:r>
+            <a:r>
+              <a:rPr lang="en-US" sz="2550" dirty="0" spc="-28" kern="0">
+                <a:solidFill>
+                  <a:srgbClr val="F3EEE3"/>
+                </a:solidFill>
+                <a:latin typeface="Be Vietnam Pro" pitchFamily="34" charset="0"/>
+                <a:ea typeface="Be Vietnam Pro" pitchFamily="34" charset="-122"/>
+                <a:cs typeface="Be Vietnam Pro" pitchFamily="34" charset="-120"/>
+              </a:rPr>
+              <a:t> xảy</a:t>
+            </a:r>
+            <a:r>
+              <a:rPr lang="en-US" sz="2550" dirty="0" spc="-35" kern="0">
+                <a:solidFill>
+                  <a:srgbClr val="F3EEE3"/>
+                </a:solidFill>
+                <a:latin typeface="Be Vietnam Pro" pitchFamily="34" charset="0"/>
+                <a:ea typeface="Be Vietnam Pro" pitchFamily="34" charset="-122"/>
+                <a:cs typeface="Be Vietnam Pro" pitchFamily="34" charset="-120"/>
+              </a:rPr>
+              <a:t> ra</a:t>
+            </a:r>
+            <a:r>
+              <a:rPr lang="en-US" sz="2550" dirty="0" spc="-15" kern="0">
+                <a:solidFill>
+                  <a:srgbClr val="F3EEE3"/>
+                </a:solidFill>
+                <a:latin typeface="Be Vietnam Pro" pitchFamily="34" charset="0"/>
+                <a:ea typeface="Be Vietnam Pro" pitchFamily="34" charset="-122"/>
+                <a:cs typeface="Be Vietnam Pro" pitchFamily="34" charset="-120"/>
+              </a:rPr>
+              <a:t> với</a:t>
             </a:r>
             <a:r>
               <a:rPr lang="en-US" sz="2550" dirty="0" spc="2" kern="0">
@@ -19803,51 +19462,7 @@
                 <a:ea typeface="Be Vietnam Pro" pitchFamily="34" charset="-122"/>
                 <a:cs typeface="Be Vietnam Pro" pitchFamily="34" charset="-120"/>
               </a:rPr>
-              <a:t> thì</a:t>
-            </a:r>
-            <a:r>
-              <a:rPr lang="en-US" sz="2550" dirty="0" spc="-12" kern="0">
-                <a:solidFill>
-                  <a:srgbClr val="F3EEE3"/>
-                </a:solidFill>
-                <a:latin typeface="Be Vietnam Pro" pitchFamily="34" charset="0"/>
-                <a:ea typeface="Be Vietnam Pro" pitchFamily="34" charset="-122"/>
-                <a:cs typeface="Be Vietnam Pro" pitchFamily="34" charset="-120"/>
-              </a:rPr>
-              <a:t> chuyện</a:t>
-            </a:r>
-            <a:r>
-              <a:rPr lang="en-US" sz="2550" dirty="0" spc="1" kern="0">
-                <a:solidFill>
-                  <a:srgbClr val="F3EEE3"/>
-                </a:solidFill>
-                <a:latin typeface="Be Vietnam Pro" pitchFamily="34" charset="0"/>
-                <a:ea typeface="Be Vietnam Pro" pitchFamily="34" charset="-122"/>
-                <a:cs typeface="Be Vietnam Pro" pitchFamily="34" charset="-120"/>
-              </a:rPr>
-              <a:t> gì</a:t>
-            </a:r>
-            <a:r>
-              <a:rPr lang="en-US" sz="2550" dirty="0" spc="-28" kern="0">
-                <a:solidFill>
-                  <a:srgbClr val="F3EEE3"/>
-                </a:solidFill>
-                <a:latin typeface="Be Vietnam Pro" pitchFamily="34" charset="0"/>
-                <a:ea typeface="Be Vietnam Pro" pitchFamily="34" charset="-122"/>
-                <a:cs typeface="Be Vietnam Pro" pitchFamily="34" charset="-120"/>
-              </a:rPr>
-              <a:t> xảy</a:t>
-            </a:r>
-            <a:r>
-              <a:rPr lang="en-US" sz="2550" dirty="0" spc="-27" kern="0">
-                <a:solidFill>
-                  <a:srgbClr val="F3EEE3"/>
-                </a:solidFill>
-                <a:latin typeface="Be Vietnam Pro" pitchFamily="34" charset="0"/>
-                <a:ea typeface="Be Vietnam Pro" pitchFamily="34" charset="-122"/>
-                <a:cs typeface="Be Vietnam Pro" pitchFamily="34" charset="-120"/>
-              </a:rPr>
-              <a:t> ra?</a:t>
+              <a:t> B?</a:t>
             </a:r>
             <a:endParaRPr lang="en-US" sz="2550" dirty="0"/>
           </a:p>
@@ -19958,7 +19573,51 @@
                 <a:ea typeface="Be Vietnam Pro" pitchFamily="34" charset="-122"/>
                 <a:cs typeface="Be Vietnam Pro" pitchFamily="34" charset="-120"/>
               </a:rPr>
-              <a:t> chặn thì</a:t>
+              <a:t> chặn,</a:t>
+            </a:r>
+            <a:r>
+              <a:rPr lang="en-US" sz="2700" b="1" dirty="0" spc="-5" kern="0">
+                <a:solidFill>
+                  <a:srgbClr val="3DD6A0"/>
+                </a:solidFill>
+                <a:latin typeface="Be Vietnam Pro" pitchFamily="34" charset="0"/>
+                <a:ea typeface="Be Vietnam Pro" pitchFamily="34" charset="-122"/>
+                <a:cs typeface="Be Vietnam Pro" pitchFamily="34" charset="-120"/>
+              </a:rPr>
+              <a:t> luồng</a:t>
+            </a:r>
+            <a:r>
+              <a:rPr lang="en-US" sz="2700" b="1" dirty="0" spc="0" kern="0">
+                <a:solidFill>
+                  <a:srgbClr val="3DD6A0"/>
+                </a:solidFill>
+                <a:latin typeface="Be Vietnam Pro" pitchFamily="34" charset="0"/>
+                <a:ea typeface="Be Vietnam Pro" pitchFamily="34" charset="-122"/>
+                <a:cs typeface="Be Vietnam Pro" pitchFamily="34" charset="-120"/>
+              </a:rPr>
+              <a:t> thua</a:t>
+            </a:r>
+            <a:r>
+              <a:rPr lang="en-US" sz="2700" b="1" dirty="0" spc="-42" kern="0">
+                <a:solidFill>
+                  <a:srgbClr val="3DD6A0"/>
+                </a:solidFill>
+                <a:latin typeface="Be Vietnam Pro" pitchFamily="34" charset="0"/>
+                <a:ea typeface="Be Vietnam Pro" pitchFamily="34" charset="-122"/>
+                <a:cs typeface="Be Vietnam Pro" pitchFamily="34" charset="-120"/>
+              </a:rPr>
+              <a:t> CAS</a:t>
+            </a:r>
+            <a:r>
+              <a:rPr lang="en-US" sz="2700" b="1" dirty="0" spc="-4" kern="0">
+                <a:solidFill>
+                  <a:srgbClr val="3DD6A0"/>
+                </a:solidFill>
+                <a:latin typeface="Be Vietnam Pro" pitchFamily="34" charset="0"/>
+                <a:ea typeface="Be Vietnam Pro" pitchFamily="34" charset="-122"/>
+                <a:cs typeface="Be Vietnam Pro" pitchFamily="34" charset="-120"/>
+              </a:rPr>
+              <a:t> làm</a:t>
             </a:r>
             <a:r>
               <a:rPr lang="en-US" sz="2700" b="1" dirty="0" spc="2" kern="0">
@@ -19969,40 +19628,7 @@
                 <a:ea typeface="Be Vietnam Pro" pitchFamily="34" charset="-122"/>
                 <a:cs typeface="Be Vietnam Pro" pitchFamily="34" charset="-120"/>
               </a:rPr>
-              <a:t> khác</a:t>
-            </a:r>
-            <a:r>
-              <a:rPr lang="en-US" sz="2700" b="1" dirty="0" spc="-2" kern="0">
-                <a:solidFill>
-                  <a:srgbClr val="3DD6A0"/>
-                </a:solidFill>
-                <a:latin typeface="Be Vietnam Pro" pitchFamily="34" charset="0"/>
-                <a:ea typeface="Be Vietnam Pro" pitchFamily="34" charset="-122"/>
-                <a:cs typeface="Be Vietnam Pro" pitchFamily="34" charset="-120"/>
-              </a:rPr>
-              <a:t> ở</a:t>
-            </a:r>
-            <a:r>
-              <a:rPr lang="en-US" sz="2700" b="1" dirty="0" spc="-4" kern="0">
-                <a:solidFill>
-                  <a:srgbClr val="3DD6A0"/>
-                </a:solidFill>
-                <a:latin typeface="Be Vietnam Pro" pitchFamily="34" charset="0"/>
-                <a:ea typeface="Be Vietnam Pro" pitchFamily="34" charset="-122"/>
-                <a:cs typeface="Be Vietnam Pro" pitchFamily="34" charset="-120"/>
-              </a:rPr>
-              <a:t> chỗ</a:t>
-            </a:r>
-            <a:r>
-              <a:rPr lang="en-US" sz="2700" b="1" dirty="0" spc="1" kern="0">
-                <a:solidFill>
-                  <a:srgbClr val="3DD6A0"/>
-                </a:solidFill>
-                <a:latin typeface="Be Vietnam Pro" pitchFamily="34" charset="0"/>
-                <a:ea typeface="Be Vietnam Pro" pitchFamily="34" charset="-122"/>
-                <a:cs typeface="Be Vietnam Pro" pitchFamily="34" charset="-120"/>
-              </a:rPr>
-              <a:t> nào?</a:t>
+              <a:t> gì?</a:t>
             </a:r>
             <a:endParaRPr lang="en-US" sz="2700" dirty="0"/>
           </a:p>
@@ -20250,6 +19876,28 @@
               <a:t>B</a:t>
             </a:r>
             <a:r>
+              <a:rPr lang="en-US" sz="2550" dirty="0" spc="12" kern="0">
+                <a:solidFill>
+                  <a:srgbClr val="F3EEE3"/>
+                </a:solidFill>
+                <a:latin typeface="Be Vietnam Pro" pitchFamily="34" charset="0"/>
+                <a:ea typeface="Be Vietnam Pro" pitchFamily="34" charset="-122"/>
+                <a:cs typeface="Be Vietnam Pro" pitchFamily="34" charset="-120"/>
+              </a:rPr>
+              <a:t> đợi</a:t>
+            </a:r>
+            <a:r>
+              <a:rPr lang="en-US" sz="2550" dirty="0" spc="-12" kern="0">
+                <a:solidFill>
+                  <a:srgbClr val="F3EEE3"/>
+                </a:solidFill>
+                <a:latin typeface="Be Vietnam Pro" pitchFamily="34" charset="0"/>
+                <a:ea typeface="Be Vietnam Pro" pitchFamily="34" charset="-122"/>
+                <a:cs typeface="Be Vietnam Pro" pitchFamily="34" charset="-120"/>
+              </a:rPr>
+              <a:t> tới</a:t>
+            </a:r>
+            <a:r>
               <a:rPr lang="en-US" sz="2550" dirty="0" spc="0" kern="0">
                 <a:solidFill>
                   <a:srgbClr val="F3EEE3"/>
@@ -20258,29 +19906,7 @@
                 <a:ea typeface="Be Vietnam Pro" pitchFamily="34" charset="-122"/>
                 <a:cs typeface="Be Vietnam Pro" pitchFamily="34" charset="-120"/>
               </a:rPr>
-              <a:t> phải</a:t>
-            </a:r>
-            <a:r>
-              <a:rPr lang="en-US" sz="2550" dirty="0" spc="12" kern="0">
-                <a:solidFill>
-                  <a:srgbClr val="F3EEE3"/>
-                </a:solidFill>
-                <a:latin typeface="Be Vietnam Pro" pitchFamily="34" charset="0"/>
-                <a:ea typeface="Be Vietnam Pro" pitchFamily="34" charset="-122"/>
-                <a:cs typeface="Be Vietnam Pro" pitchFamily="34" charset="-120"/>
-              </a:rPr>
-              <a:t> đợi</a:t>
-            </a:r>
-            <a:r>
-              <a:rPr lang="en-US" sz="2550" dirty="0" spc="-12" kern="0">
-                <a:solidFill>
-                  <a:srgbClr val="F3EEE3"/>
-                </a:solidFill>
-                <a:latin typeface="Be Vietnam Pro" pitchFamily="34" charset="0"/>
-                <a:ea typeface="Be Vietnam Pro" pitchFamily="34" charset="-122"/>
-                <a:cs typeface="Be Vietnam Pro" pitchFamily="34" charset="-120"/>
-              </a:rPr>
-              <a:t> tới</a:t>
+              <a:t> khi</a:t>
             </a:r>
             <a:r>
               <a:rPr lang="en-US" sz="2550" dirty="0" spc="-1" kern="0">
@@ -20291,29 +19917,7 @@
                 <a:ea typeface="Be Vietnam Pro" pitchFamily="34" charset="-122"/>
                 <a:cs typeface="Be Vietnam Pro" pitchFamily="34" charset="-120"/>
               </a:rPr>
-              <a:t> khi</a:t>
-            </a:r>
-            <a:r>
-              <a:rPr lang="en-US" sz="2550" dirty="0" spc="-2" kern="0">
-                <a:solidFill>
-                  <a:srgbClr val="F3EEE3"/>
-                </a:solidFill>
-                <a:latin typeface="Be Vietnam Pro" pitchFamily="34" charset="0"/>
-                <a:ea typeface="Be Vietnam Pro" pitchFamily="34" charset="-122"/>
-                <a:cs typeface="Be Vietnam Pro" pitchFamily="34" charset="-120"/>
-              </a:rPr>
-              <a:t> khóa</a:t>
-            </a:r>
-            <a:r>
-              <a:rPr lang="en-US" sz="2550" dirty="0" spc="6" kern="0">
-                <a:solidFill>
-                  <a:srgbClr val="F3EEE3"/>
-                </a:solidFill>
-                <a:latin typeface="Be Vietnam Pro" pitchFamily="34" charset="0"/>
-                <a:ea typeface="Be Vietnam Pro" pitchFamily="34" charset="-122"/>
-                <a:cs typeface="Be Vietnam Pro" pitchFamily="34" charset="-120"/>
-              </a:rPr>
-              <a:t> được</a:t>
+              <a:t> có</a:t>
             </a:r>
             <a:r>
               <a:rPr lang="en-US" sz="2550" dirty="0" spc="0" kern="0">
@@ -20324,7 +19928,18 @@
                 <a:ea typeface="Be Vietnam Pro" pitchFamily="34" charset="-122"/>
                 <a:cs typeface="Be Vietnam Pro" pitchFamily="34" charset="-120"/>
               </a:rPr>
-              <a:t> nhả</a:t>
+              <a:t> phần</a:t>
+            </a:r>
+            <a:r>
+              <a:rPr lang="en-US" sz="2550" dirty="0" spc="-1" kern="0">
+                <a:solidFill>
+                  <a:srgbClr val="F3EEE3"/>
+                </a:solidFill>
+                <a:latin typeface="Be Vietnam Pro" pitchFamily="34" charset="0"/>
+                <a:ea typeface="Be Vietnam Pro" pitchFamily="34" charset="-122"/>
+                <a:cs typeface="Be Vietnam Pro" pitchFamily="34" charset="-120"/>
+              </a:rPr>
+              <a:t> tử</a:t>
             </a:r>
             <a:endParaRPr lang="en-US" sz="2550" dirty="0"/>
           </a:p>
@@ -20436,7 +20051,7 @@
               <a:t>VÌ</a:t>
             </a:r>
             <a:r>
-              <a:rPr lang="en-US" sz="1800" b="1" spc="224" kern="0" dirty="0">
+              <a:rPr lang="en-US" sz="1800" b="1" spc="225" kern="0" dirty="0">
                 <a:solidFill>
                   <a:srgbClr val="7C93FF"/>
                 </a:solidFill>
@@ -20444,10 +20059,10 @@
                 <a:ea typeface="Be Vietnam Pro" pitchFamily="34" charset="-122"/>
                 <a:cs typeface="Be Vietnam Pro" pitchFamily="34" charset="-120"/>
               </a:rPr>
-              <a:t> A</a:t>
-            </a:r>
-            <a:r>
-              <a:rPr lang="en-US" sz="1800" b="1" spc="225" kern="0" dirty="0">
+              <a:t> HÀNG</a:t>
+            </a:r>
+            <a:r>
+              <a:rPr lang="en-US" sz="1800" b="1" spc="209" kern="0" dirty="0">
                 <a:solidFill>
                   <a:srgbClr val="7C93FF"/>
                 </a:solidFill>
@@ -20455,10 +20070,10 @@
                 <a:ea typeface="Be Vietnam Pro" pitchFamily="34" charset="-122"/>
                 <a:cs typeface="Be Vietnam Pro" pitchFamily="34" charset="-120"/>
               </a:rPr>
-              <a:t> GIỮ</a:t>
-            </a:r>
-            <a:r>
-              <a:rPr lang="en-US" sz="1800" b="1" spc="212" kern="0" dirty="0">
+              <a:t> ĐANG</a:t>
+            </a:r>
+            <a:r>
+              <a:rPr lang="en-US" sz="1800" b="1" spc="214" kern="0" dirty="0">
                 <a:solidFill>
                   <a:srgbClr val="7C93FF"/>
                 </a:solidFill>
@@ -20466,40 +20081,7 @@
                 <a:ea typeface="Be Vietnam Pro" pitchFamily="34" charset="-122"/>
                 <a:cs typeface="Be Vietnam Pro" pitchFamily="34" charset="-120"/>
               </a:rPr>
-              <a:t> KHÓA</a:t>
-            </a:r>
-            <a:r>
-              <a:rPr lang="en-US" sz="1800" b="1" spc="227" kern="0" dirty="0">
-                <a:solidFill>
-                  <a:srgbClr val="7C93FF"/>
-                </a:solidFill>
-                <a:latin typeface="Be Vietnam Pro" pitchFamily="34" charset="0"/>
-                <a:ea typeface="Be Vietnam Pro" pitchFamily="34" charset="-122"/>
-                <a:cs typeface="Be Vietnam Pro" pitchFamily="34" charset="-120"/>
-              </a:rPr>
-              <a:t> LÚC</a:t>
-            </a:r>
-            <a:r>
-              <a:rPr lang="en-US" sz="1800" b="1" spc="225" kern="0" dirty="0">
-                <a:solidFill>
-                  <a:srgbClr val="7C93FF"/>
-                </a:solidFill>
-                <a:latin typeface="Be Vietnam Pro" pitchFamily="34" charset="0"/>
-                <a:ea typeface="Be Vietnam Pro" pitchFamily="34" charset="-122"/>
-                <a:cs typeface="Be Vietnam Pro" pitchFamily="34" charset="-120"/>
-              </a:rPr>
-              <a:t> BỊ</a:t>
-            </a:r>
-            <a:r>
-              <a:rPr lang="en-US" sz="1800" b="1" spc="245" kern="0" dirty="0">
-                <a:solidFill>
-                  <a:srgbClr val="7C93FF"/>
-                </a:solidFill>
-                <a:latin typeface="Be Vietnam Pro" pitchFamily="34" charset="0"/>
-                <a:ea typeface="Be Vietnam Pro" pitchFamily="34" charset="-122"/>
-                <a:cs typeface="Be Vietnam Pro" pitchFamily="34" charset="-120"/>
-              </a:rPr>
-              <a:t> DỪNG</a:t>
+              <a:t> TRỐNG</a:t>
             </a:r>
             <a:endParaRPr lang="en-US" sz="1800" dirty="0"/>
           </a:p>
@@ -20533,15 +20115,48 @@
               <a:buNone/>
             </a:pPr>
             <a:r>
-              <a:rPr lang="en-US" sz="2550" dirty="0" spc="6" kern="0">
-                <a:solidFill>
-                  <a:srgbClr val="F3EEE3"/>
-                </a:solidFill>
-                <a:latin typeface="Be Vietnam Pro" pitchFamily="34" charset="0"/>
-                <a:ea typeface="Be Vietnam Pro" pitchFamily="34" charset="-122"/>
-                <a:cs typeface="Be Vietnam Pro" pitchFamily="34" charset="-120"/>
-              </a:rPr>
-              <a:t>B</a:t>
+              <a:rPr lang="en-US" sz="2550" dirty="0" spc="-7" kern="0">
+                <a:solidFill>
+                  <a:srgbClr val="F3EEE3"/>
+                </a:solidFill>
+                <a:latin typeface="Be Vietnam Pro" pitchFamily="34" charset="0"/>
+                <a:ea typeface="Be Vietnam Pro" pitchFamily="34" charset="-122"/>
+                <a:cs typeface="Be Vietnam Pro" pitchFamily="34" charset="-120"/>
+              </a:rPr>
+              <a:t>Một</a:t>
+            </a:r>
+            <a:r>
+              <a:rPr lang="en-US" sz="2550" dirty="0" spc="1" kern="0">
+                <a:solidFill>
+                  <a:srgbClr val="F3EEE3"/>
+                </a:solidFill>
+                <a:latin typeface="Be Vietnam Pro" pitchFamily="34" charset="0"/>
+                <a:ea typeface="Be Vietnam Pro" pitchFamily="34" charset="-122"/>
+                <a:cs typeface="Be Vietnam Pro" pitchFamily="34" charset="-120"/>
+              </a:rPr>
+              <a:t> luồng khác thêm</a:t>
+            </a:r>
+            <a:r>
+              <a:rPr lang="en-US" sz="2550" dirty="0" spc="-14" kern="0">
+                <a:solidFill>
+                  <a:srgbClr val="F3EEE3"/>
+                </a:solidFill>
+                <a:latin typeface="Be Vietnam Pro" pitchFamily="34" charset="0"/>
+                <a:ea typeface="Be Vietnam Pro" pitchFamily="34" charset="-122"/>
+                <a:cs typeface="Be Vietnam Pro" pitchFamily="34" charset="-120"/>
+              </a:rPr>
+              <a:t> vào</a:t>
+            </a:r>
+            <a:r>
+              <a:rPr lang="en-US" sz="2550" dirty="0" spc="2" kern="0">
+                <a:solidFill>
+                  <a:srgbClr val="F3EEE3"/>
+                </a:solidFill>
+                <a:latin typeface="Be Vietnam Pro" pitchFamily="34" charset="0"/>
+                <a:ea typeface="Be Vietnam Pro" pitchFamily="34" charset="-122"/>
+                <a:cs typeface="Be Vietnam Pro" pitchFamily="34" charset="-120"/>
+              </a:rPr>
+              <a:t> thì B</a:t>
             </a:r>
             <a:r>
               <a:rPr lang="en-US" sz="2550" dirty="0" spc="0" kern="0">
@@ -20552,7 +20167,18 @@
                 <a:ea typeface="Be Vietnam Pro" pitchFamily="34" charset="-122"/>
                 <a:cs typeface="Be Vietnam Pro" pitchFamily="34" charset="-120"/>
               </a:rPr>
-              <a:t> có</a:t>
+              <a:t> mới</a:t>
+            </a:r>
+            <a:r>
+              <a:rPr lang="en-US" sz="2550" dirty="0" spc="33" kern="0">
+                <a:solidFill>
+                  <a:srgbClr val="F3EEE3"/>
+                </a:solidFill>
+                <a:latin typeface="Be Vietnam Pro" pitchFamily="34" charset="0"/>
+                <a:ea typeface="Be Vietnam Pro" pitchFamily="34" charset="-122"/>
+                <a:cs typeface="Be Vietnam Pro" pitchFamily="34" charset="-120"/>
+              </a:rPr>
+              <a:t> đi</a:t>
             </a:r>
             <a:r>
               <a:rPr lang="en-US" sz="2550" dirty="0" spc="1" kern="0">
@@ -20563,84 +20189,7 @@
                 <a:ea typeface="Be Vietnam Pro" pitchFamily="34" charset="-122"/>
                 <a:cs typeface="Be Vietnam Pro" pitchFamily="34" charset="-120"/>
               </a:rPr>
-              <a:t> thể</a:t>
-            </a:r>
-            <a:r>
-              <a:rPr lang="en-US" sz="2550" dirty="0" spc="0" kern="0">
-                <a:solidFill>
-                  <a:srgbClr val="F3EEE3"/>
-                </a:solidFill>
-                <a:latin typeface="Be Vietnam Pro" pitchFamily="34" charset="0"/>
-                <a:ea typeface="Be Vietnam Pro" pitchFamily="34" charset="-122"/>
-                <a:cs typeface="Be Vietnam Pro" pitchFamily="34" charset="-120"/>
-              </a:rPr>
-              <a:t> chờ</a:t>
-            </a:r>
-            <a:r>
-              <a:rPr lang="en-US" sz="2550" dirty="0" spc="-37" kern="0">
-                <a:solidFill>
-                  <a:srgbClr val="F3EEE3"/>
-                </a:solidFill>
-                <a:latin typeface="Be Vietnam Pro" pitchFamily="34" charset="0"/>
-                <a:ea typeface="Be Vietnam Pro" pitchFamily="34" charset="-122"/>
-                <a:cs typeface="Be Vietnam Pro" pitchFamily="34" charset="-120"/>
-              </a:rPr>
-              <a:t> rất</a:t>
-            </a:r>
-            <a:r>
-              <a:rPr lang="en-US" sz="2550" dirty="0" spc="2" kern="0">
-                <a:solidFill>
-                  <a:srgbClr val="F3EEE3"/>
-                </a:solidFill>
-                <a:latin typeface="Be Vietnam Pro" pitchFamily="34" charset="0"/>
-                <a:ea typeface="Be Vietnam Pro" pitchFamily="34" charset="-122"/>
-                <a:cs typeface="Be Vietnam Pro" pitchFamily="34" charset="-120"/>
-              </a:rPr>
-              <a:t> lâu</a:t>
-            </a:r>
-            <a:r>
-              <a:rPr lang="en-US" sz="2550" dirty="0" spc="-19" kern="0">
-                <a:solidFill>
-                  <a:srgbClr val="F3EEE3"/>
-                </a:solidFill>
-                <a:latin typeface="Be Vietnam Pro" pitchFamily="34" charset="0"/>
-                <a:ea typeface="Be Vietnam Pro" pitchFamily="34" charset="-122"/>
-                <a:cs typeface="Be Vietnam Pro" pitchFamily="34" charset="-120"/>
-              </a:rPr>
-              <a:t> và</a:t>
-            </a:r>
-            <a:r>
-              <a:rPr lang="en-US" sz="2550" dirty="0" spc="1" kern="0">
-                <a:solidFill>
-                  <a:srgbClr val="F3EEE3"/>
-                </a:solidFill>
-                <a:latin typeface="Be Vietnam Pro" pitchFamily="34" charset="0"/>
-                <a:ea typeface="Be Vietnam Pro" pitchFamily="34" charset="-122"/>
-                <a:cs typeface="Be Vietnam Pro" pitchFamily="34" charset="-120"/>
-              </a:rPr>
-              <a:t> bị</a:t>
-            </a:r>
-            <a:r>
-              <a:rPr lang="en-US" sz="2550" dirty="0" spc="-4" kern="0">
-                <a:solidFill>
-                  <a:srgbClr val="F3EEE3"/>
-                </a:solidFill>
-                <a:latin typeface="Be Vietnam Pro" pitchFamily="34" charset="0"/>
-                <a:ea typeface="Be Vietnam Pro" pitchFamily="34" charset="-122"/>
-                <a:cs typeface="Be Vietnam Pro" pitchFamily="34" charset="-120"/>
-              </a:rPr>
-              <a:t> bỏ</a:t>
-            </a:r>
-            <a:r>
-              <a:rPr lang="en-US" sz="2550" dirty="0" spc="12" kern="0">
-                <a:solidFill>
-                  <a:srgbClr val="F3EEE3"/>
-                </a:solidFill>
-                <a:latin typeface="Be Vietnam Pro" pitchFamily="34" charset="0"/>
-                <a:ea typeface="Be Vietnam Pro" pitchFamily="34" charset="-122"/>
-                <a:cs typeface="Be Vietnam Pro" pitchFamily="34" charset="-120"/>
-              </a:rPr>
-              <a:t> đói</a:t>
+              <a:t> tiếp</a:t>
             </a:r>
             <a:endParaRPr lang="en-US" sz="2550" dirty="0"/>
           </a:p>
@@ -20805,48 +20354,15 @@
               <a:buNone/>
             </a:pPr>
             <a:r>
-              <a:rPr lang="en-US" sz="2550" dirty="0" spc="6" kern="0">
-                <a:solidFill>
-                  <a:srgbClr val="F3EEE3"/>
-                </a:solidFill>
-                <a:latin typeface="Be Vietnam Pro" pitchFamily="34" charset="0"/>
-                <a:ea typeface="Be Vietnam Pro" pitchFamily="34" charset="-122"/>
-                <a:cs typeface="Be Vietnam Pro" pitchFamily="34" charset="-120"/>
-              </a:rPr>
-              <a:t>B</a:t>
-            </a:r>
-            <a:r>
-              <a:rPr lang="en-US" sz="2550" dirty="0" spc="7" kern="0">
-                <a:solidFill>
-                  <a:srgbClr val="F3EEE3"/>
-                </a:solidFill>
-                <a:latin typeface="Be Vietnam Pro" pitchFamily="34" charset="0"/>
-                <a:ea typeface="Be Vietnam Pro" pitchFamily="34" charset="-122"/>
-                <a:cs typeface="Be Vietnam Pro" pitchFamily="34" charset="-120"/>
-              </a:rPr>
-              <a:t> được</a:t>
-            </a:r>
-            <a:r>
-              <a:rPr lang="en-US" sz="2550" dirty="0" spc="-3" kern="0">
-                <a:solidFill>
-                  <a:srgbClr val="F3EEE3"/>
-                </a:solidFill>
-                <a:latin typeface="Be Vietnam Pro" pitchFamily="34" charset="0"/>
-                <a:ea typeface="Be Vietnam Pro" pitchFamily="34" charset="-122"/>
-                <a:cs typeface="Be Vietnam Pro" pitchFamily="34" charset="-120"/>
-              </a:rPr>
-              <a:t> báo</a:t>
-            </a:r>
-            <a:r>
-              <a:rPr lang="en-US" sz="2550" dirty="0" spc="-16" kern="0">
-                <a:solidFill>
-                  <a:srgbClr val="F3EEE3"/>
-                </a:solidFill>
-                <a:latin typeface="Be Vietnam Pro" pitchFamily="34" charset="0"/>
-                <a:ea typeface="Be Vietnam Pro" pitchFamily="34" charset="-122"/>
-                <a:cs typeface="Be Vietnam Pro" pitchFamily="34" charset="-120"/>
-              </a:rPr>
-              <a:t> ngay,</a:t>
+              <a:rPr lang="en-US" sz="2550" dirty="0" spc="-5" kern="0">
+                <a:solidFill>
+                  <a:srgbClr val="F3EEE3"/>
+                </a:solidFill>
+                <a:latin typeface="Be Vietnam Pro" pitchFamily="34" charset="0"/>
+                <a:ea typeface="Be Vietnam Pro" pitchFamily="34" charset="-122"/>
+                <a:cs typeface="Be Vietnam Pro" pitchFamily="34" charset="-120"/>
+              </a:rPr>
+              <a:t>Đọc</a:t>
             </a:r>
             <a:r>
               <a:rPr lang="en-US" sz="2550" dirty="0" spc="0" kern="0">
@@ -20857,18 +20373,40 @@
                 <a:ea typeface="Be Vietnam Pro" pitchFamily="34" charset="-122"/>
                 <a:cs typeface="Be Vietnam Pro" pitchFamily="34" charset="-120"/>
               </a:rPr>
-              <a:t> tự</a:t>
-            </a:r>
-            <a:r>
-              <a:rPr lang="en-US" sz="2550" dirty="0" spc="-15" kern="0">
-                <a:solidFill>
-                  <a:srgbClr val="F3EEE3"/>
-                </a:solidFill>
-                <a:latin typeface="Be Vietnam Pro" pitchFamily="34" charset="0"/>
-                <a:ea typeface="Be Vietnam Pro" pitchFamily="34" charset="-122"/>
-                <a:cs typeface="Be Vietnam Pro" pitchFamily="34" charset="-120"/>
-              </a:rPr>
-              <a:t> quyết,</a:t>
+              <a:t> lại,</a:t>
+            </a:r>
+            <a:r>
+              <a:rPr lang="en-US" sz="2550" dirty="0" spc="-1" kern="0">
+                <a:solidFill>
+                  <a:srgbClr val="F3EEE3"/>
+                </a:solidFill>
+                <a:latin typeface="Be Vietnam Pro" pitchFamily="34" charset="0"/>
+                <a:ea typeface="Be Vietnam Pro" pitchFamily="34" charset="-122"/>
+                <a:cs typeface="Be Vietnam Pro" pitchFamily="34" charset="-120"/>
+              </a:rPr>
+              <a:t> thử</a:t>
+            </a:r>
+            <a:r>
+              <a:rPr lang="en-US" sz="2550" dirty="0" spc="-13" kern="0">
+                <a:solidFill>
+                  <a:srgbClr val="F3EEE3"/>
+                </a:solidFill>
+                <a:latin typeface="Be Vietnam Pro" pitchFamily="34" charset="0"/>
+                <a:ea typeface="Be Vietnam Pro" pitchFamily="34" charset="-122"/>
+                <a:cs typeface="Be Vietnam Pro" pitchFamily="34" charset="-120"/>
+              </a:rPr>
+              <a:t> gắn</a:t>
+            </a:r>
+            <a:r>
+              <a:rPr lang="en-US" sz="2550" dirty="0" spc="1" kern="0">
+                <a:solidFill>
+                  <a:srgbClr val="F3EEE3"/>
+                </a:solidFill>
+                <a:latin typeface="Be Vietnam Pro" pitchFamily="34" charset="0"/>
+                <a:ea typeface="Be Vietnam Pro" pitchFamily="34" charset="-122"/>
+                <a:cs typeface="Be Vietnam Pro" pitchFamily="34" charset="-120"/>
+              </a:rPr>
+              <a:t> tiếp,</a:t>
             </a:r>
             <a:r>
               <a:rPr lang="en-US" sz="2550" dirty="0" spc="0" kern="0">
@@ -20882,26 +20420,26 @@
               <a:t> không</a:t>
             </a:r>
             <a:r>
-              <a:rPr lang="en-US" sz="2550" dirty="0" spc="1" kern="0">
-                <a:solidFill>
-                  <a:srgbClr val="F3EEE3"/>
-                </a:solidFill>
-                <a:latin typeface="Be Vietnam Pro" pitchFamily="34" charset="0"/>
-                <a:ea typeface="Be Vietnam Pro" pitchFamily="34" charset="-122"/>
-                <a:cs typeface="Be Vietnam Pro" pitchFamily="34" charset="-120"/>
-              </a:rPr>
-              <a:t> bị</a:t>
-            </a:r>
-            <a:r>
-              <a:rPr lang="en-US" sz="2550" dirty="0" spc="-22" kern="0">
-                <a:solidFill>
-                  <a:srgbClr val="F3EEE3"/>
-                </a:solidFill>
-                <a:latin typeface="Be Vietnam Pro" pitchFamily="34" charset="0"/>
-                <a:ea typeface="Be Vietnam Pro" pitchFamily="34" charset="-122"/>
-                <a:cs typeface="Be Vietnam Pro" pitchFamily="34" charset="-120"/>
-              </a:rPr>
-              <a:t> treo</a:t>
+              <a:rPr lang="en-US" sz="2550" dirty="0" spc="12" kern="0">
+                <a:solidFill>
+                  <a:srgbClr val="F3EEE3"/>
+                </a:solidFill>
+                <a:latin typeface="Be Vietnam Pro" pitchFamily="34" charset="0"/>
+                <a:ea typeface="Be Vietnam Pro" pitchFamily="34" charset="-122"/>
+                <a:cs typeface="Be Vietnam Pro" pitchFamily="34" charset="-120"/>
+              </a:rPr>
+              <a:t> đợi</a:t>
+            </a:r>
+            <a:r>
+              <a:rPr lang="en-US" sz="2550" dirty="0" spc="-2" kern="0">
+                <a:solidFill>
+                  <a:srgbClr val="F3EEE3"/>
+                </a:solidFill>
+                <a:latin typeface="Be Vietnam Pro" pitchFamily="34" charset="0"/>
+                <a:ea typeface="Be Vietnam Pro" pitchFamily="34" charset="-122"/>
+                <a:cs typeface="Be Vietnam Pro" pitchFamily="34" charset="-120"/>
+              </a:rPr>
+              <a:t> khóa</a:t>
             </a:r>
             <a:endParaRPr lang="en-US" sz="2550" dirty="0"/>
           </a:p>

</xml_diff>

<commit_message>
Lesson sd-10-010: rebuild deck slide 3 around the full and empty conditions of a blocking queue, and re-export the PPTX
Co-Authored-By: Claude Sonnet 5.5 <noreply@anthropic.com>
Claude-Session: https://claude.ai/code/session_01Y9NYFwg4CcDYEWi1zr53gi
</commit_message>
<xml_diff>
--- a/system-design-101/vi/lessons/sd-10-010/slides/sd-10-010.pptx
+++ b/system-design-101/vi/lessons/sd-10-010/slides/sd-10-010.pptx
@@ -2574,7 +2574,7 @@
               <a:buNone/>
             </a:pPr>
             <a:r>
-              <a:rPr lang="en-US" sz="4200" dirty="0" spc="3" kern="0">
+              <a:rPr lang="en-US" sz="4200" dirty="0" spc="-28" kern="0">
                 <a:solidFill>
                   <a:srgbClr val="F3EEE3"/>
                 </a:solidFill>
@@ -2582,10 +2582,10 @@
                 <a:ea typeface="Bricolage Grotesque ExtraBold" pitchFamily="34" charset="-122"/>
                 <a:cs typeface="Bricolage Grotesque ExtraBold" pitchFamily="34" charset="-120"/>
               </a:rPr>
-              <a:t>Dùng</a:t>
-            </a:r>
-            <a:r>
-              <a:rPr lang="en-US" sz="4200" dirty="0" spc="-4" kern="0">
+              <a:t>Đợi</a:t>
+            </a:r>
+            <a:r>
+              <a:rPr lang="en-US" sz="4200" dirty="0" spc="-2" kern="0">
                 <a:solidFill>
                   <a:srgbClr val="F3EEE3"/>
                 </a:solidFill>
@@ -2593,7 +2593,40 @@
                 <a:ea typeface="Bricolage Grotesque ExtraBold" pitchFamily="34" charset="-122"/>
                 <a:cs typeface="Bricolage Grotesque ExtraBold" pitchFamily="34" charset="-120"/>
               </a:rPr>
-              <a:t> khóa</a:t>
+              <a:t> khi</a:t>
+            </a:r>
+            <a:r>
+              <a:rPr lang="en-US" sz="4200" dirty="0" spc="8" kern="0">
+                <a:solidFill>
+                  <a:srgbClr val="F3EEE3"/>
+                </a:solidFill>
+                <a:latin typeface="Bricolage Grotesque ExtraBold" pitchFamily="34" charset="0"/>
+                <a:ea typeface="Bricolage Grotesque ExtraBold" pitchFamily="34" charset="-122"/>
+                <a:cs typeface="Bricolage Grotesque ExtraBold" pitchFamily="34" charset="-120"/>
+              </a:rPr>
+              <a:t> đầy</a:t>
+            </a:r>
+            <a:r>
+              <a:rPr lang="en-US" sz="4200" dirty="0" spc="-4" kern="0">
+                <a:solidFill>
+                  <a:srgbClr val="F3EEE3"/>
+                </a:solidFill>
+                <a:latin typeface="Bricolage Grotesque ExtraBold" pitchFamily="34" charset="0"/>
+                <a:ea typeface="Bricolage Grotesque ExtraBold" pitchFamily="34" charset="-122"/>
+                <a:cs typeface="Bricolage Grotesque ExtraBold" pitchFamily="34" charset="-120"/>
+              </a:rPr>
+              <a:t> hoặc</a:t>
+            </a:r>
+            <a:r>
+              <a:rPr lang="en-US" sz="4200" dirty="0" spc="-8" kern="0">
+                <a:solidFill>
+                  <a:srgbClr val="F3EEE3"/>
+                </a:solidFill>
+                <a:latin typeface="Bricolage Grotesque ExtraBold" pitchFamily="34" charset="0"/>
+                <a:ea typeface="Bricolage Grotesque ExtraBold" pitchFamily="34" charset="-122"/>
+                <a:cs typeface="Bricolage Grotesque ExtraBold" pitchFamily="34" charset="-120"/>
+              </a:rPr>
+              <a:t> trống</a:t>
             </a:r>
             <a:endParaRPr lang="en-US" sz="4200" dirty="0"/>
           </a:p>
@@ -7053,7 +7086,7 @@
               <a:buNone/>
             </a:pPr>
             <a:r>
-              <a:rPr lang="en-US" sz="6900" dirty="0" spc="-9" kern="0">
+              <a:rPr lang="en-US" sz="6900" dirty="0" spc="-1" kern="0">
                 <a:solidFill>
                   <a:srgbClr val="F3EEE3"/>
                 </a:solidFill>
@@ -7061,10 +7094,10 @@
                 <a:ea typeface="Bricolage Grotesque ExtraBold" pitchFamily="34" charset="-122"/>
                 <a:cs typeface="Bricolage Grotesque ExtraBold" pitchFamily="34" charset="-120"/>
               </a:rPr>
-              <a:t>Khóa</a:t>
-            </a:r>
-            <a:r>
-              <a:rPr lang="en-US" sz="6900" dirty="0" spc="1" kern="0">
+              <a:t>Hàng</a:t>
+            </a:r>
+            <a:r>
+              <a:rPr lang="en-US" sz="6900" dirty="0" spc="-3" kern="0">
                 <a:solidFill>
                   <a:srgbClr val="F3EEE3"/>
                 </a:solidFill>
@@ -7072,18 +7105,7 @@
                 <a:ea typeface="Bricolage Grotesque ExtraBold" pitchFamily="34" charset="-122"/>
                 <a:cs typeface="Bricolage Grotesque ExtraBold" pitchFamily="34" charset="-120"/>
               </a:rPr>
-              <a:t> bị</a:t>
-            </a:r>
-            <a:r>
-              <a:rPr lang="en-US" sz="6900" dirty="0" spc="-42" kern="0">
-                <a:solidFill>
-                  <a:srgbClr val="F3EEE3"/>
-                </a:solidFill>
-                <a:latin typeface="Bricolage Grotesque ExtraBold" pitchFamily="34" charset="0"/>
-                <a:ea typeface="Bricolage Grotesque ExtraBold" pitchFamily="34" charset="-122"/>
-                <a:cs typeface="Bricolage Grotesque ExtraBold" pitchFamily="34" charset="-120"/>
-              </a:rPr>
-              <a:t> giữ,</a:t>
+              <a:t> đầy,</a:t>
             </a:r>
             <a:endParaRPr lang="en-US" sz="6900" dirty="0"/>
           </a:p>
@@ -7156,7 +7178,7 @@
               <a:buNone/>
             </a:pPr>
             <a:r>
-              <a:rPr lang="en-US" sz="3000" b="1" dirty="0" spc="-5" kern="0">
+              <a:rPr lang="en-US" sz="3000" b="1" dirty="0" spc="-1" kern="0">
                 <a:solidFill>
                   <a:srgbClr val="FFB454"/>
                 </a:solidFill>
@@ -7164,10 +7186,10 @@
                 <a:ea typeface="Be Vietnam Pro" pitchFamily="34" charset="-122"/>
                 <a:cs typeface="Be Vietnam Pro" pitchFamily="34" charset="-120"/>
               </a:rPr>
-              <a:t>Thuật</a:t>
-            </a:r>
-            <a:r>
-              <a:rPr lang="en-US" sz="3000" b="1" dirty="0" spc="-6" kern="0">
+              <a:t>Chặn:</a:t>
+            </a:r>
+            <a:r>
+              <a:rPr lang="en-US" sz="3000" b="1" dirty="0" spc="13" kern="0">
                 <a:solidFill>
                   <a:srgbClr val="FFB454"/>
                 </a:solidFill>
@@ -7175,10 +7197,10 @@
                 <a:ea typeface="Be Vietnam Pro" pitchFamily="34" charset="-122"/>
                 <a:cs typeface="Be Vietnam Pro" pitchFamily="34" charset="-120"/>
               </a:rPr>
-              <a:t> toán</a:t>
-            </a:r>
-            <a:r>
-              <a:rPr lang="en-US" sz="3000" b="1" dirty="0" spc="-3" kern="0">
+              <a:t> đợi</a:t>
+            </a:r>
+            <a:r>
+              <a:rPr lang="en-US" sz="3000" b="1" dirty="0" spc="0" kern="0">
                 <a:solidFill>
                   <a:srgbClr val="FFB454"/>
                 </a:solidFill>
@@ -7186,10 +7208,10 @@
                 <a:ea typeface="Be Vietnam Pro" pitchFamily="34" charset="-122"/>
                 <a:cs typeface="Be Vietnam Pro" pitchFamily="34" charset="-120"/>
               </a:rPr>
-              <a:t> chặn</a:t>
-            </a:r>
-            <a:r>
-              <a:rPr lang="en-US" sz="3000" b="1" dirty="0" spc="-2" kern="0">
+              <a:t> khi</a:t>
+            </a:r>
+            <a:r>
+              <a:rPr lang="en-US" sz="3000" b="1" dirty="0" spc="13" kern="0">
                 <a:solidFill>
                   <a:srgbClr val="FFB454"/>
                 </a:solidFill>
@@ -7197,10 +7219,10 @@
                 <a:ea typeface="Be Vietnam Pro" pitchFamily="34" charset="-122"/>
                 <a:cs typeface="Be Vietnam Pro" pitchFamily="34" charset="-120"/>
               </a:rPr>
-              <a:t> dùng</a:t>
-            </a:r>
-            <a:r>
-              <a:rPr lang="en-US" sz="3000" b="1" dirty="0" spc="-8" kern="0">
+              <a:t> chưa</a:t>
+            </a:r>
+            <a:r>
+              <a:rPr lang="en-US" sz="3000" b="1" dirty="0" spc="-1" kern="0">
                 <a:solidFill>
                   <a:srgbClr val="FFB454"/>
                 </a:solidFill>
@@ -7208,7 +7230,18 @@
                 <a:ea typeface="Be Vietnam Pro" pitchFamily="34" charset="-122"/>
                 <a:cs typeface="Be Vietnam Pro" pitchFamily="34" charset="-120"/>
               </a:rPr>
-              <a:t> khóa</a:t>
+              <a:t> làm</a:t>
+            </a:r>
+            <a:r>
+              <a:rPr lang="en-US" sz="3000" b="1" dirty="0" spc="13" kern="0">
+                <a:solidFill>
+                  <a:srgbClr val="FFB454"/>
+                </a:solidFill>
+                <a:latin typeface="Be Vietnam Pro" pitchFamily="34" charset="0"/>
+                <a:ea typeface="Be Vietnam Pro" pitchFamily="34" charset="-122"/>
+                <a:cs typeface="Be Vietnam Pro" pitchFamily="34" charset="-120"/>
+              </a:rPr>
+              <a:t> được</a:t>
             </a:r>
             <a:endParaRPr lang="en-US" sz="3000" dirty="0"/>
           </a:p>
@@ -7242,7 +7275,7 @@
               <a:buNone/>
             </a:pPr>
             <a:r>
-              <a:rPr lang="en-US" sz="2550" dirty="0" spc="-6" kern="0">
+              <a:rPr lang="en-US" sz="2550" dirty="0" spc="3" kern="0">
                 <a:solidFill>
                   <a:srgbClr val="C4C8D6"/>
                 </a:solidFill>
@@ -7250,7 +7283,18 @@
                 <a:ea typeface="Be Vietnam Pro" pitchFamily="34" charset="-122"/>
                 <a:cs typeface="Be Vietnam Pro" pitchFamily="34" charset="-120"/>
               </a:rPr>
-              <a:t>LinkedBlockingQueue</a:t>
+              <a:t>put</a:t>
+            </a:r>
+            <a:r>
+              <a:rPr lang="en-US" sz="2550" dirty="0" spc="12" kern="0">
+                <a:solidFill>
+                  <a:srgbClr val="C4C8D6"/>
+                </a:solidFill>
+                <a:latin typeface="Be Vietnam Pro" pitchFamily="34" charset="0"/>
+                <a:ea typeface="Be Vietnam Pro" pitchFamily="34" charset="-122"/>
+                <a:cs typeface="Be Vietnam Pro" pitchFamily="34" charset="-120"/>
+              </a:rPr>
+              <a:t> đợi</a:t>
             </a:r>
             <a:r>
               <a:rPr lang="en-US" sz="2550" dirty="0" spc="0" kern="0">
@@ -7261,7 +7305,40 @@
                 <a:ea typeface="Be Vietnam Pro" pitchFamily="34" charset="-122"/>
                 <a:cs typeface="Be Vietnam Pro" pitchFamily="34" charset="-120"/>
               </a:rPr>
-              <a:t> có</a:t>
+              <a:t> khi hàng</a:t>
+            </a:r>
+            <a:r>
+              <a:rPr lang="en-US" sz="2550" dirty="0" spc="3" kern="0">
+                <a:solidFill>
+                  <a:srgbClr val="C4C8D6"/>
+                </a:solidFill>
+                <a:latin typeface="Be Vietnam Pro" pitchFamily="34" charset="0"/>
+                <a:ea typeface="Be Vietnam Pro" pitchFamily="34" charset="-122"/>
+                <a:cs typeface="Be Vietnam Pro" pitchFamily="34" charset="-120"/>
+              </a:rPr>
+              <a:t> đầy;</a:t>
+            </a:r>
+            <a:r>
+              <a:rPr lang="en-US" sz="2550" dirty="0" spc="-32" kern="0">
+                <a:solidFill>
+                  <a:srgbClr val="C4C8D6"/>
+                </a:solidFill>
+                <a:latin typeface="Be Vietnam Pro" pitchFamily="34" charset="0"/>
+                <a:ea typeface="Be Vietnam Pro" pitchFamily="34" charset="-122"/>
+                <a:cs typeface="Be Vietnam Pro" pitchFamily="34" charset="-120"/>
+              </a:rPr>
+              <a:t> take</a:t>
+            </a:r>
+            <a:r>
+              <a:rPr lang="en-US" sz="2550" dirty="0" spc="13" kern="0">
+                <a:solidFill>
+                  <a:srgbClr val="C4C8D6"/>
+                </a:solidFill>
+                <a:latin typeface="Be Vietnam Pro" pitchFamily="34" charset="0"/>
+                <a:ea typeface="Be Vietnam Pro" pitchFamily="34" charset="-122"/>
+                <a:cs typeface="Be Vietnam Pro" pitchFamily="34" charset="-120"/>
+              </a:rPr>
+              <a:t> đợi</a:t>
             </a:r>
             <a:r>
               <a:rPr lang="en-US" sz="2550" dirty="0" spc="-1" kern="0">
@@ -7272,10 +7349,10 @@
                 <a:ea typeface="Be Vietnam Pro" pitchFamily="34" charset="-122"/>
                 <a:cs typeface="Be Vietnam Pro" pitchFamily="34" charset="-120"/>
               </a:rPr>
-              <a:t> hai khóa:</a:t>
-            </a:r>
-            <a:r>
-              <a:rPr lang="en-US" sz="2550" dirty="0" spc="0" kern="0">
+              <a:t> khi</a:t>
+            </a:r>
+            <a:r>
+              <a:rPr lang="en-US" sz="2550" dirty="0" spc="1" kern="0">
                 <a:solidFill>
                   <a:srgbClr val="C4C8D6"/>
                 </a:solidFill>
@@ -7283,10 +7360,10 @@
                 <a:ea typeface="Be Vietnam Pro" pitchFamily="34" charset="-122"/>
                 <a:cs typeface="Be Vietnam Pro" pitchFamily="34" charset="-120"/>
               </a:rPr>
-              <a:t> cần</a:t>
-            </a:r>
-            <a:r>
-              <a:rPr lang="en-US" sz="2550" dirty="0" spc="-3" kern="0">
+              <a:t> hàng</a:t>
+            </a:r>
+            <a:r>
+              <a:rPr lang="en-US" sz="2550" dirty="0" spc="-14" kern="0">
                 <a:solidFill>
                   <a:srgbClr val="C4C8D6"/>
                 </a:solidFill>
@@ -7294,73 +7371,7 @@
                 <a:ea typeface="Be Vietnam Pro" pitchFamily="34" charset="-122"/>
                 <a:cs typeface="Be Vietnam Pro" pitchFamily="34" charset="-120"/>
               </a:rPr>
-              <a:t> khóa</a:t>
-            </a:r>
-            <a:r>
-              <a:rPr lang="en-US" sz="2550" dirty="0" spc="11" kern="0">
-                <a:solidFill>
-                  <a:srgbClr val="C4C8D6"/>
-                </a:solidFill>
-                <a:latin typeface="Be Vietnam Pro" pitchFamily="34" charset="0"/>
-                <a:ea typeface="Be Vietnam Pro" pitchFamily="34" charset="-122"/>
-                <a:cs typeface="Be Vietnam Pro" pitchFamily="34" charset="-120"/>
-              </a:rPr>
-              <a:t> đang</a:t>
-            </a:r>
-            <a:r>
-              <a:rPr lang="en-US" sz="2550" dirty="0" spc="0" kern="0">
-                <a:solidFill>
-                  <a:srgbClr val="C4C8D6"/>
-                </a:solidFill>
-                <a:latin typeface="Be Vietnam Pro" pitchFamily="34" charset="0"/>
-                <a:ea typeface="Be Vietnam Pro" pitchFamily="34" charset="-122"/>
-                <a:cs typeface="Be Vietnam Pro" pitchFamily="34" charset="-120"/>
-              </a:rPr>
-              <a:t> bị</a:t>
-            </a:r>
-            <a:r>
-              <a:rPr lang="en-US" sz="2550" dirty="0" spc="-1" kern="0">
-                <a:solidFill>
-                  <a:srgbClr val="C4C8D6"/>
-                </a:solidFill>
-                <a:latin typeface="Be Vietnam Pro" pitchFamily="34" charset="0"/>
-                <a:ea typeface="Be Vietnam Pro" pitchFamily="34" charset="-122"/>
-                <a:cs typeface="Be Vietnam Pro" pitchFamily="34" charset="-120"/>
-              </a:rPr>
-              <a:t> giữ</a:t>
-            </a:r>
-            <a:r>
-              <a:rPr lang="en-US" sz="2550" dirty="0" spc="1" kern="0">
-                <a:solidFill>
-                  <a:srgbClr val="C4C8D6"/>
-                </a:solidFill>
-                <a:latin typeface="Be Vietnam Pro" pitchFamily="34" charset="0"/>
-                <a:ea typeface="Be Vietnam Pro" pitchFamily="34" charset="-122"/>
-                <a:cs typeface="Be Vietnam Pro" pitchFamily="34" charset="-120"/>
-              </a:rPr>
-              <a:t> thì</a:t>
-            </a:r>
-            <a:r>
-              <a:rPr lang="en-US" sz="2550" dirty="0" spc="0" kern="0">
-                <a:solidFill>
-                  <a:srgbClr val="C4C8D6"/>
-                </a:solidFill>
-                <a:latin typeface="Be Vietnam Pro" pitchFamily="34" charset="0"/>
-                <a:ea typeface="Be Vietnam Pro" pitchFamily="34" charset="-122"/>
-                <a:cs typeface="Be Vietnam Pro" pitchFamily="34" charset="-120"/>
-              </a:rPr>
-              <a:t> phải</a:t>
-            </a:r>
-            <a:r>
-              <a:rPr lang="en-US" sz="2550" dirty="0" spc="11" kern="0">
-                <a:solidFill>
-                  <a:srgbClr val="C4C8D6"/>
-                </a:solidFill>
-                <a:latin typeface="Be Vietnam Pro" pitchFamily="34" charset="0"/>
-                <a:ea typeface="Be Vietnam Pro" pitchFamily="34" charset="-122"/>
-                <a:cs typeface="Be Vietnam Pro" pitchFamily="34" charset="-120"/>
-              </a:rPr>
-              <a:t> đợi.</a:t>
+              <a:t> trống.</a:t>
             </a:r>
             <a:endParaRPr lang="en-US" sz="2550" dirty="0"/>
           </a:p>
@@ -7395,7 +7406,7 @@
               <a:buNone/>
             </a:pPr>
             <a:r>
-              <a:rPr lang="en-US" sz="2100" b="1" dirty="0" spc="-2" kern="0">
+              <a:rPr lang="en-US" sz="2100" b="1" dirty="0" spc="0" kern="0">
                 <a:solidFill>
                   <a:srgbClr val="14161C"/>
                 </a:solidFill>
@@ -7403,10 +7414,10 @@
                 <a:ea typeface="Be Vietnam Pro" pitchFamily="34" charset="-122"/>
                 <a:cs typeface="Be Vietnam Pro" pitchFamily="34" charset="-120"/>
               </a:rPr>
-              <a:t>Dùng</a:t>
-            </a:r>
-            <a:r>
-              <a:rPr lang="en-US" sz="2100" b="1" dirty="0" spc="-8" kern="0">
+              <a:t>đầy</a:t>
+            </a:r>
+            <a:r>
+              <a:rPr lang="en-US" sz="2100" b="1" dirty="0" spc="-4" kern="0">
                 <a:solidFill>
                   <a:srgbClr val="14161C"/>
                 </a:solidFill>
@@ -7414,7 +7425,18 @@
                 <a:ea typeface="Be Vietnam Pro" pitchFamily="34" charset="-122"/>
                 <a:cs typeface="Be Vietnam Pro" pitchFamily="34" charset="-120"/>
               </a:rPr>
-              <a:t> khóa</a:t>
+              <a:t> hoặc</a:t>
+            </a:r>
+            <a:r>
+              <a:rPr lang="en-US" sz="2100" b="1" dirty="0" spc="-14" kern="0">
+                <a:solidFill>
+                  <a:srgbClr val="14161C"/>
+                </a:solidFill>
+                <a:latin typeface="Be Vietnam Pro" pitchFamily="34" charset="0"/>
+                <a:ea typeface="Be Vietnam Pro" pitchFamily="34" charset="-122"/>
+                <a:cs typeface="Be Vietnam Pro" pitchFamily="34" charset="-120"/>
+              </a:rPr>
+              <a:t> trống</a:t>
             </a:r>
             <a:endParaRPr lang="en-US" sz="2100" dirty="0"/>
           </a:p>
@@ -7449,7 +7471,7 @@
               <a:buNone/>
             </a:pPr>
             <a:r>
-              <a:rPr lang="en-US" sz="2100" b="1" dirty="0" spc="-2" kern="0">
+              <a:rPr lang="en-US" sz="2100" b="1" dirty="0" spc="-24" kern="0">
                 <a:solidFill>
                   <a:srgbClr val="14161C"/>
                 </a:solidFill>
@@ -7457,10 +7479,10 @@
                 <a:ea typeface="Be Vietnam Pro" pitchFamily="34" charset="-122"/>
                 <a:cs typeface="Be Vietnam Pro" pitchFamily="34" charset="-120"/>
               </a:rPr>
-              <a:t>put</a:t>
-            </a:r>
-            <a:r>
-              <a:rPr lang="en-US" sz="2100" b="1" dirty="0" spc="-19" kern="0">
+              <a:t>offer,</a:t>
+            </a:r>
+            <a:r>
+              <a:rPr lang="en-US" sz="2100" b="1" dirty="0" spc="-4" kern="0">
                 <a:solidFill>
                   <a:srgbClr val="14161C"/>
                 </a:solidFill>
@@ -7468,10 +7490,10 @@
                 <a:ea typeface="Be Vietnam Pro" pitchFamily="34" charset="-122"/>
                 <a:cs typeface="Be Vietnam Pro" pitchFamily="34" charset="-120"/>
               </a:rPr>
-              <a:t> và</a:t>
-            </a:r>
-            <a:r>
-              <a:rPr lang="en-US" sz="2100" b="1" dirty="0" spc="-23" kern="0">
+              <a:t> poll</a:t>
+            </a:r>
+            <a:r>
+              <a:rPr lang="en-US" sz="2100" b="1" dirty="0" spc="-8" kern="0">
                 <a:solidFill>
                   <a:srgbClr val="14161C"/>
                 </a:solidFill>
@@ -7479,10 +7501,10 @@
                 <a:ea typeface="Be Vietnam Pro" pitchFamily="34" charset="-122"/>
                 <a:cs typeface="Be Vietnam Pro" pitchFamily="34" charset="-120"/>
               </a:rPr>
-              <a:t> take</a:t>
-            </a:r>
-            <a:r>
-              <a:rPr lang="en-US" sz="2100" b="1" dirty="0" spc="0" kern="0">
+              <a:t> không</a:t>
+            </a:r>
+            <a:r>
+              <a:rPr lang="en-US" sz="2100" b="1" dirty="0" spc="5" kern="0">
                 <a:solidFill>
                   <a:srgbClr val="14161C"/>
                 </a:solidFill>
@@ -7490,18 +7512,7 @@
                 <a:ea typeface="Be Vietnam Pro" pitchFamily="34" charset="-122"/>
                 <a:cs typeface="Be Vietnam Pro" pitchFamily="34" charset="-120"/>
               </a:rPr>
-              <a:t> chặn</a:t>
-            </a:r>
-            <a:r>
-              <a:rPr lang="en-US" sz="2100" b="1" dirty="0" spc="-5" kern="0">
-                <a:solidFill>
-                  <a:srgbClr val="14161C"/>
-                </a:solidFill>
-                <a:latin typeface="Be Vietnam Pro" pitchFamily="34" charset="0"/>
-                <a:ea typeface="Be Vietnam Pro" pitchFamily="34" charset="-122"/>
-                <a:cs typeface="Be Vietnam Pro" pitchFamily="34" charset="-120"/>
-              </a:rPr>
-              <a:t> luồng</a:t>
+              <a:t> đợi</a:t>
             </a:r>
             <a:endParaRPr lang="en-US" sz="2100" dirty="0"/>
           </a:p>
@@ -7607,15 +7618,15 @@
               <a:buNone/>
             </a:pPr>
             <a:r>
-              <a:rPr lang="en-US" sz="2550" dirty="0" spc="-3" kern="0">
-                <a:solidFill>
-                  <a:srgbClr val="F3EEE3"/>
-                </a:solidFill>
-                <a:latin typeface="Be Vietnam Pro" pitchFamily="34" charset="0"/>
-                <a:ea typeface="Be Vietnam Pro" pitchFamily="34" charset="-122"/>
-                <a:cs typeface="Be Vietnam Pro" pitchFamily="34" charset="-120"/>
-              </a:rPr>
-              <a:t>Khi</a:t>
+              <a:rPr lang="en-US" sz="2550" dirty="0" spc="0" kern="0">
+                <a:solidFill>
+                  <a:srgbClr val="F3EEE3"/>
+                </a:solidFill>
+                <a:latin typeface="Be Vietnam Pro" pitchFamily="34" charset="0"/>
+                <a:ea typeface="Be Vietnam Pro" pitchFamily="34" charset="-122"/>
+                <a:cs typeface="Be Vietnam Pro" pitchFamily="34" charset="-120"/>
+              </a:rPr>
+              <a:t>Chặn</a:t>
             </a:r>
             <a:r>
               <a:rPr lang="en-US" sz="2550" dirty="0" spc="1" kern="0">
@@ -7626,7 +7637,51 @@
                 <a:ea typeface="Be Vietnam Pro" pitchFamily="34" charset="-122"/>
                 <a:cs typeface="Be Vietnam Pro" pitchFamily="34" charset="-120"/>
               </a:rPr>
-              <a:t> A</a:t>
+              <a:t> là</a:t>
+            </a:r>
+            <a:r>
+              <a:rPr lang="en-US" sz="2550" dirty="0" spc="12" kern="0">
+                <a:solidFill>
+                  <a:srgbClr val="F3EEE3"/>
+                </a:solidFill>
+                <a:latin typeface="Be Vietnam Pro" pitchFamily="34" charset="0"/>
+                <a:ea typeface="Be Vietnam Pro" pitchFamily="34" charset="-122"/>
+                <a:cs typeface="Be Vietnam Pro" pitchFamily="34" charset="-120"/>
+              </a:rPr>
+              <a:t> đợi</a:t>
+            </a:r>
+            <a:r>
+              <a:rPr lang="en-US" sz="2550" dirty="0" spc="-1" kern="0">
+                <a:solidFill>
+                  <a:srgbClr val="F3EEE3"/>
+                </a:solidFill>
+                <a:latin typeface="Be Vietnam Pro" pitchFamily="34" charset="0"/>
+                <a:ea typeface="Be Vietnam Pro" pitchFamily="34" charset="-122"/>
+                <a:cs typeface="Be Vietnam Pro" pitchFamily="34" charset="-120"/>
+              </a:rPr>
+              <a:t> vì</a:t>
+            </a:r>
+            <a:r>
+              <a:rPr lang="en-US" sz="2550" dirty="0" spc="1" kern="0">
+                <a:solidFill>
+                  <a:srgbClr val="F3EEE3"/>
+                </a:solidFill>
+                <a:latin typeface="Be Vietnam Pro" pitchFamily="34" charset="0"/>
+                <a:ea typeface="Be Vietnam Pro" pitchFamily="34" charset="-122"/>
+                <a:cs typeface="Be Vietnam Pro" pitchFamily="34" charset="-120"/>
+              </a:rPr>
+              <a:t> hàng</a:t>
+            </a:r>
+            <a:r>
+              <a:rPr lang="en-US" sz="2550" dirty="0" spc="3" kern="0">
+                <a:solidFill>
+                  <a:srgbClr val="F3EEE3"/>
+                </a:solidFill>
+                <a:latin typeface="Be Vietnam Pro" pitchFamily="34" charset="0"/>
+                <a:ea typeface="Be Vietnam Pro" pitchFamily="34" charset="-122"/>
+                <a:cs typeface="Be Vietnam Pro" pitchFamily="34" charset="-120"/>
+              </a:rPr>
+              <a:t> đầy</a:t>
             </a:r>
             <a:r>
               <a:rPr lang="en-US" sz="2550" dirty="0" spc="-2" kern="0">
@@ -7637,18 +7692,18 @@
                 <a:ea typeface="Be Vietnam Pro" pitchFamily="34" charset="-122"/>
                 <a:cs typeface="Be Vietnam Pro" pitchFamily="34" charset="-120"/>
               </a:rPr>
-              <a:t> giữ khóa,</a:t>
-            </a:r>
-            <a:r>
-              <a:rPr lang="en-US" sz="2550" dirty="0" spc="2" kern="0">
-                <a:solidFill>
-                  <a:srgbClr val="F3EEE3"/>
-                </a:solidFill>
-                <a:latin typeface="Be Vietnam Pro" pitchFamily="34" charset="0"/>
-                <a:ea typeface="Be Vietnam Pro" pitchFamily="34" charset="-122"/>
-                <a:cs typeface="Be Vietnam Pro" pitchFamily="34" charset="-120"/>
-              </a:rPr>
-              <a:t> B</a:t>
+              <a:t> hoặc</a:t>
+            </a:r>
+            <a:r>
+              <a:rPr lang="en-US" sz="2550" dirty="0" spc="-15" kern="0">
+                <a:solidFill>
+                  <a:srgbClr val="F3EEE3"/>
+                </a:solidFill>
+                <a:latin typeface="Be Vietnam Pro" pitchFamily="34" charset="0"/>
+                <a:ea typeface="Be Vietnam Pro" pitchFamily="34" charset="-122"/>
+                <a:cs typeface="Be Vietnam Pro" pitchFamily="34" charset="-120"/>
+              </a:rPr>
+              <a:t> trống,</a:t>
             </a:r>
             <a:r>
               <a:rPr lang="en-US" sz="2550" dirty="0" spc="1" kern="0">
@@ -7659,40 +7714,18 @@
                 <a:ea typeface="Be Vietnam Pro" pitchFamily="34" charset="-122"/>
                 <a:cs typeface="Be Vietnam Pro" pitchFamily="34" charset="-120"/>
               </a:rPr>
-              <a:t> chỉ</a:t>
-            </a:r>
-            <a:r>
-              <a:rPr lang="en-US" sz="2550" dirty="0" spc="-5" kern="0">
-                <a:solidFill>
-                  <a:srgbClr val="F3EEE3"/>
-                </a:solidFill>
-                <a:latin typeface="Be Vietnam Pro" pitchFamily="34" charset="0"/>
-                <a:ea typeface="Be Vietnam Pro" pitchFamily="34" charset="-122"/>
-                <a:cs typeface="Be Vietnam Pro" pitchFamily="34" charset="-120"/>
-              </a:rPr>
-              <a:t> biết</a:t>
-            </a:r>
-            <a:r>
-              <a:rPr lang="en-US" sz="2550" dirty="0" spc="13" kern="0">
-                <a:solidFill>
-                  <a:srgbClr val="F3EEE3"/>
-                </a:solidFill>
-                <a:latin typeface="Be Vietnam Pro" pitchFamily="34" charset="0"/>
-                <a:ea typeface="Be Vietnam Pro" pitchFamily="34" charset="-122"/>
-                <a:cs typeface="Be Vietnam Pro" pitchFamily="34" charset="-120"/>
-              </a:rPr>
-              <a:t> đợi</a:t>
-            </a:r>
-            <a:r>
-              <a:rPr lang="en-US" sz="2550" dirty="0" spc="-13" kern="0">
-                <a:solidFill>
-                  <a:srgbClr val="F3EEE3"/>
-                </a:solidFill>
-                <a:latin typeface="Be Vietnam Pro" pitchFamily="34" charset="0"/>
-                <a:ea typeface="Be Vietnam Pro" pitchFamily="34" charset="-122"/>
-                <a:cs typeface="Be Vietnam Pro" pitchFamily="34" charset="-120"/>
-              </a:rPr>
-              <a:t> tới</a:t>
+              <a:t> không</a:t>
+            </a:r>
+            <a:r>
+              <a:rPr lang="en-US" sz="2550" dirty="0" spc="-1" kern="0">
+                <a:solidFill>
+                  <a:srgbClr val="F3EEE3"/>
+                </a:solidFill>
+                <a:latin typeface="Be Vietnam Pro" pitchFamily="34" charset="0"/>
+                <a:ea typeface="Be Vietnam Pro" pitchFamily="34" charset="-122"/>
+                <a:cs typeface="Be Vietnam Pro" pitchFamily="34" charset="-120"/>
+              </a:rPr>
+              <a:t> phải</a:t>
             </a:r>
             <a:r>
               <a:rPr lang="en-US" sz="2550" dirty="0" spc="0" kern="0">
@@ -7703,7 +7736,7 @@
                 <a:ea typeface="Be Vietnam Pro" pitchFamily="34" charset="-122"/>
                 <a:cs typeface="Be Vietnam Pro" pitchFamily="34" charset="-120"/>
               </a:rPr>
-              <a:t> khi</a:t>
+              <a:t> vì</a:t>
             </a:r>
             <a:r>
               <a:rPr lang="en-US" sz="2550" dirty="0" spc="-2" kern="0">
@@ -7714,29 +7747,7 @@
                 <a:ea typeface="Be Vietnam Pro" pitchFamily="34" charset="-122"/>
                 <a:cs typeface="Be Vietnam Pro" pitchFamily="34" charset="-120"/>
               </a:rPr>
-              <a:t> khóa</a:t>
-            </a:r>
-            <a:r>
-              <a:rPr lang="en-US" sz="2550" dirty="0" spc="6" kern="0">
-                <a:solidFill>
-                  <a:srgbClr val="F3EEE3"/>
-                </a:solidFill>
-                <a:latin typeface="Be Vietnam Pro" pitchFamily="34" charset="0"/>
-                <a:ea typeface="Be Vietnam Pro" pitchFamily="34" charset="-122"/>
-                <a:cs typeface="Be Vietnam Pro" pitchFamily="34" charset="-120"/>
-              </a:rPr>
-              <a:t> được</a:t>
-            </a:r>
-            <a:r>
-              <a:rPr lang="en-US" sz="2550" dirty="0" spc="1" kern="0">
-                <a:solidFill>
-                  <a:srgbClr val="F3EEE3"/>
-                </a:solidFill>
-                <a:latin typeface="Be Vietnam Pro" pitchFamily="34" charset="0"/>
-                <a:ea typeface="Be Vietnam Pro" pitchFamily="34" charset="-122"/>
-                <a:cs typeface="Be Vietnam Pro" pitchFamily="34" charset="-120"/>
-              </a:rPr>
-              <a:t> nhả.</a:t>
+              <a:t> khóa.</a:t>
             </a:r>
             <a:endParaRPr lang="en-US" sz="2550" dirty="0"/>
           </a:p>
@@ -8159,6 +8170,17 @@
               <a:buNone/>
             </a:pPr>
             <a:r>
+              <a:rPr lang="en-US" sz="1950" dirty="0" spc="-2" kern="0">
+                <a:solidFill>
+                  <a:srgbClr val="F3EEE3"/>
+                </a:solidFill>
+                <a:latin typeface="Be Vietnam Pro" pitchFamily="34" charset="0"/>
+                <a:ea typeface="Be Vietnam Pro" pitchFamily="34" charset="-122"/>
+                <a:cs typeface="Be Vietnam Pro" pitchFamily="34" charset="-120"/>
+              </a:rPr>
+              <a:t>put: lấp</a:t>
+            </a:r>
+            <a:r>
               <a:rPr lang="en-US" sz="1950" dirty="0" spc="2" kern="0">
                 <a:solidFill>
                   <a:srgbClr val="F3EEE3"/>
@@ -8167,51 +8189,18 @@
                 <a:ea typeface="Be Vietnam Pro" pitchFamily="34" charset="-122"/>
                 <a:cs typeface="Be Vietnam Pro" pitchFamily="34" charset="-120"/>
               </a:rPr>
-              <a:t>Giữ</a:t>
-            </a:r>
-            <a:r>
-              <a:rPr lang="en-US" sz="1950" dirty="0" spc="-10" kern="0">
-                <a:solidFill>
-                  <a:srgbClr val="F3EEE3"/>
-                </a:solidFill>
-                <a:latin typeface="Be Vietnam Pro" pitchFamily="34" charset="0"/>
-                <a:ea typeface="Be Vietnam Pro" pitchFamily="34" charset="-122"/>
-                <a:cs typeface="Be Vietnam Pro" pitchFamily="34" charset="-120"/>
-              </a:rPr>
-              <a:t> putLock,</a:t>
-            </a:r>
-            <a:r>
-              <a:rPr lang="en-US" sz="1950" dirty="0" spc="-1" kern="0">
-                <a:solidFill>
-                  <a:srgbClr val="F3EEE3"/>
-                </a:solidFill>
-                <a:latin typeface="Be Vietnam Pro" pitchFamily="34" charset="0"/>
-                <a:ea typeface="Be Vietnam Pro" pitchFamily="34" charset="-122"/>
-                <a:cs typeface="Be Vietnam Pro" pitchFamily="34" charset="-120"/>
-              </a:rPr>
-              <a:t> thêm</a:t>
-            </a:r>
-            <a:r>
-              <a:rPr lang="en-US" sz="1950" dirty="0" spc="0" kern="0">
-                <a:solidFill>
-                  <a:srgbClr val="F3EEE3"/>
-                </a:solidFill>
-                <a:latin typeface="Be Vietnam Pro" pitchFamily="34" charset="0"/>
-                <a:ea typeface="Be Vietnam Pro" pitchFamily="34" charset="-122"/>
-                <a:cs typeface="Be Vietnam Pro" pitchFamily="34" charset="-120"/>
-              </a:rPr>
-              <a:t> phần</a:t>
-            </a:r>
-            <a:r>
-              <a:rPr lang="en-US" sz="1950" dirty="0" spc="-1" kern="0">
-                <a:solidFill>
-                  <a:srgbClr val="F3EEE3"/>
-                </a:solidFill>
-                <a:latin typeface="Be Vietnam Pro" pitchFamily="34" charset="0"/>
-                <a:ea typeface="Be Vietnam Pro" pitchFamily="34" charset="-122"/>
-                <a:cs typeface="Be Vietnam Pro" pitchFamily="34" charset="-120"/>
-              </a:rPr>
-              <a:t> tử</a:t>
+              <a:t> đầy</a:t>
+            </a:r>
+            <a:r>
+              <a:rPr lang="en-US" sz="1950" dirty="0" spc="1" kern="0">
+                <a:solidFill>
+                  <a:srgbClr val="F3EEE3"/>
+                </a:solidFill>
+                <a:latin typeface="Be Vietnam Pro" pitchFamily="34" charset="0"/>
+                <a:ea typeface="Be Vietnam Pro" pitchFamily="34" charset="-122"/>
+                <a:cs typeface="Be Vietnam Pro" pitchFamily="34" charset="-120"/>
+              </a:rPr>
+              <a:t> hàng</a:t>
             </a:r>
             <a:endParaRPr lang="en-US" sz="1950" dirty="0"/>
           </a:p>
@@ -8267,26 +8256,37 @@
               <a:buNone/>
             </a:pPr>
             <a:r>
-              <a:rPr lang="en-US" sz="1950" dirty="0" spc="4" kern="0">
-                <a:solidFill>
-                  <a:srgbClr val="F3EEE3"/>
-                </a:solidFill>
-                <a:latin typeface="Be Vietnam Pro" pitchFamily="34" charset="0"/>
-                <a:ea typeface="Be Vietnam Pro" pitchFamily="34" charset="-122"/>
-                <a:cs typeface="Be Vietnam Pro" pitchFamily="34" charset="-120"/>
-              </a:rPr>
-              <a:t>Xin</a:t>
-            </a:r>
-            <a:r>
-              <a:rPr lang="en-US" sz="1950" dirty="0" spc="-12" kern="0">
-                <a:solidFill>
-                  <a:srgbClr val="F3EEE3"/>
-                </a:solidFill>
-                <a:latin typeface="Be Vietnam Pro" pitchFamily="34" charset="0"/>
-                <a:ea typeface="Be Vietnam Pro" pitchFamily="34" charset="-122"/>
-                <a:cs typeface="Be Vietnam Pro" pitchFamily="34" charset="-120"/>
-              </a:rPr>
-              <a:t> putLock</a:t>
+              <a:rPr lang="en-US" sz="1950" dirty="0" spc="-2" kern="0">
+                <a:solidFill>
+                  <a:srgbClr val="F3EEE3"/>
+                </a:solidFill>
+                <a:latin typeface="Be Vietnam Pro" pitchFamily="34" charset="0"/>
+                <a:ea typeface="Be Vietnam Pro" pitchFamily="34" charset="-122"/>
+                <a:cs typeface="Be Vietnam Pro" pitchFamily="34" charset="-120"/>
+              </a:rPr>
+              <a:t>put:</a:t>
+            </a:r>
+            <a:r>
+              <a:rPr lang="en-US" sz="1950" dirty="0" spc="0" kern="0">
+                <a:solidFill>
+                  <a:srgbClr val="F3EEE3"/>
+                </a:solidFill>
+                <a:latin typeface="Be Vietnam Pro" pitchFamily="34" charset="0"/>
+                <a:ea typeface="Be Vietnam Pro" pitchFamily="34" charset="-122"/>
+                <a:cs typeface="Be Vietnam Pro" pitchFamily="34" charset="-120"/>
+              </a:rPr>
+              <a:t> thêm</a:t>
+            </a:r>
+            <a:r>
+              <a:rPr lang="en-US" sz="1950" dirty="0" spc="-1" kern="0">
+                <a:solidFill>
+                  <a:srgbClr val="F3EEE3"/>
+                </a:solidFill>
+                <a:latin typeface="Be Vietnam Pro" pitchFamily="34" charset="0"/>
+                <a:ea typeface="Be Vietnam Pro" pitchFamily="34" charset="-122"/>
+                <a:cs typeface="Be Vietnam Pro" pitchFamily="34" charset="-120"/>
+              </a:rPr>
+              <a:t> tiếp</a:t>
             </a:r>
             <a:endParaRPr lang="en-US" sz="1950" dirty="0"/>
           </a:p>
@@ -8342,7 +8342,7 @@
               <a:buNone/>
             </a:pPr>
             <a:r>
-              <a:rPr lang="en-US" sz="1950" b="1" dirty="0" spc="6" kern="0">
+              <a:rPr lang="en-US" sz="1950" b="1" dirty="0" spc="-2" kern="0">
                 <a:solidFill>
                   <a:srgbClr val="FFB454"/>
                 </a:solidFill>
@@ -8350,10 +8350,10 @@
                 <a:ea typeface="Be Vietnam Pro" pitchFamily="34" charset="-122"/>
                 <a:cs typeface="Be Vietnam Pro" pitchFamily="34" charset="-120"/>
               </a:rPr>
-              <a:t>Đợi</a:t>
-            </a:r>
-            <a:r>
-              <a:rPr lang="en-US" sz="1950" b="1" dirty="0" spc="1" kern="0">
+              <a:t>Hàng</a:t>
+            </a:r>
+            <a:r>
+              <a:rPr lang="en-US" sz="1950" b="1" dirty="0" spc="-1" kern="0">
                 <a:solidFill>
                   <a:srgbClr val="FFB454"/>
                 </a:solidFill>
@@ -8361,10 +8361,10 @@
                 <a:ea typeface="Be Vietnam Pro" pitchFamily="34" charset="-122"/>
                 <a:cs typeface="Be Vietnam Pro" pitchFamily="34" charset="-120"/>
               </a:rPr>
-              <a:t> tới khi</a:t>
-            </a:r>
-            <a:r>
-              <a:rPr lang="en-US" sz="1950" b="1" dirty="0" spc="-7" kern="0">
+              <a:t> đầy:</a:t>
+            </a:r>
+            <a:r>
+              <a:rPr lang="en-US" sz="1950" b="1" dirty="0" spc="7" kern="0">
                 <a:solidFill>
                   <a:srgbClr val="FFB454"/>
                 </a:solidFill>
@@ -8372,10 +8372,10 @@
                 <a:ea typeface="Be Vietnam Pro" pitchFamily="34" charset="-122"/>
                 <a:cs typeface="Be Vietnam Pro" pitchFamily="34" charset="-120"/>
               </a:rPr>
-              <a:t> putLock</a:t>
-            </a:r>
-            <a:r>
-              <a:rPr lang="en-US" sz="1950" b="1" dirty="0" spc="7" kern="0">
+              <a:t> đợi</a:t>
+            </a:r>
+            <a:r>
+              <a:rPr lang="en-US" sz="1950" b="1" dirty="0" spc="0" kern="0">
                 <a:solidFill>
                   <a:srgbClr val="FFB454"/>
                 </a:solidFill>
@@ -8383,10 +8383,10 @@
                 <a:ea typeface="Be Vietnam Pro" pitchFamily="34" charset="-122"/>
                 <a:cs typeface="Be Vietnam Pro" pitchFamily="34" charset="-120"/>
               </a:rPr>
-              <a:t> được</a:t>
-            </a:r>
-            <a:r>
-              <a:rPr lang="en-US" sz="1950" b="1" dirty="0" spc="-1" kern="0">
+              <a:t> tới</a:t>
+            </a:r>
+            <a:r>
+              <a:rPr lang="en-US" sz="1950" b="1" dirty="0" spc="2" kern="0">
                 <a:solidFill>
                   <a:srgbClr val="FFB454"/>
                 </a:solidFill>
@@ -8394,7 +8394,29 @@
                 <a:ea typeface="Be Vietnam Pro" pitchFamily="34" charset="-122"/>
                 <a:cs typeface="Be Vietnam Pro" pitchFamily="34" charset="-120"/>
               </a:rPr>
-              <a:t> nhả</a:t>
+              <a:t> khi</a:t>
+            </a:r>
+            <a:r>
+              <a:rPr lang="en-US" sz="1950" b="1" dirty="0" spc="-6" kern="0">
+                <a:solidFill>
+                  <a:srgbClr val="FFB454"/>
+                </a:solidFill>
+                <a:latin typeface="Be Vietnam Pro" pitchFamily="34" charset="0"/>
+                <a:ea typeface="Be Vietnam Pro" pitchFamily="34" charset="-122"/>
+                <a:cs typeface="Be Vietnam Pro" pitchFamily="34" charset="-120"/>
+              </a:rPr>
+              <a:t> có</a:t>
+            </a:r>
+            <a:r>
+              <a:rPr lang="en-US" sz="1950" b="1" dirty="0" spc="-4" kern="0">
+                <a:solidFill>
+                  <a:srgbClr val="FFB454"/>
+                </a:solidFill>
+                <a:latin typeface="Be Vietnam Pro" pitchFamily="34" charset="0"/>
+                <a:ea typeface="Be Vietnam Pro" pitchFamily="34" charset="-122"/>
+                <a:cs typeface="Be Vietnam Pro" pitchFamily="34" charset="-120"/>
+              </a:rPr>
+              <a:t> chỗ</a:t>
             </a:r>
             <a:endParaRPr lang="en-US" sz="1950" dirty="0"/>
           </a:p>
@@ -8454,6 +8476,28 @@
               <a:buNone/>
             </a:pPr>
             <a:r>
+              <a:rPr lang="en-US" sz="2100" b="1" dirty="0" spc="10" kern="0">
+                <a:solidFill>
+                  <a:srgbClr val="14161C"/>
+                </a:solidFill>
+                <a:latin typeface="Be Vietnam Pro" pitchFamily="34" charset="0"/>
+                <a:ea typeface="Be Vietnam Pro" pitchFamily="34" charset="-122"/>
+                <a:cs typeface="Be Vietnam Pro" pitchFamily="34" charset="-120"/>
+              </a:rPr>
+              <a:t>đã</a:t>
+            </a:r>
+            <a:r>
+              <a:rPr lang="en-US" sz="2100" b="1" dirty="0" spc="1" kern="0">
+                <a:solidFill>
+                  <a:srgbClr val="14161C"/>
+                </a:solidFill>
+                <a:latin typeface="Be Vietnam Pro" pitchFamily="34" charset="0"/>
+                <a:ea typeface="Be Vietnam Pro" pitchFamily="34" charset="-122"/>
+                <a:cs typeface="Be Vietnam Pro" pitchFamily="34" charset="-120"/>
+              </a:rPr>
+              <a:t> lấp</a:t>
+            </a:r>
+            <a:r>
               <a:rPr lang="en-US" sz="2100" b="1" dirty="0" spc="-2" kern="0">
                 <a:solidFill>
                   <a:srgbClr val="14161C"/>
@@ -8462,18 +8506,7 @@
                 <a:ea typeface="Be Vietnam Pro" pitchFamily="34" charset="-122"/>
                 <a:cs typeface="Be Vietnam Pro" pitchFamily="34" charset="-120"/>
               </a:rPr>
-              <a:t>giữ</a:t>
-            </a:r>
-            <a:r>
-              <a:rPr lang="en-US" sz="2100" b="1" dirty="0" spc="-9" kern="0">
-                <a:solidFill>
-                  <a:srgbClr val="14161C"/>
-                </a:solidFill>
-                <a:latin typeface="Be Vietnam Pro" pitchFamily="34" charset="0"/>
-                <a:ea typeface="Be Vietnam Pro" pitchFamily="34" charset="-122"/>
-                <a:cs typeface="Be Vietnam Pro" pitchFamily="34" charset="-120"/>
-              </a:rPr>
-              <a:t> khóa</a:t>
+              <a:t> đầy</a:t>
             </a:r>
             <a:endParaRPr lang="en-US" sz="2100" dirty="0"/>
           </a:p>
@@ -12265,18 +12298,40 @@
                 <a:ea typeface="Be Vietnam Pro" pitchFamily="34" charset="-122"/>
                 <a:cs typeface="Be Vietnam Pro" pitchFamily="34" charset="-120"/>
               </a:rPr>
-              <a:t> khóa</a:t>
-            </a:r>
-            <a:r>
-              <a:rPr lang="en-US" sz="2400" b="1" dirty="0" spc="11" kern="0">
-                <a:solidFill>
-                  <a:srgbClr val="F3EEE3"/>
-                </a:solidFill>
-                <a:latin typeface="Be Vietnam Pro" pitchFamily="34" charset="0"/>
-                <a:ea typeface="Be Vietnam Pro" pitchFamily="34" charset="-122"/>
-                <a:cs typeface="Be Vietnam Pro" pitchFamily="34" charset="-120"/>
-              </a:rPr>
-              <a:t> được</a:t>
+              <a:t> có</a:t>
+            </a:r>
+            <a:r>
+              <a:rPr lang="en-US" sz="2400" b="1" dirty="0" spc="-3" kern="0">
+                <a:solidFill>
+                  <a:srgbClr val="F3EEE3"/>
+                </a:solidFill>
+                <a:latin typeface="Be Vietnam Pro" pitchFamily="34" charset="0"/>
+                <a:ea typeface="Be Vietnam Pro" pitchFamily="34" charset="-122"/>
+                <a:cs typeface="Be Vietnam Pro" pitchFamily="34" charset="-120"/>
+              </a:rPr>
+              <a:t> chỗ</a:t>
+            </a:r>
+            <a:r>
+              <a:rPr lang="en-US" sz="2400" b="1" dirty="0" spc="-2" kern="0">
+                <a:solidFill>
+                  <a:srgbClr val="F3EEE3"/>
+                </a:solidFill>
+                <a:latin typeface="Be Vietnam Pro" pitchFamily="34" charset="0"/>
+                <a:ea typeface="Be Vietnam Pro" pitchFamily="34" charset="-122"/>
+                <a:cs typeface="Be Vietnam Pro" pitchFamily="34" charset="-120"/>
+              </a:rPr>
+              <a:t> hoặc</a:t>
+            </a:r>
+            <a:r>
+              <a:rPr lang="en-US" sz="2400" b="1" dirty="0" spc="-3" kern="0">
+                <a:solidFill>
+                  <a:srgbClr val="F3EEE3"/>
+                </a:solidFill>
+                <a:latin typeface="Be Vietnam Pro" pitchFamily="34" charset="0"/>
+                <a:ea typeface="Be Vietnam Pro" pitchFamily="34" charset="-122"/>
+                <a:cs typeface="Be Vietnam Pro" pitchFamily="34" charset="-120"/>
+              </a:rPr>
+              <a:t> có</a:t>
             </a:r>
             <a:r>
               <a:rPr lang="en-US" sz="2400" b="1" dirty="0" spc="-4" kern="0">
@@ -12287,7 +12342,18 @@
                 <a:ea typeface="Be Vietnam Pro" pitchFamily="34" charset="-122"/>
                 <a:cs typeface="Be Vietnam Pro" pitchFamily="34" charset="-120"/>
               </a:rPr>
-              <a:t> nhả</a:t>
+              <a:t> phần</a:t>
+            </a:r>
+            <a:r>
+              <a:rPr lang="en-US" sz="2400" b="1" dirty="0" spc="3" kern="0">
+                <a:solidFill>
+                  <a:srgbClr val="F3EEE3"/>
+                </a:solidFill>
+                <a:latin typeface="Be Vietnam Pro" pitchFamily="34" charset="0"/>
+                <a:ea typeface="Be Vietnam Pro" pitchFamily="34" charset="-122"/>
+                <a:cs typeface="Be Vietnam Pro" pitchFamily="34" charset="-120"/>
+              </a:rPr>
+              <a:t> tử</a:t>
             </a:r>
             <a:endParaRPr lang="en-US" sz="2400" dirty="0"/>
           </a:p>
@@ -17258,26 +17324,37 @@
               <a:buNone/>
             </a:pPr>
             <a:r>
-              <a:rPr lang="en-US" sz="2100" b="1" dirty="0" spc="-2" kern="0">
-                <a:solidFill>
-                  <a:srgbClr val="F3EEE3"/>
-                </a:solidFill>
-                <a:latin typeface="Be Vietnam Pro" pitchFamily="34" charset="0"/>
-                <a:ea typeface="Be Vietnam Pro" pitchFamily="34" charset="-122"/>
-                <a:cs typeface="Be Vietnam Pro" pitchFamily="34" charset="-120"/>
-              </a:rPr>
-              <a:t>dùng</a:t>
-            </a:r>
-            <a:r>
-              <a:rPr lang="en-US" sz="2100" b="1" dirty="0" spc="-8" kern="0">
-                <a:solidFill>
-                  <a:srgbClr val="F3EEE3"/>
-                </a:solidFill>
-                <a:latin typeface="Be Vietnam Pro" pitchFamily="34" charset="0"/>
-                <a:ea typeface="Be Vietnam Pro" pitchFamily="34" charset="-122"/>
-                <a:cs typeface="Be Vietnam Pro" pitchFamily="34" charset="-120"/>
-              </a:rPr>
-              <a:t> khóa</a:t>
+              <a:rPr lang="en-US" sz="2100" b="1" dirty="0" spc="9" kern="0">
+                <a:solidFill>
+                  <a:srgbClr val="F3EEE3"/>
+                </a:solidFill>
+                <a:latin typeface="Be Vietnam Pro" pitchFamily="34" charset="0"/>
+                <a:ea typeface="Be Vietnam Pro" pitchFamily="34" charset="-122"/>
+                <a:cs typeface="Be Vietnam Pro" pitchFamily="34" charset="-120"/>
+              </a:rPr>
+              <a:t>đợi</a:t>
+            </a:r>
+            <a:r>
+              <a:rPr lang="en-US" sz="2100" b="1" dirty="0" spc="-3" kern="0">
+                <a:solidFill>
+                  <a:srgbClr val="F3EEE3"/>
+                </a:solidFill>
+                <a:latin typeface="Be Vietnam Pro" pitchFamily="34" charset="0"/>
+                <a:ea typeface="Be Vietnam Pro" pitchFamily="34" charset="-122"/>
+                <a:cs typeface="Be Vietnam Pro" pitchFamily="34" charset="-120"/>
+              </a:rPr>
+              <a:t> khi</a:t>
+            </a:r>
+            <a:r>
+              <a:rPr lang="en-US" sz="2100" b="1" dirty="0" spc="-9" kern="0">
+                <a:solidFill>
+                  <a:srgbClr val="F3EEE3"/>
+                </a:solidFill>
+                <a:latin typeface="Be Vietnam Pro" pitchFamily="34" charset="0"/>
+                <a:ea typeface="Be Vietnam Pro" pitchFamily="34" charset="-122"/>
+                <a:cs typeface="Be Vietnam Pro" pitchFamily="34" charset="-120"/>
+              </a:rPr>
+              <a:t> đầy/trống</a:t>
             </a:r>
             <a:endParaRPr lang="en-US" sz="2100" dirty="0"/>
           </a:p>

</xml_diff>

<commit_message>
Lesson sd-10-010: state that wait-free means every operation finishes in its own finite steps regardless of other threads, with the figure, metadata and deck
Co-Authored-By: Claude Sonnet 5.5 <noreply@anthropic.com>
Claude-Session: https://claude.ai/code/session_01Y9NYFwg4CcDYEWi1zr53gi
</commit_message>
<xml_diff>
--- a/system-design-101/vi/lessons/sd-10-010/slides/sd-10-010.pptx
+++ b/system-design-101/vi/lessons/sd-10-010/slides/sd-10-010.pptx
@@ -14133,17 +14133,17 @@
           <a:ln/>
         </p:spPr>
         <p:txBody>
-          <a:bodyPr wrap="square" lIns="0" tIns="8557" rIns="0" bIns="-8557" rtlCol="0" anchor="t"/>
+          <a:bodyPr wrap="square" lIns="0" tIns="6271" rIns="0" bIns="-6271" rtlCol="0" anchor="t"/>
           <a:lstStyle/>
           <a:p>
             <a:pPr algn="ctr" indent="0" marL="0">
               <a:lnSpc>
-                <a:spcPts val="3038"/>
+                <a:spcPts val="2228"/>
               </a:lnSpc>
               <a:buNone/>
             </a:pPr>
             <a:r>
-              <a:rPr lang="en-US" sz="2250" dirty="0" spc="-2" kern="0">
+              <a:rPr lang="en-US" sz="1650" dirty="0" spc="-2" kern="0">
                 <a:solidFill>
                   <a:srgbClr val="6B6A66"/>
                 </a:solidFill>
@@ -14151,10 +14151,10 @@
                 <a:ea typeface="Be Vietnam Pro" pitchFamily="34" charset="-122"/>
                 <a:cs typeface="Be Vietnam Pro" pitchFamily="34" charset="-120"/>
               </a:rPr>
-              <a:t>Mọi</a:t>
-            </a:r>
-            <a:r>
-              <a:rPr lang="en-US" sz="2250" dirty="0" spc="1" kern="0">
+              <a:t>Mỗi</a:t>
+            </a:r>
+            <a:r>
+              <a:rPr lang="en-US" sz="1650" dirty="0" spc="1" kern="0">
                 <a:solidFill>
                   <a:srgbClr val="6B6A66"/>
                 </a:solidFill>
@@ -14162,10 +14162,109 @@
                 <a:ea typeface="Be Vietnam Pro" pitchFamily="34" charset="-122"/>
                 <a:cs typeface="Be Vietnam Pro" pitchFamily="34" charset="-120"/>
               </a:rPr>
+              <a:t> thao</a:t>
+            </a:r>
+            <a:r>
+              <a:rPr lang="en-US" sz="1650" dirty="0" spc="-6" kern="0">
+                <a:solidFill>
+                  <a:srgbClr val="6B6A66"/>
+                </a:solidFill>
+                <a:latin typeface="Be Vietnam Pro" pitchFamily="34" charset="0"/>
+                <a:ea typeface="Be Vietnam Pro" pitchFamily="34" charset="-122"/>
+                <a:cs typeface="Be Vietnam Pro" pitchFamily="34" charset="-120"/>
+              </a:rPr>
+              <a:t> tác</a:t>
+            </a:r>
+            <a:r>
+              <a:rPr lang="en-US" sz="1650" dirty="0" spc="-11" kern="0">
+                <a:solidFill>
+                  <a:srgbClr val="6B6A66"/>
+                </a:solidFill>
+                <a:latin typeface="Be Vietnam Pro" pitchFamily="34" charset="0"/>
+                <a:ea typeface="Be Vietnam Pro" pitchFamily="34" charset="-122"/>
+                <a:cs typeface="Be Vietnam Pro" pitchFamily="34" charset="-120"/>
+              </a:rPr>
+              <a:t> xong trong</a:t>
+            </a:r>
+            <a:r>
+              <a:rPr lang="en-US" sz="1650" dirty="0" spc="-4" kern="0">
+                <a:solidFill>
+                  <a:srgbClr val="6B6A66"/>
+                </a:solidFill>
+                <a:latin typeface="Be Vietnam Pro" pitchFamily="34" charset="0"/>
+                <a:ea typeface="Be Vietnam Pro" pitchFamily="34" charset="-122"/>
+                <a:cs typeface="Be Vietnam Pro" pitchFamily="34" charset="-120"/>
+              </a:rPr>
+              <a:t> số</a:t>
+            </a:r>
+            <a:r>
+              <a:rPr lang="en-US" sz="1650" dirty="0" spc="6" kern="0">
+                <a:solidFill>
+                  <a:srgbClr val="6B6A66"/>
+                </a:solidFill>
+                <a:latin typeface="Be Vietnam Pro" pitchFamily="34" charset="0"/>
+                <a:ea typeface="Be Vietnam Pro" pitchFamily="34" charset="-122"/>
+                <a:cs typeface="Be Vietnam Pro" pitchFamily="34" charset="-120"/>
+              </a:rPr>
+              <a:t> bước</a:t>
+            </a:r>
+            <a:r>
+              <a:rPr lang="en-US" sz="1650" dirty="0" spc="12" kern="0">
+                <a:solidFill>
+                  <a:srgbClr val="6B6A66"/>
+                </a:solidFill>
+                <a:latin typeface="Be Vietnam Pro" pitchFamily="34" charset="0"/>
+                <a:ea typeface="Be Vietnam Pro" pitchFamily="34" charset="-122"/>
+                <a:cs typeface="Be Vietnam Pro" pitchFamily="34" charset="-120"/>
+              </a:rPr>
+              <a:t> hữu</a:t>
+            </a:r>
+            <a:r>
+              <a:rPr lang="en-US" sz="1650" dirty="0" spc="1" kern="0">
+                <a:solidFill>
+                  <a:srgbClr val="6B6A66"/>
+                </a:solidFill>
+                <a:latin typeface="Be Vietnam Pro" pitchFamily="34" charset="0"/>
+                <a:ea typeface="Be Vietnam Pro" pitchFamily="34" charset="-122"/>
+                <a:cs typeface="Be Vietnam Pro" pitchFamily="34" charset="-120"/>
+              </a:rPr>
+              <a:t> hạn,</a:t>
+            </a:r>
+            <a:r>
+              <a:rPr lang="en-US" sz="1650" dirty="0" spc="-7" kern="0">
+                <a:solidFill>
+                  <a:srgbClr val="6B6A66"/>
+                </a:solidFill>
+                <a:latin typeface="Be Vietnam Pro" pitchFamily="34" charset="0"/>
+                <a:ea typeface="Be Vietnam Pro" pitchFamily="34" charset="-122"/>
+                <a:cs typeface="Be Vietnam Pro" pitchFamily="34" charset="-120"/>
+              </a:rPr>
+              <a:t> bất</a:t>
+            </a:r>
+            <a:r>
+              <a:rPr lang="en-US" sz="1650" dirty="0" spc="-21" kern="0">
+                <a:solidFill>
+                  <a:srgbClr val="6B6A66"/>
+                </a:solidFill>
+                <a:latin typeface="Be Vietnam Pro" pitchFamily="34" charset="0"/>
+                <a:ea typeface="Be Vietnam Pro" pitchFamily="34" charset="-122"/>
+                <a:cs typeface="Be Vietnam Pro" pitchFamily="34" charset="-120"/>
+              </a:rPr>
+              <a:t> kể</a:t>
+            </a:r>
+            <a:r>
+              <a:rPr lang="en-US" sz="1650" dirty="0" spc="-1" kern="0">
+                <a:solidFill>
+                  <a:srgbClr val="6B6A66"/>
+                </a:solidFill>
+                <a:latin typeface="Be Vietnam Pro" pitchFamily="34" charset="0"/>
+                <a:ea typeface="Be Vietnam Pro" pitchFamily="34" charset="-122"/>
+                <a:cs typeface="Be Vietnam Pro" pitchFamily="34" charset="-120"/>
+              </a:rPr>
               <a:t> luồng</a:t>
             </a:r>
             <a:r>
-              <a:rPr lang="en-US" sz="2250" dirty="0" spc="-4" kern="0">
+              <a:rPr lang="en-US" sz="1650" dirty="0" spc="1" kern="0">
                 <a:solidFill>
                   <a:srgbClr val="6B6A66"/>
                 </a:solidFill>
@@ -14173,86 +14272,9 @@
                 <a:ea typeface="Be Vietnam Pro" pitchFamily="34" charset="-122"/>
                 <a:cs typeface="Be Vietnam Pro" pitchFamily="34" charset="-120"/>
               </a:rPr>
-              <a:t> hoàn</a:t>
-            </a:r>
-            <a:r>
-              <a:rPr lang="en-US" sz="2250" dirty="0" spc="0" kern="0">
-                <a:solidFill>
-                  <a:srgbClr val="6B6A66"/>
-                </a:solidFill>
-                <a:latin typeface="Be Vietnam Pro" pitchFamily="34" charset="0"/>
-                <a:ea typeface="Be Vietnam Pro" pitchFamily="34" charset="-122"/>
-                <a:cs typeface="Be Vietnam Pro" pitchFamily="34" charset="-120"/>
-              </a:rPr>
-              <a:t> thành</a:t>
-            </a:r>
-            <a:r>
-              <a:rPr lang="en-US" sz="2250" dirty="0" spc="-3" kern="0">
-                <a:solidFill>
-                  <a:srgbClr val="6B6A66"/>
-                </a:solidFill>
-                <a:latin typeface="Be Vietnam Pro" pitchFamily="34" charset="0"/>
-                <a:ea typeface="Be Vietnam Pro" pitchFamily="34" charset="-122"/>
-                <a:cs typeface="Be Vietnam Pro" pitchFamily="34" charset="-120"/>
-              </a:rPr>
-              <a:t> việc</a:t>
-            </a:r>
-            <a:r>
-              <a:rPr lang="en-US" sz="2250" dirty="0" spc="-16" kern="0">
-                <a:solidFill>
-                  <a:srgbClr val="6B6A66"/>
-                </a:solidFill>
-                <a:latin typeface="Be Vietnam Pro" pitchFamily="34" charset="0"/>
-                <a:ea typeface="Be Vietnam Pro" pitchFamily="34" charset="-122"/>
-                <a:cs typeface="Be Vietnam Pro" pitchFamily="34" charset="-120"/>
-              </a:rPr>
-              <a:t> trong</a:t>
-            </a:r>
-            <a:r>
-              <a:rPr lang="en-US" sz="2250" dirty="0" spc="-3" kern="0">
-                <a:solidFill>
-                  <a:srgbClr val="6B6A66"/>
-                </a:solidFill>
-                <a:latin typeface="Be Vietnam Pro" pitchFamily="34" charset="0"/>
-                <a:ea typeface="Be Vietnam Pro" pitchFamily="34" charset="-122"/>
-                <a:cs typeface="Be Vietnam Pro" pitchFamily="34" charset="-120"/>
-              </a:rPr>
-              <a:t> số</a:t>
-            </a:r>
-            <a:r>
-              <a:rPr lang="en-US" sz="2250" dirty="0" spc="10" kern="0">
-                <a:solidFill>
-                  <a:srgbClr val="6B6A66"/>
-                </a:solidFill>
-                <a:latin typeface="Be Vietnam Pro" pitchFamily="34" charset="0"/>
-                <a:ea typeface="Be Vietnam Pro" pitchFamily="34" charset="-122"/>
-                <a:cs typeface="Be Vietnam Pro" pitchFamily="34" charset="-120"/>
-              </a:rPr>
-              <a:t> bước</a:t>
-            </a:r>
-            <a:r>
-              <a:rPr lang="en-US" sz="2250" dirty="0" spc="18" kern="0">
-                <a:solidFill>
-                  <a:srgbClr val="6B6A66"/>
-                </a:solidFill>
-                <a:latin typeface="Be Vietnam Pro" pitchFamily="34" charset="0"/>
-                <a:ea typeface="Be Vietnam Pro" pitchFamily="34" charset="-122"/>
-                <a:cs typeface="Be Vietnam Pro" pitchFamily="34" charset="-120"/>
-              </a:rPr>
-              <a:t> hữu</a:t>
-            </a:r>
-            <a:r>
-              <a:rPr lang="en-US" sz="2250" dirty="0" spc="1" kern="0">
-                <a:solidFill>
-                  <a:srgbClr val="6B6A66"/>
-                </a:solidFill>
-                <a:latin typeface="Be Vietnam Pro" pitchFamily="34" charset="0"/>
-                <a:ea typeface="Be Vietnam Pro" pitchFamily="34" charset="-122"/>
-                <a:cs typeface="Be Vietnam Pro" pitchFamily="34" charset="-120"/>
-              </a:rPr>
-              <a:t> hạn.</a:t>
-            </a:r>
-            <a:endParaRPr lang="en-US" sz="2250" dirty="0"/>
+              <a:t> khác.</a:t>
+            </a:r>
+            <a:endParaRPr lang="en-US" sz="1650" dirty="0"/>
           </a:p>
         </p:txBody>
       </p:sp>

</xml_diff>